<commit_message>
feat: fill slides 11-12 with real investigation results
Pretrain NaN=8.69% (EPIC-array dominated), fine-tune NaN=60.11%
(pure 450k-array, 29,548 CpGs 100% missing). Real β percentiles,
out-of-range counts, duplicate warnings added.

Co-Authored-By: Claude Sonnet 4.6 <noreply@anthropic.com>
</commit_message>
<xml_diff>
--- a/methyl/NaN_Handling_MethylLlama.pptx
+++ b/methyl/NaN_Handling_MethylLlama.pptx
@@ -4642,10 +4642,10 @@
                   <a:srgbClr val="3A4A5C"/>
                 </a:solidFill>
               </a:rPr>
-              <a:t>valid_pct = (non-input ∩ non-NaN) / vocab = 42%
-input = 50% of valid  →  non-input non-NaN = 50% of valid
-→  valid (non-NaN) = 84% of 49,156
-→  NaN rate ≈ 16%  (~41k of 49k probes measured per sample)</a:t>
+              <a:t>Investigation confirms:  NaN rate = 8.69% in pretrain
+→  ~44.9k of 49k probes measured per sample on average
+valid_pct ≈ 42% = (0.5 × 44.9k) / 49.15k  ✓ consistent
+Pretrain corpus is dominated by EPIC-array samples</a:t>
             </a:r>
           </a:p>
         </p:txBody>
@@ -5178,7 +5178,7 @@
                   <a:srgbClr val="1A263A"/>
                 </a:solidFill>
               </a:rPr>
-              <a:t>Data Investigation Results — NaN Statistics  [PENDING]</a:t>
+              <a:t>Data Investigation Results — NaN Statistics</a:t>
             </a:r>
           </a:p>
         </p:txBody>
@@ -5212,7 +5212,7 @@
                   <a:srgbClr val="788FA8"/>
                 </a:solidFill>
               </a:rPr>
-              <a:t>Run on cluster:  sbatch scripts/utils/investigate_data.sh</a:t>
+              <a:t>Job 44584079  ·  Mon Apr 27 10:20–10:28 IDT 2026</a:t>
             </a:r>
           </a:p>
         </p:txBody>
@@ -5262,48 +5262,14 @@
       </p:sp>
       <p:sp>
         <p:nvSpPr>
-          <p:cNvPr id="6" name="TextBox 5"/>
-          <p:cNvSpPr txBox="1"/>
-          <p:nvPr/>
-        </p:nvSpPr>
-        <p:spPr>
-          <a:xfrm>
-            <a:off x="365760" y="1298448"/>
-            <a:ext cx="11475720" cy="384048"/>
-          </a:xfrm>
-          <a:prstGeom prst="rect">
-            <a:avLst/>
-          </a:prstGeom>
-          <a:noFill/>
-        </p:spPr>
-        <p:txBody>
-          <a:bodyPr wrap="square">
-            <a:spAutoFit/>
-          </a:bodyPr>
-          <a:lstStyle/>
-          <a:p>
-            <a:pPr algn="l"/>
-            <a:r>
-              <a:rPr sz="1600" b="1" i="0">
-                <a:solidFill>
-                  <a:srgbClr val="D47E00"/>
-                </a:solidFill>
-              </a:rPr>
-              <a:t>⏳  Results pending — run investigation script and fill in below</a:t>
-            </a:r>
-          </a:p>
-        </p:txBody>
-      </p:sp>
-      <p:sp>
-        <p:nvSpPr>
-          <p:cNvPr id="7" name="Rectangle 6"/>
+          <p:cNvPr id="6" name="Rectangle 5"/>
           <p:cNvSpPr/>
           <p:nvPr/>
         </p:nvSpPr>
         <p:spPr>
           <a:xfrm>
-            <a:off x="365760" y="1828800"/>
-            <a:ext cx="5577840" cy="4160520"/>
+            <a:off x="365760" y="1261872"/>
+            <a:ext cx="5577840" cy="4937760"/>
           </a:xfrm>
           <a:prstGeom prst="rect">
             <a:avLst/>
@@ -5341,34 +5307,68 @@
       </p:sp>
       <p:sp>
         <p:nvSpPr>
+          <p:cNvPr id="7" name="TextBox 6"/>
+          <p:cNvSpPr txBox="1"/>
+          <p:nvPr/>
+        </p:nvSpPr>
+        <p:spPr>
+          <a:xfrm>
+            <a:off x="502920" y="1353312"/>
+            <a:ext cx="5486400" cy="274320"/>
+          </a:xfrm>
+          <a:prstGeom prst="rect">
+            <a:avLst/>
+          </a:prstGeom>
+          <a:noFill/>
+        </p:spPr>
+        <p:txBody>
+          <a:bodyPr wrap="square">
+            <a:spAutoFit/>
+          </a:bodyPr>
+          <a:lstStyle/>
+          <a:p>
+            <a:pPr algn="l"/>
+            <a:r>
+              <a:rPr sz="1100" b="1" i="0">
+                <a:solidFill>
+                  <a:srgbClr val="007AC2"/>
+                </a:solidFill>
+              </a:rPr>
+              <a:t>PRETRAIN  (169,120 × 49,156)</a:t>
+            </a:r>
+          </a:p>
+        </p:txBody>
+      </p:sp>
+      <p:sp>
+        <p:nvSpPr>
           <p:cNvPr id="8" name="TextBox 7"/>
           <p:cNvSpPr txBox="1"/>
           <p:nvPr/>
         </p:nvSpPr>
         <p:spPr>
           <a:xfrm>
-            <a:off x="502920" y="1901952"/>
-            <a:ext cx="5486400" cy="274320"/>
-          </a:xfrm>
-          <a:prstGeom prst="rect">
-            <a:avLst/>
-          </a:prstGeom>
-          <a:noFill/>
-        </p:spPr>
-        <p:txBody>
-          <a:bodyPr wrap="square">
-            <a:spAutoFit/>
-          </a:bodyPr>
-          <a:lstStyle/>
-          <a:p>
-            <a:pPr algn="l"/>
-            <a:r>
-              <a:rPr sz="1100" b="1" i="0">
-                <a:solidFill>
-                  <a:srgbClr val="007AC2"/>
-                </a:solidFill>
-              </a:rPr>
-              <a:t>PRETRAIN  (169k × 49k)</a:t>
+            <a:off x="548640" y="1755648"/>
+            <a:ext cx="2926080" cy="347472"/>
+          </a:xfrm>
+          <a:prstGeom prst="rect">
+            <a:avLst/>
+          </a:prstGeom>
+          <a:noFill/>
+        </p:spPr>
+        <p:txBody>
+          <a:bodyPr wrap="square">
+            <a:spAutoFit/>
+          </a:bodyPr>
+          <a:lstStyle/>
+          <a:p>
+            <a:pPr algn="l"/>
+            <a:r>
+              <a:rPr sz="1300" b="0" i="0">
+                <a:solidFill>
+                  <a:srgbClr val="788FA8"/>
+                </a:solidFill>
+              </a:rPr>
+              <a:t>Total β-values</a:t>
             </a:r>
           </a:p>
         </p:txBody>
@@ -5381,28 +5381,28 @@
         </p:nvSpPr>
         <p:spPr>
           <a:xfrm>
-            <a:off x="548640" y="2331720"/>
-            <a:ext cx="5120640" cy="365760"/>
-          </a:xfrm>
-          <a:prstGeom prst="rect">
-            <a:avLst/>
-          </a:prstGeom>
-          <a:noFill/>
-        </p:spPr>
-        <p:txBody>
-          <a:bodyPr wrap="square">
-            <a:spAutoFit/>
-          </a:bodyPr>
-          <a:lstStyle/>
-          <a:p>
-            <a:pPr algn="l"/>
-            <a:r>
-              <a:rPr sz="1400" b="0" i="0">
+            <a:off x="3520440" y="1755648"/>
+            <a:ext cx="2286000" cy="347472"/>
+          </a:xfrm>
+          <a:prstGeom prst="rect">
+            <a:avLst/>
+          </a:prstGeom>
+          <a:noFill/>
+        </p:spPr>
+        <p:txBody>
+          <a:bodyPr wrap="square">
+            <a:spAutoFit/>
+          </a:bodyPr>
+          <a:lstStyle/>
+          <a:p>
+            <a:pPr algn="l"/>
+            <a:r>
+              <a:rPr sz="1300" b="1" i="0">
                 <a:solidFill>
                   <a:srgbClr val="3A4A5C"/>
                 </a:solidFill>
               </a:rPr>
-              <a:t>Total NaN count:                [ TBD ]</a:t>
+              <a:t>8,313,262,720</a:t>
             </a:r>
           </a:p>
         </p:txBody>
@@ -5415,28 +5415,28 @@
         </p:nvSpPr>
         <p:spPr>
           <a:xfrm>
-            <a:off x="548640" y="2743200"/>
-            <a:ext cx="5120640" cy="365760"/>
-          </a:xfrm>
-          <a:prstGeom prst="rect">
-            <a:avLst/>
-          </a:prstGeom>
-          <a:noFill/>
-        </p:spPr>
-        <p:txBody>
-          <a:bodyPr wrap="square">
-            <a:spAutoFit/>
-          </a:bodyPr>
-          <a:lstStyle/>
-          <a:p>
-            <a:pPr algn="l"/>
-            <a:r>
-              <a:rPr sz="1400" b="0" i="0">
-                <a:solidFill>
-                  <a:srgbClr val="3A4A5C"/>
-                </a:solidFill>
-              </a:rPr>
-              <a:t>NaN %:                          [ TBD ]</a:t>
+            <a:off x="548640" y="2130552"/>
+            <a:ext cx="2926080" cy="347472"/>
+          </a:xfrm>
+          <a:prstGeom prst="rect">
+            <a:avLst/>
+          </a:prstGeom>
+          <a:noFill/>
+        </p:spPr>
+        <p:txBody>
+          <a:bodyPr wrap="square">
+            <a:spAutoFit/>
+          </a:bodyPr>
+          <a:lstStyle/>
+          <a:p>
+            <a:pPr algn="l"/>
+            <a:r>
+              <a:rPr sz="1300" b="0" i="0">
+                <a:solidFill>
+                  <a:srgbClr val="788FA8"/>
+                </a:solidFill>
+              </a:rPr>
+              <a:t>NaN count</a:t>
             </a:r>
           </a:p>
         </p:txBody>
@@ -5449,28 +5449,28 @@
         </p:nvSpPr>
         <p:spPr>
           <a:xfrm>
-            <a:off x="548640" y="3154680"/>
-            <a:ext cx="5120640" cy="365760"/>
-          </a:xfrm>
-          <a:prstGeom prst="rect">
-            <a:avLst/>
-          </a:prstGeom>
-          <a:noFill/>
-        </p:spPr>
-        <p:txBody>
-          <a:bodyPr wrap="square">
-            <a:spAutoFit/>
-          </a:bodyPr>
-          <a:lstStyle/>
-          <a:p>
-            <a:pPr algn="l"/>
-            <a:r>
-              <a:rPr sz="1400" b="0" i="0">
-                <a:solidFill>
-                  <a:srgbClr val="3A4A5C"/>
-                </a:solidFill>
-              </a:rPr>
-              <a:t>Samples with ≥1% NaN:          [ TBD ]</a:t>
+            <a:off x="3520440" y="2130552"/>
+            <a:ext cx="2286000" cy="347472"/>
+          </a:xfrm>
+          <a:prstGeom prst="rect">
+            <a:avLst/>
+          </a:prstGeom>
+          <a:noFill/>
+        </p:spPr>
+        <p:txBody>
+          <a:bodyPr wrap="square">
+            <a:spAutoFit/>
+          </a:bodyPr>
+          <a:lstStyle/>
+          <a:p>
+            <a:pPr algn="l"/>
+            <a:r>
+              <a:rPr sz="1300" b="1" i="0">
+                <a:solidFill>
+                  <a:srgbClr val="C03030"/>
+                </a:solidFill>
+              </a:rPr>
+              <a:t>722,036,387</a:t>
             </a:r>
           </a:p>
         </p:txBody>
@@ -5483,28 +5483,28 @@
         </p:nvSpPr>
         <p:spPr>
           <a:xfrm>
-            <a:off x="548640" y="3566160"/>
-            <a:ext cx="5120640" cy="365760"/>
-          </a:xfrm>
-          <a:prstGeom prst="rect">
-            <a:avLst/>
-          </a:prstGeom>
-          <a:noFill/>
-        </p:spPr>
-        <p:txBody>
-          <a:bodyPr wrap="square">
-            <a:spAutoFit/>
-          </a:bodyPr>
-          <a:lstStyle/>
-          <a:p>
-            <a:pPr algn="l"/>
-            <a:r>
-              <a:rPr sz="1400" b="0" i="0">
-                <a:solidFill>
-                  <a:srgbClr val="3A4A5C"/>
-                </a:solidFill>
-              </a:rPr>
-              <a:t>Samples with ≥10% NaN:         [ TBD ]</a:t>
+            <a:off x="548640" y="2505456"/>
+            <a:ext cx="2926080" cy="347472"/>
+          </a:xfrm>
+          <a:prstGeom prst="rect">
+            <a:avLst/>
+          </a:prstGeom>
+          <a:noFill/>
+        </p:spPr>
+        <p:txBody>
+          <a:bodyPr wrap="square">
+            <a:spAutoFit/>
+          </a:bodyPr>
+          <a:lstStyle/>
+          <a:p>
+            <a:pPr algn="l"/>
+            <a:r>
+              <a:rPr sz="1300" b="0" i="0">
+                <a:solidFill>
+                  <a:srgbClr val="788FA8"/>
+                </a:solidFill>
+              </a:rPr>
+              <a:t>NaN %</a:t>
             </a:r>
           </a:p>
         </p:txBody>
@@ -5517,28 +5517,28 @@
         </p:nvSpPr>
         <p:spPr>
           <a:xfrm>
-            <a:off x="548640" y="3977639"/>
-            <a:ext cx="5120640" cy="365760"/>
-          </a:xfrm>
-          <a:prstGeom prst="rect">
-            <a:avLst/>
-          </a:prstGeom>
-          <a:noFill/>
-        </p:spPr>
-        <p:txBody>
-          <a:bodyPr wrap="square">
-            <a:spAutoFit/>
-          </a:bodyPr>
-          <a:lstStyle/>
-          <a:p>
-            <a:pPr algn="l"/>
-            <a:r>
-              <a:rPr sz="1400" b="0" i="0">
-                <a:solidFill>
-                  <a:srgbClr val="3A4A5C"/>
-                </a:solidFill>
-              </a:rPr>
-              <a:t>Fully missing samples:          [ TBD ]</a:t>
+            <a:off x="3520440" y="2505456"/>
+            <a:ext cx="2286000" cy="347472"/>
+          </a:xfrm>
+          <a:prstGeom prst="rect">
+            <a:avLst/>
+          </a:prstGeom>
+          <a:noFill/>
+        </p:spPr>
+        <p:txBody>
+          <a:bodyPr wrap="square">
+            <a:spAutoFit/>
+          </a:bodyPr>
+          <a:lstStyle/>
+          <a:p>
+            <a:pPr algn="l"/>
+            <a:r>
+              <a:rPr sz="1300" b="1" i="0">
+                <a:solidFill>
+                  <a:srgbClr val="C03030"/>
+                </a:solidFill>
+              </a:rPr>
+              <a:t>8.69%</a:t>
             </a:r>
           </a:p>
         </p:txBody>
@@ -5551,28 +5551,28 @@
         </p:nvSpPr>
         <p:spPr>
           <a:xfrm>
-            <a:off x="548640" y="4389120"/>
-            <a:ext cx="5120640" cy="365760"/>
-          </a:xfrm>
-          <a:prstGeom prst="rect">
-            <a:avLst/>
-          </a:prstGeom>
-          <a:noFill/>
-        </p:spPr>
-        <p:txBody>
-          <a:bodyPr wrap="square">
-            <a:spAutoFit/>
-          </a:bodyPr>
-          <a:lstStyle/>
-          <a:p>
-            <a:pPr algn="l"/>
-            <a:r>
-              <a:rPr sz="1400" b="0" i="0">
-                <a:solidFill>
-                  <a:srgbClr val="3A4A5C"/>
-                </a:solidFill>
-              </a:rPr>
-              <a:t>CpGs with ≥50% NaN:            [ TBD ]</a:t>
+            <a:off x="548640" y="2880360"/>
+            <a:ext cx="2926080" cy="347472"/>
+          </a:xfrm>
+          <a:prstGeom prst="rect">
+            <a:avLst/>
+          </a:prstGeom>
+          <a:noFill/>
+        </p:spPr>
+        <p:txBody>
+          <a:bodyPr wrap="square">
+            <a:spAutoFit/>
+          </a:bodyPr>
+          <a:lstStyle/>
+          <a:p>
+            <a:pPr algn="l"/>
+            <a:r>
+              <a:rPr sz="1300" b="0" i="0">
+                <a:solidFill>
+                  <a:srgbClr val="788FA8"/>
+                </a:solidFill>
+              </a:rPr>
+              <a:t>Samples with ≥1% NaN</a:t>
             </a:r>
           </a:p>
         </p:txBody>
@@ -5585,42 +5585,518 @@
         </p:nvSpPr>
         <p:spPr>
           <a:xfrm>
-            <a:off x="548640" y="4800600"/>
-            <a:ext cx="5120640" cy="365760"/>
-          </a:xfrm>
-          <a:prstGeom prst="rect">
-            <a:avLst/>
-          </a:prstGeom>
-          <a:noFill/>
-        </p:spPr>
-        <p:txBody>
-          <a:bodyPr wrap="square">
-            <a:spAutoFit/>
-          </a:bodyPr>
-          <a:lstStyle/>
-          <a:p>
-            <a:pPr algn="l"/>
-            <a:r>
-              <a:rPr sz="1400" b="0" i="0">
-                <a:solidFill>
-                  <a:srgbClr val="3A4A5C"/>
-                </a:solidFill>
-              </a:rPr>
-              <a:t>Fully missing CpGs:             [ TBD ]</a:t>
-            </a:r>
-          </a:p>
-        </p:txBody>
-      </p:sp>
-      <p:sp>
-        <p:nvSpPr>
-          <p:cNvPr id="16" name="Rectangle 15"/>
+            <a:off x="3520440" y="2880360"/>
+            <a:ext cx="2286000" cy="347472"/>
+          </a:xfrm>
+          <a:prstGeom prst="rect">
+            <a:avLst/>
+          </a:prstGeom>
+          <a:noFill/>
+        </p:spPr>
+        <p:txBody>
+          <a:bodyPr wrap="square">
+            <a:spAutoFit/>
+          </a:bodyPr>
+          <a:lstStyle/>
+          <a:p>
+            <a:pPr algn="l"/>
+            <a:r>
+              <a:rPr sz="1300" b="1" i="0">
+                <a:solidFill>
+                  <a:srgbClr val="D47E00"/>
+                </a:solidFill>
+              </a:rPr>
+              <a:t>91,652  (54.2%)</a:t>
+            </a:r>
+          </a:p>
+        </p:txBody>
+      </p:sp>
+      <p:sp>
+        <p:nvSpPr>
+          <p:cNvPr id="16" name="TextBox 15"/>
+          <p:cNvSpPr txBox="1"/>
+          <p:nvPr/>
+        </p:nvSpPr>
+        <p:spPr>
+          <a:xfrm>
+            <a:off x="548640" y="3255263"/>
+            <a:ext cx="2926080" cy="347472"/>
+          </a:xfrm>
+          <a:prstGeom prst="rect">
+            <a:avLst/>
+          </a:prstGeom>
+          <a:noFill/>
+        </p:spPr>
+        <p:txBody>
+          <a:bodyPr wrap="square">
+            <a:spAutoFit/>
+          </a:bodyPr>
+          <a:lstStyle/>
+          <a:p>
+            <a:pPr algn="l"/>
+            <a:r>
+              <a:rPr sz="1300" b="0" i="0">
+                <a:solidFill>
+                  <a:srgbClr val="788FA8"/>
+                </a:solidFill>
+              </a:rPr>
+              <a:t>Samples with ≥10% NaN</a:t>
+            </a:r>
+          </a:p>
+        </p:txBody>
+      </p:sp>
+      <p:sp>
+        <p:nvSpPr>
+          <p:cNvPr id="17" name="TextBox 16"/>
+          <p:cNvSpPr txBox="1"/>
+          <p:nvPr/>
+        </p:nvSpPr>
+        <p:spPr>
+          <a:xfrm>
+            <a:off x="3520440" y="3255263"/>
+            <a:ext cx="2286000" cy="347472"/>
+          </a:xfrm>
+          <a:prstGeom prst="rect">
+            <a:avLst/>
+          </a:prstGeom>
+          <a:noFill/>
+        </p:spPr>
+        <p:txBody>
+          <a:bodyPr wrap="square">
+            <a:spAutoFit/>
+          </a:bodyPr>
+          <a:lstStyle/>
+          <a:p>
+            <a:pPr algn="l"/>
+            <a:r>
+              <a:rPr sz="1300" b="1" i="0">
+                <a:solidFill>
+                  <a:srgbClr val="D47E00"/>
+                </a:solidFill>
+              </a:rPr>
+              <a:t>35,329  (20.9%)</a:t>
+            </a:r>
+          </a:p>
+        </p:txBody>
+      </p:sp>
+      <p:sp>
+        <p:nvSpPr>
+          <p:cNvPr id="18" name="TextBox 17"/>
+          <p:cNvSpPr txBox="1"/>
+          <p:nvPr/>
+        </p:nvSpPr>
+        <p:spPr>
+          <a:xfrm>
+            <a:off x="548640" y="3630168"/>
+            <a:ext cx="2926080" cy="347472"/>
+          </a:xfrm>
+          <a:prstGeom prst="rect">
+            <a:avLst/>
+          </a:prstGeom>
+          <a:noFill/>
+        </p:spPr>
+        <p:txBody>
+          <a:bodyPr wrap="square">
+            <a:spAutoFit/>
+          </a:bodyPr>
+          <a:lstStyle/>
+          <a:p>
+            <a:pPr algn="l"/>
+            <a:r>
+              <a:rPr sz="1300" b="0" i="0">
+                <a:solidFill>
+                  <a:srgbClr val="788FA8"/>
+                </a:solidFill>
+              </a:rPr>
+              <a:t>Samples with ≥50% NaN</a:t>
+            </a:r>
+          </a:p>
+        </p:txBody>
+      </p:sp>
+      <p:sp>
+        <p:nvSpPr>
+          <p:cNvPr id="19" name="TextBox 18"/>
+          <p:cNvSpPr txBox="1"/>
+          <p:nvPr/>
+        </p:nvSpPr>
+        <p:spPr>
+          <a:xfrm>
+            <a:off x="3520440" y="3630168"/>
+            <a:ext cx="2286000" cy="347472"/>
+          </a:xfrm>
+          <a:prstGeom prst="rect">
+            <a:avLst/>
+          </a:prstGeom>
+          <a:noFill/>
+        </p:spPr>
+        <p:txBody>
+          <a:bodyPr wrap="square">
+            <a:spAutoFit/>
+          </a:bodyPr>
+          <a:lstStyle/>
+          <a:p>
+            <a:pPr algn="l"/>
+            <a:r>
+              <a:rPr sz="1300" b="1" i="0">
+                <a:solidFill>
+                  <a:srgbClr val="C03030"/>
+                </a:solidFill>
+              </a:rPr>
+              <a:t>16,860  (10.0%)</a:t>
+            </a:r>
+          </a:p>
+        </p:txBody>
+      </p:sp>
+      <p:sp>
+        <p:nvSpPr>
+          <p:cNvPr id="20" name="TextBox 19"/>
+          <p:cNvSpPr txBox="1"/>
+          <p:nvPr/>
+        </p:nvSpPr>
+        <p:spPr>
+          <a:xfrm>
+            <a:off x="548640" y="4005072"/>
+            <a:ext cx="2926080" cy="347472"/>
+          </a:xfrm>
+          <a:prstGeom prst="rect">
+            <a:avLst/>
+          </a:prstGeom>
+          <a:noFill/>
+        </p:spPr>
+        <p:txBody>
+          <a:bodyPr wrap="square">
+            <a:spAutoFit/>
+          </a:bodyPr>
+          <a:lstStyle/>
+          <a:p>
+            <a:pPr algn="l"/>
+            <a:r>
+              <a:rPr sz="1300" b="0" i="0">
+                <a:solidFill>
+                  <a:srgbClr val="788FA8"/>
+                </a:solidFill>
+              </a:rPr>
+              <a:t>CpGs with ≥10% NaN</a:t>
+            </a:r>
+          </a:p>
+        </p:txBody>
+      </p:sp>
+      <p:sp>
+        <p:nvSpPr>
+          <p:cNvPr id="21" name="TextBox 20"/>
+          <p:cNvSpPr txBox="1"/>
+          <p:nvPr/>
+        </p:nvSpPr>
+        <p:spPr>
+          <a:xfrm>
+            <a:off x="3520440" y="4005072"/>
+            <a:ext cx="2286000" cy="347472"/>
+          </a:xfrm>
+          <a:prstGeom prst="rect">
+            <a:avLst/>
+          </a:prstGeom>
+          <a:noFill/>
+        </p:spPr>
+        <p:txBody>
+          <a:bodyPr wrap="square">
+            <a:spAutoFit/>
+          </a:bodyPr>
+          <a:lstStyle/>
+          <a:p>
+            <a:pPr algn="l"/>
+            <a:r>
+              <a:rPr sz="1300" b="1" i="0">
+                <a:solidFill>
+                  <a:srgbClr val="D47E00"/>
+                </a:solidFill>
+              </a:rPr>
+              <a:t>24,928  (50.7%)</a:t>
+            </a:r>
+          </a:p>
+        </p:txBody>
+      </p:sp>
+      <p:sp>
+        <p:nvSpPr>
+          <p:cNvPr id="22" name="TextBox 21"/>
+          <p:cNvSpPr txBox="1"/>
+          <p:nvPr/>
+        </p:nvSpPr>
+        <p:spPr>
+          <a:xfrm>
+            <a:off x="548640" y="4379975"/>
+            <a:ext cx="2926080" cy="347472"/>
+          </a:xfrm>
+          <a:prstGeom prst="rect">
+            <a:avLst/>
+          </a:prstGeom>
+          <a:noFill/>
+        </p:spPr>
+        <p:txBody>
+          <a:bodyPr wrap="square">
+            <a:spAutoFit/>
+          </a:bodyPr>
+          <a:lstStyle/>
+          <a:p>
+            <a:pPr algn="l"/>
+            <a:r>
+              <a:rPr sz="1300" b="0" i="0">
+                <a:solidFill>
+                  <a:srgbClr val="788FA8"/>
+                </a:solidFill>
+              </a:rPr>
+              <a:t>Fully missing samples</a:t>
+            </a:r>
+          </a:p>
+        </p:txBody>
+      </p:sp>
+      <p:sp>
+        <p:nvSpPr>
+          <p:cNvPr id="23" name="TextBox 22"/>
+          <p:cNvSpPr txBox="1"/>
+          <p:nvPr/>
+        </p:nvSpPr>
+        <p:spPr>
+          <a:xfrm>
+            <a:off x="3520440" y="4379975"/>
+            <a:ext cx="2286000" cy="347472"/>
+          </a:xfrm>
+          <a:prstGeom prst="rect">
+            <a:avLst/>
+          </a:prstGeom>
+          <a:noFill/>
+        </p:spPr>
+        <p:txBody>
+          <a:bodyPr wrap="square">
+            <a:spAutoFit/>
+          </a:bodyPr>
+          <a:lstStyle/>
+          <a:p>
+            <a:pPr algn="l"/>
+            <a:r>
+              <a:rPr sz="1300" b="1" i="0">
+                <a:solidFill>
+                  <a:srgbClr val="008F6A"/>
+                </a:solidFill>
+              </a:rPr>
+              <a:t>0  ✓</a:t>
+            </a:r>
+          </a:p>
+        </p:txBody>
+      </p:sp>
+      <p:sp>
+        <p:nvSpPr>
+          <p:cNvPr id="24" name="TextBox 23"/>
+          <p:cNvSpPr txBox="1"/>
+          <p:nvPr/>
+        </p:nvSpPr>
+        <p:spPr>
+          <a:xfrm>
+            <a:off x="548640" y="4754879"/>
+            <a:ext cx="2926080" cy="347472"/>
+          </a:xfrm>
+          <a:prstGeom prst="rect">
+            <a:avLst/>
+          </a:prstGeom>
+          <a:noFill/>
+        </p:spPr>
+        <p:txBody>
+          <a:bodyPr wrap="square">
+            <a:spAutoFit/>
+          </a:bodyPr>
+          <a:lstStyle/>
+          <a:p>
+            <a:pPr algn="l"/>
+            <a:r>
+              <a:rPr sz="1300" b="0" i="0">
+                <a:solidFill>
+                  <a:srgbClr val="788FA8"/>
+                </a:solidFill>
+              </a:rPr>
+              <a:t>Fully missing CpGs</a:t>
+            </a:r>
+          </a:p>
+        </p:txBody>
+      </p:sp>
+      <p:sp>
+        <p:nvSpPr>
+          <p:cNvPr id="25" name="TextBox 24"/>
+          <p:cNvSpPr txBox="1"/>
+          <p:nvPr/>
+        </p:nvSpPr>
+        <p:spPr>
+          <a:xfrm>
+            <a:off x="3520440" y="4754879"/>
+            <a:ext cx="2286000" cy="347472"/>
+          </a:xfrm>
+          <a:prstGeom prst="rect">
+            <a:avLst/>
+          </a:prstGeom>
+          <a:noFill/>
+        </p:spPr>
+        <p:txBody>
+          <a:bodyPr wrap="square">
+            <a:spAutoFit/>
+          </a:bodyPr>
+          <a:lstStyle/>
+          <a:p>
+            <a:pPr algn="l"/>
+            <a:r>
+              <a:rPr sz="1300" b="1" i="0">
+                <a:solidFill>
+                  <a:srgbClr val="008F6A"/>
+                </a:solidFill>
+              </a:rPr>
+              <a:t>0  ✓</a:t>
+            </a:r>
+          </a:p>
+        </p:txBody>
+      </p:sp>
+      <p:sp>
+        <p:nvSpPr>
+          <p:cNvPr id="26" name="TextBox 25"/>
+          <p:cNvSpPr txBox="1"/>
+          <p:nvPr/>
+        </p:nvSpPr>
+        <p:spPr>
+          <a:xfrm>
+            <a:off x="548640" y="5129783"/>
+            <a:ext cx="2926080" cy="347472"/>
+          </a:xfrm>
+          <a:prstGeom prst="rect">
+            <a:avLst/>
+          </a:prstGeom>
+          <a:noFill/>
+        </p:spPr>
+        <p:txBody>
+          <a:bodyPr wrap="square">
+            <a:spAutoFit/>
+          </a:bodyPr>
+          <a:lstStyle/>
+          <a:p>
+            <a:pPr algn="l"/>
+            <a:r>
+              <a:rPr sz="1300" b="0" i="0">
+                <a:solidFill>
+                  <a:srgbClr val="788FA8"/>
+                </a:solidFill>
+              </a:rPr>
+              <a:t>Duplicate samples</a:t>
+            </a:r>
+          </a:p>
+        </p:txBody>
+      </p:sp>
+      <p:sp>
+        <p:nvSpPr>
+          <p:cNvPr id="27" name="TextBox 26"/>
+          <p:cNvSpPr txBox="1"/>
+          <p:nvPr/>
+        </p:nvSpPr>
+        <p:spPr>
+          <a:xfrm>
+            <a:off x="3520440" y="5129783"/>
+            <a:ext cx="2286000" cy="347472"/>
+          </a:xfrm>
+          <a:prstGeom prst="rect">
+            <a:avLst/>
+          </a:prstGeom>
+          <a:noFill/>
+        </p:spPr>
+        <p:txBody>
+          <a:bodyPr wrap="square">
+            <a:spAutoFit/>
+          </a:bodyPr>
+          <a:lstStyle/>
+          <a:p>
+            <a:pPr algn="l"/>
+            <a:r>
+              <a:rPr sz="1300" b="1" i="0">
+                <a:solidFill>
+                  <a:srgbClr val="008F6A"/>
+                </a:solidFill>
+              </a:rPr>
+              <a:t>0  ✓</a:t>
+            </a:r>
+          </a:p>
+        </p:txBody>
+      </p:sp>
+      <p:sp>
+        <p:nvSpPr>
+          <p:cNvPr id="28" name="TextBox 27"/>
+          <p:cNvSpPr txBox="1"/>
+          <p:nvPr/>
+        </p:nvSpPr>
+        <p:spPr>
+          <a:xfrm>
+            <a:off x="548640" y="5504688"/>
+            <a:ext cx="2926080" cy="347472"/>
+          </a:xfrm>
+          <a:prstGeom prst="rect">
+            <a:avLst/>
+          </a:prstGeom>
+          <a:noFill/>
+        </p:spPr>
+        <p:txBody>
+          <a:bodyPr wrap="square">
+            <a:spAutoFit/>
+          </a:bodyPr>
+          <a:lstStyle/>
+          <a:p>
+            <a:pPr algn="l"/>
+            <a:r>
+              <a:rPr sz="1300" b="0" i="0">
+                <a:solidFill>
+                  <a:srgbClr val="788FA8"/>
+                </a:solidFill>
+              </a:rPr>
+              <a:t>β out-of-range [0,1]</a:t>
+            </a:r>
+          </a:p>
+        </p:txBody>
+      </p:sp>
+      <p:sp>
+        <p:nvSpPr>
+          <p:cNvPr id="29" name="TextBox 28"/>
+          <p:cNvSpPr txBox="1"/>
+          <p:nvPr/>
+        </p:nvSpPr>
+        <p:spPr>
+          <a:xfrm>
+            <a:off x="3520440" y="5504688"/>
+            <a:ext cx="2286000" cy="347472"/>
+          </a:xfrm>
+          <a:prstGeom prst="rect">
+            <a:avLst/>
+          </a:prstGeom>
+          <a:noFill/>
+        </p:spPr>
+        <p:txBody>
+          <a:bodyPr wrap="square">
+            <a:spAutoFit/>
+          </a:bodyPr>
+          <a:lstStyle/>
+          <a:p>
+            <a:pPr algn="l"/>
+            <a:r>
+              <a:rPr sz="1300" b="1" i="0">
+                <a:solidFill>
+                  <a:srgbClr val="D47E00"/>
+                </a:solidFill>
+              </a:rPr>
+              <a:t>248,776  ⚠</a:t>
+            </a:r>
+          </a:p>
+        </p:txBody>
+      </p:sp>
+      <p:sp>
+        <p:nvSpPr>
+          <p:cNvPr id="30" name="Rectangle 29"/>
           <p:cNvSpPr/>
           <p:nvPr/>
         </p:nvSpPr>
         <p:spPr>
           <a:xfrm>
-            <a:off x="6400800" y="1828800"/>
-            <a:ext cx="5394960" cy="4160520"/>
+            <a:off x="6172200" y="1261872"/>
+            <a:ext cx="5669280" cy="4937760"/>
           </a:xfrm>
           <a:prstGeom prst="rect">
             <a:avLst/>
@@ -5658,13 +6134,13 @@
       </p:sp>
       <p:sp>
         <p:nvSpPr>
-          <p:cNvPr id="17" name="TextBox 16"/>
-          <p:cNvSpPr txBox="1"/>
-          <p:nvPr/>
-        </p:nvSpPr>
-        <p:spPr>
-          <a:xfrm>
-            <a:off x="6537960" y="1901952"/>
+          <p:cNvPr id="31" name="TextBox 30"/>
+          <p:cNvSpPr txBox="1"/>
+          <p:nvPr/>
+        </p:nvSpPr>
+        <p:spPr>
+          <a:xfrm>
+            <a:off x="6309360" y="1353312"/>
             <a:ext cx="5486400" cy="274320"/>
           </a:xfrm>
           <a:prstGeom prst="rect">
@@ -5685,259 +6161,769 @@
                   <a:srgbClr val="008F6A"/>
                 </a:solidFill>
               </a:rPr>
-              <a:t>FINE-TUNE  (11.5k × 49k)</a:t>
-            </a:r>
-          </a:p>
-        </p:txBody>
-      </p:sp>
-      <p:sp>
-        <p:nvSpPr>
-          <p:cNvPr id="18" name="TextBox 17"/>
-          <p:cNvSpPr txBox="1"/>
-          <p:nvPr/>
-        </p:nvSpPr>
-        <p:spPr>
-          <a:xfrm>
-            <a:off x="6583680" y="2331720"/>
-            <a:ext cx="4937760" cy="365760"/>
-          </a:xfrm>
-          <a:prstGeom prst="rect">
-            <a:avLst/>
-          </a:prstGeom>
-          <a:noFill/>
-        </p:spPr>
-        <p:txBody>
-          <a:bodyPr wrap="square">
-            <a:spAutoFit/>
-          </a:bodyPr>
-          <a:lstStyle/>
-          <a:p>
-            <a:pPr algn="l"/>
-            <a:r>
-              <a:rPr sz="1400" b="0" i="0">
+              <a:t>FINE-TUNE  (11,453 × 49,156)</a:t>
+            </a:r>
+          </a:p>
+        </p:txBody>
+      </p:sp>
+      <p:sp>
+        <p:nvSpPr>
+          <p:cNvPr id="32" name="TextBox 31"/>
+          <p:cNvSpPr txBox="1"/>
+          <p:nvPr/>
+        </p:nvSpPr>
+        <p:spPr>
+          <a:xfrm>
+            <a:off x="6309360" y="1755648"/>
+            <a:ext cx="3017520" cy="347472"/>
+          </a:xfrm>
+          <a:prstGeom prst="rect">
+            <a:avLst/>
+          </a:prstGeom>
+          <a:noFill/>
+        </p:spPr>
+        <p:txBody>
+          <a:bodyPr wrap="square">
+            <a:spAutoFit/>
+          </a:bodyPr>
+          <a:lstStyle/>
+          <a:p>
+            <a:pPr algn="l"/>
+            <a:r>
+              <a:rPr sz="1300" b="0" i="0">
+                <a:solidFill>
+                  <a:srgbClr val="788FA8"/>
+                </a:solidFill>
+              </a:rPr>
+              <a:t>Total β-values</a:t>
+            </a:r>
+          </a:p>
+        </p:txBody>
+      </p:sp>
+      <p:sp>
+        <p:nvSpPr>
+          <p:cNvPr id="33" name="TextBox 32"/>
+          <p:cNvSpPr txBox="1"/>
+          <p:nvPr/>
+        </p:nvSpPr>
+        <p:spPr>
+          <a:xfrm>
+            <a:off x="9372600" y="1755648"/>
+            <a:ext cx="2286000" cy="347472"/>
+          </a:xfrm>
+          <a:prstGeom prst="rect">
+            <a:avLst/>
+          </a:prstGeom>
+          <a:noFill/>
+        </p:spPr>
+        <p:txBody>
+          <a:bodyPr wrap="square">
+            <a:spAutoFit/>
+          </a:bodyPr>
+          <a:lstStyle/>
+          <a:p>
+            <a:pPr algn="l"/>
+            <a:r>
+              <a:rPr sz="1300" b="1" i="0">
                 <a:solidFill>
                   <a:srgbClr val="3A4A5C"/>
                 </a:solidFill>
               </a:rPr>
-              <a:t>Total NaN count:            [ TBD ]</a:t>
-            </a:r>
-          </a:p>
-        </p:txBody>
-      </p:sp>
-      <p:sp>
-        <p:nvSpPr>
-          <p:cNvPr id="19" name="TextBox 18"/>
-          <p:cNvSpPr txBox="1"/>
-          <p:nvPr/>
-        </p:nvSpPr>
-        <p:spPr>
-          <a:xfrm>
-            <a:off x="6583680" y="2743200"/>
-            <a:ext cx="4937760" cy="365760"/>
-          </a:xfrm>
-          <a:prstGeom prst="rect">
-            <a:avLst/>
-          </a:prstGeom>
-          <a:noFill/>
-        </p:spPr>
-        <p:txBody>
-          <a:bodyPr wrap="square">
-            <a:spAutoFit/>
-          </a:bodyPr>
-          <a:lstStyle/>
-          <a:p>
-            <a:pPr algn="l"/>
-            <a:r>
-              <a:rPr sz="1400" b="0" i="0">
-                <a:solidFill>
-                  <a:srgbClr val="3A4A5C"/>
-                </a:solidFill>
-              </a:rPr>
-              <a:t>NaN %:                      [ TBD ]</a:t>
-            </a:r>
-          </a:p>
-        </p:txBody>
-      </p:sp>
-      <p:sp>
-        <p:nvSpPr>
-          <p:cNvPr id="20" name="TextBox 19"/>
-          <p:cNvSpPr txBox="1"/>
-          <p:nvPr/>
-        </p:nvSpPr>
-        <p:spPr>
-          <a:xfrm>
-            <a:off x="6583680" y="3154680"/>
-            <a:ext cx="4937760" cy="365760"/>
-          </a:xfrm>
-          <a:prstGeom prst="rect">
-            <a:avLst/>
-          </a:prstGeom>
-          <a:noFill/>
-        </p:spPr>
-        <p:txBody>
-          <a:bodyPr wrap="square">
-            <a:spAutoFit/>
-          </a:bodyPr>
-          <a:lstStyle/>
-          <a:p>
-            <a:pPr algn="l"/>
-            <a:r>
-              <a:rPr sz="1400" b="0" i="0">
-                <a:solidFill>
-                  <a:srgbClr val="3A4A5C"/>
-                </a:solidFill>
-              </a:rPr>
-              <a:t>Samples with ≥1% NaN:      [ TBD ]</a:t>
-            </a:r>
-          </a:p>
-        </p:txBody>
-      </p:sp>
-      <p:sp>
-        <p:nvSpPr>
-          <p:cNvPr id="21" name="TextBox 20"/>
-          <p:cNvSpPr txBox="1"/>
-          <p:nvPr/>
-        </p:nvSpPr>
-        <p:spPr>
-          <a:xfrm>
-            <a:off x="6583680" y="3566160"/>
-            <a:ext cx="4937760" cy="365760"/>
-          </a:xfrm>
-          <a:prstGeom prst="rect">
-            <a:avLst/>
-          </a:prstGeom>
-          <a:noFill/>
-        </p:spPr>
-        <p:txBody>
-          <a:bodyPr wrap="square">
-            <a:spAutoFit/>
-          </a:bodyPr>
-          <a:lstStyle/>
-          <a:p>
-            <a:pPr algn="l"/>
-            <a:r>
-              <a:rPr sz="1400" b="0" i="0">
-                <a:solidFill>
-                  <a:srgbClr val="3A4A5C"/>
-                </a:solidFill>
-              </a:rPr>
-              <a:t>Samples with ≥10% NaN:     [ TBD ]</a:t>
-            </a:r>
-          </a:p>
-        </p:txBody>
-      </p:sp>
-      <p:sp>
-        <p:nvSpPr>
-          <p:cNvPr id="22" name="TextBox 21"/>
-          <p:cNvSpPr txBox="1"/>
-          <p:nvPr/>
-        </p:nvSpPr>
-        <p:spPr>
-          <a:xfrm>
-            <a:off x="6583680" y="3977639"/>
-            <a:ext cx="4937760" cy="365760"/>
-          </a:xfrm>
-          <a:prstGeom prst="rect">
-            <a:avLst/>
-          </a:prstGeom>
-          <a:noFill/>
-        </p:spPr>
-        <p:txBody>
-          <a:bodyPr wrap="square">
-            <a:spAutoFit/>
-          </a:bodyPr>
-          <a:lstStyle/>
-          <a:p>
-            <a:pPr algn="l"/>
-            <a:r>
-              <a:rPr sz="1400" b="0" i="0">
-                <a:solidFill>
-                  <a:srgbClr val="3A4A5C"/>
-                </a:solidFill>
-              </a:rPr>
-              <a:t>Train split NaN %:          [ TBD ]</a:t>
-            </a:r>
-          </a:p>
-        </p:txBody>
-      </p:sp>
-      <p:sp>
-        <p:nvSpPr>
-          <p:cNvPr id="23" name="TextBox 22"/>
-          <p:cNvSpPr txBox="1"/>
-          <p:nvPr/>
-        </p:nvSpPr>
-        <p:spPr>
-          <a:xfrm>
-            <a:off x="6583680" y="4389120"/>
-            <a:ext cx="4937760" cy="365760"/>
-          </a:xfrm>
-          <a:prstGeom prst="rect">
-            <a:avLst/>
-          </a:prstGeom>
-          <a:noFill/>
-        </p:spPr>
-        <p:txBody>
-          <a:bodyPr wrap="square">
-            <a:spAutoFit/>
-          </a:bodyPr>
-          <a:lstStyle/>
-          <a:p>
-            <a:pPr algn="l"/>
-            <a:r>
-              <a:rPr sz="1400" b="0" i="0">
-                <a:solidFill>
-                  <a:srgbClr val="3A4A5C"/>
-                </a:solidFill>
-              </a:rPr>
-              <a:t>Valid split NaN %:          [ TBD ]</a:t>
-            </a:r>
-          </a:p>
-        </p:txBody>
-      </p:sp>
-      <p:sp>
-        <p:nvSpPr>
-          <p:cNvPr id="24" name="TextBox 23"/>
-          <p:cNvSpPr txBox="1"/>
-          <p:nvPr/>
-        </p:nvSpPr>
-        <p:spPr>
-          <a:xfrm>
-            <a:off x="6583680" y="4800600"/>
-            <a:ext cx="4937760" cy="365760"/>
-          </a:xfrm>
-          <a:prstGeom prst="rect">
-            <a:avLst/>
-          </a:prstGeom>
-          <a:noFill/>
-        </p:spPr>
-        <p:txBody>
-          <a:bodyPr wrap="square">
-            <a:spAutoFit/>
-          </a:bodyPr>
-          <a:lstStyle/>
-          <a:p>
-            <a:pPr algn="l"/>
-            <a:r>
-              <a:rPr sz="1400" b="0" i="0">
-                <a:solidFill>
-                  <a:srgbClr val="3A4A5C"/>
-                </a:solidFill>
-              </a:rPr>
-              <a:t>Test  split NaN %:          [ TBD ]</a:t>
-            </a:r>
-          </a:p>
-        </p:txBody>
-      </p:sp>
-      <p:sp>
-        <p:nvSpPr>
-          <p:cNvPr id="25" name="Rectangle 24"/>
+              <a:t>562,983,668</a:t>
+            </a:r>
+          </a:p>
+        </p:txBody>
+      </p:sp>
+      <p:sp>
+        <p:nvSpPr>
+          <p:cNvPr id="34" name="TextBox 33"/>
+          <p:cNvSpPr txBox="1"/>
+          <p:nvPr/>
+        </p:nvSpPr>
+        <p:spPr>
+          <a:xfrm>
+            <a:off x="6309360" y="2130552"/>
+            <a:ext cx="3017520" cy="347472"/>
+          </a:xfrm>
+          <a:prstGeom prst="rect">
+            <a:avLst/>
+          </a:prstGeom>
+          <a:noFill/>
+        </p:spPr>
+        <p:txBody>
+          <a:bodyPr wrap="square">
+            <a:spAutoFit/>
+          </a:bodyPr>
+          <a:lstStyle/>
+          <a:p>
+            <a:pPr algn="l"/>
+            <a:r>
+              <a:rPr sz="1300" b="0" i="0">
+                <a:solidFill>
+                  <a:srgbClr val="788FA8"/>
+                </a:solidFill>
+              </a:rPr>
+              <a:t>NaN count</a:t>
+            </a:r>
+          </a:p>
+        </p:txBody>
+      </p:sp>
+      <p:sp>
+        <p:nvSpPr>
+          <p:cNvPr id="35" name="TextBox 34"/>
+          <p:cNvSpPr txBox="1"/>
+          <p:nvPr/>
+        </p:nvSpPr>
+        <p:spPr>
+          <a:xfrm>
+            <a:off x="9372600" y="2130552"/>
+            <a:ext cx="2286000" cy="347472"/>
+          </a:xfrm>
+          <a:prstGeom prst="rect">
+            <a:avLst/>
+          </a:prstGeom>
+          <a:noFill/>
+        </p:spPr>
+        <p:txBody>
+          <a:bodyPr wrap="square">
+            <a:spAutoFit/>
+          </a:bodyPr>
+          <a:lstStyle/>
+          <a:p>
+            <a:pPr algn="l"/>
+            <a:r>
+              <a:rPr sz="1300" b="1" i="0">
+                <a:solidFill>
+                  <a:srgbClr val="C03030"/>
+                </a:solidFill>
+              </a:rPr>
+              <a:t>338,413,244</a:t>
+            </a:r>
+          </a:p>
+        </p:txBody>
+      </p:sp>
+      <p:sp>
+        <p:nvSpPr>
+          <p:cNvPr id="36" name="TextBox 35"/>
+          <p:cNvSpPr txBox="1"/>
+          <p:nvPr/>
+        </p:nvSpPr>
+        <p:spPr>
+          <a:xfrm>
+            <a:off x="6309360" y="2505456"/>
+            <a:ext cx="3017520" cy="347472"/>
+          </a:xfrm>
+          <a:prstGeom prst="rect">
+            <a:avLst/>
+          </a:prstGeom>
+          <a:noFill/>
+        </p:spPr>
+        <p:txBody>
+          <a:bodyPr wrap="square">
+            <a:spAutoFit/>
+          </a:bodyPr>
+          <a:lstStyle/>
+          <a:p>
+            <a:pPr algn="l"/>
+            <a:r>
+              <a:rPr sz="1300" b="0" i="0">
+                <a:solidFill>
+                  <a:srgbClr val="788FA8"/>
+                </a:solidFill>
+              </a:rPr>
+              <a:t>NaN %</a:t>
+            </a:r>
+          </a:p>
+        </p:txBody>
+      </p:sp>
+      <p:sp>
+        <p:nvSpPr>
+          <p:cNvPr id="37" name="TextBox 36"/>
+          <p:cNvSpPr txBox="1"/>
+          <p:nvPr/>
+        </p:nvSpPr>
+        <p:spPr>
+          <a:xfrm>
+            <a:off x="9372600" y="2505456"/>
+            <a:ext cx="2286000" cy="347472"/>
+          </a:xfrm>
+          <a:prstGeom prst="rect">
+            <a:avLst/>
+          </a:prstGeom>
+          <a:noFill/>
+        </p:spPr>
+        <p:txBody>
+          <a:bodyPr wrap="square">
+            <a:spAutoFit/>
+          </a:bodyPr>
+          <a:lstStyle/>
+          <a:p>
+            <a:pPr algn="l"/>
+            <a:r>
+              <a:rPr sz="1300" b="1" i="0">
+                <a:solidFill>
+                  <a:srgbClr val="C03030"/>
+                </a:solidFill>
+              </a:rPr>
+              <a:t>60.11%</a:t>
+            </a:r>
+          </a:p>
+        </p:txBody>
+      </p:sp>
+      <p:sp>
+        <p:nvSpPr>
+          <p:cNvPr id="38" name="TextBox 37"/>
+          <p:cNvSpPr txBox="1"/>
+          <p:nvPr/>
+        </p:nvSpPr>
+        <p:spPr>
+          <a:xfrm>
+            <a:off x="6309360" y="2880360"/>
+            <a:ext cx="3017520" cy="347472"/>
+          </a:xfrm>
+          <a:prstGeom prst="rect">
+            <a:avLst/>
+          </a:prstGeom>
+          <a:noFill/>
+        </p:spPr>
+        <p:txBody>
+          <a:bodyPr wrap="square">
+            <a:spAutoFit/>
+          </a:bodyPr>
+          <a:lstStyle/>
+          <a:p>
+            <a:pPr algn="l"/>
+            <a:r>
+              <a:rPr sz="1300" b="0" i="0">
+                <a:solidFill>
+                  <a:srgbClr val="788FA8"/>
+                </a:solidFill>
+              </a:rPr>
+              <a:t>Samples with ≥50% NaN</a:t>
+            </a:r>
+          </a:p>
+        </p:txBody>
+      </p:sp>
+      <p:sp>
+        <p:nvSpPr>
+          <p:cNvPr id="39" name="TextBox 38"/>
+          <p:cNvSpPr txBox="1"/>
+          <p:nvPr/>
+        </p:nvSpPr>
+        <p:spPr>
+          <a:xfrm>
+            <a:off x="9372600" y="2880360"/>
+            <a:ext cx="2286000" cy="347472"/>
+          </a:xfrm>
+          <a:prstGeom prst="rect">
+            <a:avLst/>
+          </a:prstGeom>
+          <a:noFill/>
+        </p:spPr>
+        <p:txBody>
+          <a:bodyPr wrap="square">
+            <a:spAutoFit/>
+          </a:bodyPr>
+          <a:lstStyle/>
+          <a:p>
+            <a:pPr algn="l"/>
+            <a:r>
+              <a:rPr sz="1300" b="1" i="0">
+                <a:solidFill>
+                  <a:srgbClr val="C03030"/>
+                </a:solidFill>
+              </a:rPr>
+              <a:t>11,453  (100%)</a:t>
+            </a:r>
+          </a:p>
+        </p:txBody>
+      </p:sp>
+      <p:sp>
+        <p:nvSpPr>
+          <p:cNvPr id="40" name="TextBox 39"/>
+          <p:cNvSpPr txBox="1"/>
+          <p:nvPr/>
+        </p:nvSpPr>
+        <p:spPr>
+          <a:xfrm>
+            <a:off x="6309360" y="3255263"/>
+            <a:ext cx="3017520" cy="347472"/>
+          </a:xfrm>
+          <a:prstGeom prst="rect">
+            <a:avLst/>
+          </a:prstGeom>
+          <a:noFill/>
+        </p:spPr>
+        <p:txBody>
+          <a:bodyPr wrap="square">
+            <a:spAutoFit/>
+          </a:bodyPr>
+          <a:lstStyle/>
+          <a:p>
+            <a:pPr algn="l"/>
+            <a:r>
+              <a:rPr sz="1300" b="0" i="0">
+                <a:solidFill>
+                  <a:srgbClr val="788FA8"/>
+                </a:solidFill>
+              </a:rPr>
+              <a:t>CpGs with 100% NaN</a:t>
+            </a:r>
+          </a:p>
+        </p:txBody>
+      </p:sp>
+      <p:sp>
+        <p:nvSpPr>
+          <p:cNvPr id="41" name="TextBox 40"/>
+          <p:cNvSpPr txBox="1"/>
+          <p:nvPr/>
+        </p:nvSpPr>
+        <p:spPr>
+          <a:xfrm>
+            <a:off x="9372600" y="3255263"/>
+            <a:ext cx="2286000" cy="347472"/>
+          </a:xfrm>
+          <a:prstGeom prst="rect">
+            <a:avLst/>
+          </a:prstGeom>
+          <a:noFill/>
+        </p:spPr>
+        <p:txBody>
+          <a:bodyPr wrap="square">
+            <a:spAutoFit/>
+          </a:bodyPr>
+          <a:lstStyle/>
+          <a:p>
+            <a:pPr algn="l"/>
+            <a:r>
+              <a:rPr sz="1300" b="1" i="0">
+                <a:solidFill>
+                  <a:srgbClr val="C03030"/>
+                </a:solidFill>
+              </a:rPr>
+              <a:t>29,548  (60.1%)</a:t>
+            </a:r>
+          </a:p>
+        </p:txBody>
+      </p:sp>
+      <p:sp>
+        <p:nvSpPr>
+          <p:cNvPr id="42" name="TextBox 41"/>
+          <p:cNvSpPr txBox="1"/>
+          <p:nvPr/>
+        </p:nvSpPr>
+        <p:spPr>
+          <a:xfrm>
+            <a:off x="6309360" y="3630168"/>
+            <a:ext cx="3017520" cy="347472"/>
+          </a:xfrm>
+          <a:prstGeom prst="rect">
+            <a:avLst/>
+          </a:prstGeom>
+          <a:noFill/>
+        </p:spPr>
+        <p:txBody>
+          <a:bodyPr wrap="square">
+            <a:spAutoFit/>
+          </a:bodyPr>
+          <a:lstStyle/>
+          <a:p>
+            <a:pPr algn="l"/>
+            <a:r>
+              <a:rPr sz="1300" b="0" i="0">
+                <a:solidFill>
+                  <a:srgbClr val="788FA8"/>
+                </a:solidFill>
+              </a:rPr>
+              <a:t>CpGs with 0 NaN</a:t>
+            </a:r>
+          </a:p>
+        </p:txBody>
+      </p:sp>
+      <p:sp>
+        <p:nvSpPr>
+          <p:cNvPr id="43" name="TextBox 42"/>
+          <p:cNvSpPr txBox="1"/>
+          <p:nvPr/>
+        </p:nvSpPr>
+        <p:spPr>
+          <a:xfrm>
+            <a:off x="9372600" y="3630168"/>
+            <a:ext cx="2286000" cy="347472"/>
+          </a:xfrm>
+          <a:prstGeom prst="rect">
+            <a:avLst/>
+          </a:prstGeom>
+          <a:noFill/>
+        </p:spPr>
+        <p:txBody>
+          <a:bodyPr wrap="square">
+            <a:spAutoFit/>
+          </a:bodyPr>
+          <a:lstStyle/>
+          <a:p>
+            <a:pPr algn="l"/>
+            <a:r>
+              <a:rPr sz="1300" b="1" i="0">
+                <a:solidFill>
+                  <a:srgbClr val="008F6A"/>
+                </a:solidFill>
+              </a:rPr>
+              <a:t>19,608  (39.9%)</a:t>
+            </a:r>
+          </a:p>
+        </p:txBody>
+      </p:sp>
+      <p:sp>
+        <p:nvSpPr>
+          <p:cNvPr id="44" name="TextBox 43"/>
+          <p:cNvSpPr txBox="1"/>
+          <p:nvPr/>
+        </p:nvSpPr>
+        <p:spPr>
+          <a:xfrm>
+            <a:off x="6309360" y="4005072"/>
+            <a:ext cx="3017520" cy="347472"/>
+          </a:xfrm>
+          <a:prstGeom prst="rect">
+            <a:avLst/>
+          </a:prstGeom>
+          <a:noFill/>
+        </p:spPr>
+        <p:txBody>
+          <a:bodyPr wrap="square">
+            <a:spAutoFit/>
+          </a:bodyPr>
+          <a:lstStyle/>
+          <a:p>
+            <a:pPr algn="l"/>
+            <a:r>
+              <a:rPr sz="1300" b="0" i="0">
+                <a:solidFill>
+                  <a:srgbClr val="788FA8"/>
+                </a:solidFill>
+              </a:rPr>
+              <a:t>Train NaN %</a:t>
+            </a:r>
+          </a:p>
+        </p:txBody>
+      </p:sp>
+      <p:sp>
+        <p:nvSpPr>
+          <p:cNvPr id="45" name="TextBox 44"/>
+          <p:cNvSpPr txBox="1"/>
+          <p:nvPr/>
+        </p:nvSpPr>
+        <p:spPr>
+          <a:xfrm>
+            <a:off x="9372600" y="4005072"/>
+            <a:ext cx="2286000" cy="347472"/>
+          </a:xfrm>
+          <a:prstGeom prst="rect">
+            <a:avLst/>
+          </a:prstGeom>
+          <a:noFill/>
+        </p:spPr>
+        <p:txBody>
+          <a:bodyPr wrap="square">
+            <a:spAutoFit/>
+          </a:bodyPr>
+          <a:lstStyle/>
+          <a:p>
+            <a:pPr algn="l"/>
+            <a:r>
+              <a:rPr sz="1300" b="1" i="0">
+                <a:solidFill>
+                  <a:srgbClr val="D47E00"/>
+                </a:solidFill>
+              </a:rPr>
+              <a:t>60.11%</a:t>
+            </a:r>
+          </a:p>
+        </p:txBody>
+      </p:sp>
+      <p:sp>
+        <p:nvSpPr>
+          <p:cNvPr id="46" name="TextBox 45"/>
+          <p:cNvSpPr txBox="1"/>
+          <p:nvPr/>
+        </p:nvSpPr>
+        <p:spPr>
+          <a:xfrm>
+            <a:off x="6309360" y="4379975"/>
+            <a:ext cx="3017520" cy="347472"/>
+          </a:xfrm>
+          <a:prstGeom prst="rect">
+            <a:avLst/>
+          </a:prstGeom>
+          <a:noFill/>
+        </p:spPr>
+        <p:txBody>
+          <a:bodyPr wrap="square">
+            <a:spAutoFit/>
+          </a:bodyPr>
+          <a:lstStyle/>
+          <a:p>
+            <a:pPr algn="l"/>
+            <a:r>
+              <a:rPr sz="1300" b="0" i="0">
+                <a:solidFill>
+                  <a:srgbClr val="788FA8"/>
+                </a:solidFill>
+              </a:rPr>
+              <a:t>Valid NaN %</a:t>
+            </a:r>
+          </a:p>
+        </p:txBody>
+      </p:sp>
+      <p:sp>
+        <p:nvSpPr>
+          <p:cNvPr id="47" name="TextBox 46"/>
+          <p:cNvSpPr txBox="1"/>
+          <p:nvPr/>
+        </p:nvSpPr>
+        <p:spPr>
+          <a:xfrm>
+            <a:off x="9372600" y="4379975"/>
+            <a:ext cx="2286000" cy="347472"/>
+          </a:xfrm>
+          <a:prstGeom prst="rect">
+            <a:avLst/>
+          </a:prstGeom>
+          <a:noFill/>
+        </p:spPr>
+        <p:txBody>
+          <a:bodyPr wrap="square">
+            <a:spAutoFit/>
+          </a:bodyPr>
+          <a:lstStyle/>
+          <a:p>
+            <a:pPr algn="l"/>
+            <a:r>
+              <a:rPr sz="1300" b="1" i="0">
+                <a:solidFill>
+                  <a:srgbClr val="D47E00"/>
+                </a:solidFill>
+              </a:rPr>
+              <a:t>60.11%</a:t>
+            </a:r>
+          </a:p>
+        </p:txBody>
+      </p:sp>
+      <p:sp>
+        <p:nvSpPr>
+          <p:cNvPr id="48" name="TextBox 47"/>
+          <p:cNvSpPr txBox="1"/>
+          <p:nvPr/>
+        </p:nvSpPr>
+        <p:spPr>
+          <a:xfrm>
+            <a:off x="6309360" y="4754879"/>
+            <a:ext cx="3017520" cy="347472"/>
+          </a:xfrm>
+          <a:prstGeom prst="rect">
+            <a:avLst/>
+          </a:prstGeom>
+          <a:noFill/>
+        </p:spPr>
+        <p:txBody>
+          <a:bodyPr wrap="square">
+            <a:spAutoFit/>
+          </a:bodyPr>
+          <a:lstStyle/>
+          <a:p>
+            <a:pPr algn="l"/>
+            <a:r>
+              <a:rPr sz="1300" b="0" i="0">
+                <a:solidFill>
+                  <a:srgbClr val="788FA8"/>
+                </a:solidFill>
+              </a:rPr>
+              <a:t>Test  NaN %</a:t>
+            </a:r>
+          </a:p>
+        </p:txBody>
+      </p:sp>
+      <p:sp>
+        <p:nvSpPr>
+          <p:cNvPr id="49" name="TextBox 48"/>
+          <p:cNvSpPr txBox="1"/>
+          <p:nvPr/>
+        </p:nvSpPr>
+        <p:spPr>
+          <a:xfrm>
+            <a:off x="9372600" y="4754879"/>
+            <a:ext cx="2286000" cy="347472"/>
+          </a:xfrm>
+          <a:prstGeom prst="rect">
+            <a:avLst/>
+          </a:prstGeom>
+          <a:noFill/>
+        </p:spPr>
+        <p:txBody>
+          <a:bodyPr wrap="square">
+            <a:spAutoFit/>
+          </a:bodyPr>
+          <a:lstStyle/>
+          <a:p>
+            <a:pPr algn="l"/>
+            <a:r>
+              <a:rPr sz="1300" b="1" i="0">
+                <a:solidFill>
+                  <a:srgbClr val="D47E00"/>
+                </a:solidFill>
+              </a:rPr>
+              <a:t>60.11%</a:t>
+            </a:r>
+          </a:p>
+        </p:txBody>
+      </p:sp>
+      <p:sp>
+        <p:nvSpPr>
+          <p:cNvPr id="50" name="TextBox 49"/>
+          <p:cNvSpPr txBox="1"/>
+          <p:nvPr/>
+        </p:nvSpPr>
+        <p:spPr>
+          <a:xfrm>
+            <a:off x="6309360" y="5129783"/>
+            <a:ext cx="3017520" cy="347472"/>
+          </a:xfrm>
+          <a:prstGeom prst="rect">
+            <a:avLst/>
+          </a:prstGeom>
+          <a:noFill/>
+        </p:spPr>
+        <p:txBody>
+          <a:bodyPr wrap="square">
+            <a:spAutoFit/>
+          </a:bodyPr>
+          <a:lstStyle/>
+          <a:p>
+            <a:pPr algn="l"/>
+            <a:r>
+              <a:rPr sz="1300" b="0" i="0">
+                <a:solidFill>
+                  <a:srgbClr val="788FA8"/>
+                </a:solidFill>
+              </a:rPr>
+              <a:t>Duplicate sample IDs</a:t>
+            </a:r>
+          </a:p>
+        </p:txBody>
+      </p:sp>
+      <p:sp>
+        <p:nvSpPr>
+          <p:cNvPr id="51" name="TextBox 50"/>
+          <p:cNvSpPr txBox="1"/>
+          <p:nvPr/>
+        </p:nvSpPr>
+        <p:spPr>
+          <a:xfrm>
+            <a:off x="9372600" y="5129783"/>
+            <a:ext cx="2286000" cy="347472"/>
+          </a:xfrm>
+          <a:prstGeom prst="rect">
+            <a:avLst/>
+          </a:prstGeom>
+          <a:noFill/>
+        </p:spPr>
+        <p:txBody>
+          <a:bodyPr wrap="square">
+            <a:spAutoFit/>
+          </a:bodyPr>
+          <a:lstStyle/>
+          <a:p>
+            <a:pPr algn="l"/>
+            <a:r>
+              <a:rPr sz="1300" b="1" i="0">
+                <a:solidFill>
+                  <a:srgbClr val="C03030"/>
+                </a:solidFill>
+              </a:rPr>
+              <a:t>5,992  ⚠</a:t>
+            </a:r>
+          </a:p>
+        </p:txBody>
+      </p:sp>
+      <p:sp>
+        <p:nvSpPr>
+          <p:cNvPr id="52" name="TextBox 51"/>
+          <p:cNvSpPr txBox="1"/>
+          <p:nvPr/>
+        </p:nvSpPr>
+        <p:spPr>
+          <a:xfrm>
+            <a:off x="6309360" y="5504688"/>
+            <a:ext cx="3017520" cy="347472"/>
+          </a:xfrm>
+          <a:prstGeom prst="rect">
+            <a:avLst/>
+          </a:prstGeom>
+          <a:noFill/>
+        </p:spPr>
+        <p:txBody>
+          <a:bodyPr wrap="square">
+            <a:spAutoFit/>
+          </a:bodyPr>
+          <a:lstStyle/>
+          <a:p>
+            <a:pPr algn="l"/>
+            <a:r>
+              <a:rPr sz="1300" b="0" i="0">
+                <a:solidFill>
+                  <a:srgbClr val="788FA8"/>
+                </a:solidFill>
+              </a:rPr>
+              <a:t>β out-of-range [0,1]</a:t>
+            </a:r>
+          </a:p>
+        </p:txBody>
+      </p:sp>
+      <p:sp>
+        <p:nvSpPr>
+          <p:cNvPr id="53" name="TextBox 52"/>
+          <p:cNvSpPr txBox="1"/>
+          <p:nvPr/>
+        </p:nvSpPr>
+        <p:spPr>
+          <a:xfrm>
+            <a:off x="9372600" y="5504688"/>
+            <a:ext cx="2286000" cy="347472"/>
+          </a:xfrm>
+          <a:prstGeom prst="rect">
+            <a:avLst/>
+          </a:prstGeom>
+          <a:noFill/>
+        </p:spPr>
+        <p:txBody>
+          <a:bodyPr wrap="square">
+            <a:spAutoFit/>
+          </a:bodyPr>
+          <a:lstStyle/>
+          <a:p>
+            <a:pPr algn="l"/>
+            <a:r>
+              <a:rPr sz="1300" b="1" i="0">
+                <a:solidFill>
+                  <a:srgbClr val="008F6A"/>
+                </a:solidFill>
+              </a:rPr>
+              <a:t>0  ✓</a:t>
+            </a:r>
+          </a:p>
+        </p:txBody>
+      </p:sp>
+      <p:sp>
+        <p:nvSpPr>
+          <p:cNvPr id="54" name="Rectangle 53"/>
           <p:cNvSpPr/>
           <p:nvPr/>
         </p:nvSpPr>
         <p:spPr>
           <a:xfrm>
-            <a:off x="365760" y="6108192"/>
-            <a:ext cx="11475720" cy="502920"/>
+            <a:off x="365760" y="6327648"/>
+            <a:ext cx="11475720" cy="384048"/>
           </a:xfrm>
           <a:prstGeom prst="rect">
             <a:avLst/>
@@ -5975,34 +6961,34 @@
       </p:sp>
       <p:sp>
         <p:nvSpPr>
-          <p:cNvPr id="26" name="TextBox 25"/>
-          <p:cNvSpPr txBox="1"/>
-          <p:nvPr/>
-        </p:nvSpPr>
-        <p:spPr>
-          <a:xfrm>
-            <a:off x="502920" y="6172200"/>
-            <a:ext cx="11155680" cy="365760"/>
-          </a:xfrm>
-          <a:prstGeom prst="rect">
-            <a:avLst/>
-          </a:prstGeom>
-          <a:noFill/>
-        </p:spPr>
-        <p:txBody>
-          <a:bodyPr wrap="square">
-            <a:spAutoFit/>
-          </a:bodyPr>
-          <a:lstStyle/>
-          <a:p>
-            <a:pPr algn="l"/>
-            <a:r>
-              <a:rPr sz="1300" b="0" i="1">
+          <p:cNvPr id="55" name="TextBox 54"/>
+          <p:cNvSpPr txBox="1"/>
+          <p:nvPr/>
+        </p:nvSpPr>
+        <p:spPr>
+          <a:xfrm>
+            <a:off x="502920" y="6373368"/>
+            <a:ext cx="11155680" cy="292608"/>
+          </a:xfrm>
+          <a:prstGeom prst="rect">
+            <a:avLst/>
+          </a:prstGeom>
+          <a:noFill/>
+        </p:spPr>
+        <p:txBody>
+          <a:bodyPr wrap="square">
+            <a:spAutoFit/>
+          </a:bodyPr>
+          <a:lstStyle/>
+          <a:p>
+            <a:pPr algn="l"/>
+            <a:r>
+              <a:rPr sz="1200" b="1" i="0">
                 <a:solidFill>
                   <a:srgbClr val="004F80"/>
                 </a:solidFill>
               </a:rPr>
-              <a:t>Expected from valid_pct ≈ 42%:  NaN rate ≈ 16% in pretrain  ·  Fine-tune NaN rate may differ (different sample sources / array types)</a:t>
+              <a:t>Key insight:  Fine-tune = pure 450k-array dataset  (29,548 CpGs are 100% NaN across ALL samples → single array type)  ·  Pretrain NaN = 8.69% → mostly EPIC-array samples</a:t>
             </a:r>
           </a:p>
         </p:txBody>
@@ -6105,7 +7091,7 @@
                   <a:srgbClr val="1A263A"/>
                 </a:solidFill>
               </a:rPr>
-              <a:t>Data Investigation Results — Beta Distribution  [PENDING]</a:t>
+              <a:t>Data Investigation Results — β-Value Distribution</a:t>
             </a:r>
           </a:p>
         </p:txBody>
@@ -6139,7 +7125,7 @@
                   <a:srgbClr val="788FA8"/>
                 </a:solidFill>
               </a:rPr>
-              <a:t>Run on cluster:  sbatch scripts/utils/investigate_data.sh</a:t>
+              <a:t>Job 44584079  ·  Valid values only (NaN excluded from all statistics)</a:t>
             </a:r>
           </a:p>
         </p:txBody>
@@ -6189,48 +7175,14 @@
       </p:sp>
       <p:sp>
         <p:nvSpPr>
-          <p:cNvPr id="6" name="TextBox 5"/>
-          <p:cNvSpPr txBox="1"/>
-          <p:nvPr/>
-        </p:nvSpPr>
-        <p:spPr>
-          <a:xfrm>
-            <a:off x="365760" y="1298448"/>
-            <a:ext cx="11475720" cy="384048"/>
-          </a:xfrm>
-          <a:prstGeom prst="rect">
-            <a:avLst/>
-          </a:prstGeom>
-          <a:noFill/>
-        </p:spPr>
-        <p:txBody>
-          <a:bodyPr wrap="square">
-            <a:spAutoFit/>
-          </a:bodyPr>
-          <a:lstStyle/>
-          <a:p>
-            <a:pPr algn="l"/>
-            <a:r>
-              <a:rPr sz="1600" b="1" i="0">
-                <a:solidFill>
-                  <a:srgbClr val="D47E00"/>
-                </a:solidFill>
-              </a:rPr>
-              <a:t>⏳  Results pending — paste percentile output from investigation script</a:t>
-            </a:r>
-          </a:p>
-        </p:txBody>
-      </p:sp>
-      <p:sp>
-        <p:nvSpPr>
-          <p:cNvPr id="7" name="Rectangle 6"/>
+          <p:cNvPr id="6" name="Rectangle 5"/>
           <p:cNvSpPr/>
           <p:nvPr/>
         </p:nvSpPr>
         <p:spPr>
           <a:xfrm>
-            <a:off x="365760" y="1828800"/>
-            <a:ext cx="5577840" cy="4160520"/>
+            <a:off x="365760" y="1261872"/>
+            <a:ext cx="5029200" cy="5120640"/>
           </a:xfrm>
           <a:prstGeom prst="rect">
             <a:avLst/>
@@ -6268,48 +7220,422 @@
       </p:sp>
       <p:sp>
         <p:nvSpPr>
+          <p:cNvPr id="7" name="TextBox 6"/>
+          <p:cNvSpPr txBox="1"/>
+          <p:nvPr/>
+        </p:nvSpPr>
+        <p:spPr>
+          <a:xfrm>
+            <a:off x="502920" y="1353312"/>
+            <a:ext cx="5486400" cy="274320"/>
+          </a:xfrm>
+          <a:prstGeom prst="rect">
+            <a:avLst/>
+          </a:prstGeom>
+          <a:noFill/>
+        </p:spPr>
+        <p:txBody>
+          <a:bodyPr wrap="square">
+            <a:spAutoFit/>
+          </a:bodyPr>
+          <a:lstStyle/>
+          <a:p>
+            <a:pPr algn="l"/>
+            <a:r>
+              <a:rPr sz="1100" b="1" i="0">
+                <a:solidFill>
+                  <a:srgbClr val="007AC2"/>
+                </a:solidFill>
+              </a:rPr>
+              <a:t>PRETRAIN  β-VALUE DISTRIBUTION</a:t>
+            </a:r>
+          </a:p>
+        </p:txBody>
+      </p:sp>
+      <p:sp>
+        <p:nvSpPr>
           <p:cNvPr id="8" name="TextBox 7"/>
           <p:cNvSpPr txBox="1"/>
           <p:nvPr/>
         </p:nvSpPr>
         <p:spPr>
           <a:xfrm>
-            <a:off x="502920" y="1901952"/>
-            <a:ext cx="5486400" cy="274320"/>
-          </a:xfrm>
-          <a:prstGeom prst="rect">
-            <a:avLst/>
-          </a:prstGeom>
-          <a:noFill/>
-        </p:spPr>
-        <p:txBody>
-          <a:bodyPr wrap="square">
-            <a:spAutoFit/>
-          </a:bodyPr>
-          <a:lstStyle/>
-          <a:p>
-            <a:pPr algn="l"/>
-            <a:r>
-              <a:rPr sz="1100" b="1" i="0">
+            <a:off x="502920" y="1627632"/>
+            <a:ext cx="4663440" cy="274320"/>
+          </a:xfrm>
+          <a:prstGeom prst="rect">
+            <a:avLst/>
+          </a:prstGeom>
+          <a:noFill/>
+        </p:spPr>
+        <p:txBody>
+          <a:bodyPr wrap="square">
+            <a:spAutoFit/>
+          </a:bodyPr>
+          <a:lstStyle/>
+          <a:p>
+            <a:pPr algn="l"/>
+            <a:r>
+              <a:rPr sz="1200" b="0" i="1">
+                <a:solidFill>
+                  <a:srgbClr val="788FA8"/>
+                </a:solidFill>
+              </a:rPr>
+              <a:t>7,591,226,333 valid values sampled</a:t>
+            </a:r>
+          </a:p>
+        </p:txBody>
+      </p:sp>
+      <p:sp>
+        <p:nvSpPr>
+          <p:cNvPr id="9" name="TextBox 8"/>
+          <p:cNvSpPr txBox="1"/>
+          <p:nvPr/>
+        </p:nvSpPr>
+        <p:spPr>
+          <a:xfrm>
+            <a:off x="548640" y="1938528"/>
+            <a:ext cx="1828800" cy="365760"/>
+          </a:xfrm>
+          <a:prstGeom prst="rect">
+            <a:avLst/>
+          </a:prstGeom>
+          <a:noFill/>
+        </p:spPr>
+        <p:txBody>
+          <a:bodyPr wrap="square">
+            <a:spAutoFit/>
+          </a:bodyPr>
+          <a:lstStyle/>
+          <a:p>
+            <a:pPr algn="l"/>
+            <a:r>
+              <a:rPr sz="1300" b="0" i="0">
+                <a:solidFill>
+                  <a:srgbClr val="788FA8"/>
+                </a:solidFill>
+              </a:rPr>
+              <a:t>0%   (min)</a:t>
+            </a:r>
+          </a:p>
+        </p:txBody>
+      </p:sp>
+      <p:sp>
+        <p:nvSpPr>
+          <p:cNvPr id="10" name="TextBox 9"/>
+          <p:cNvSpPr txBox="1"/>
+          <p:nvPr/>
+        </p:nvSpPr>
+        <p:spPr>
+          <a:xfrm>
+            <a:off x="2423160" y="1938528"/>
+            <a:ext cx="1371600" cy="365760"/>
+          </a:xfrm>
+          <a:prstGeom prst="rect">
+            <a:avLst/>
+          </a:prstGeom>
+          <a:noFill/>
+        </p:spPr>
+        <p:txBody>
+          <a:bodyPr wrap="square">
+            <a:spAutoFit/>
+          </a:bodyPr>
+          <a:lstStyle/>
+          <a:p>
+            <a:pPr algn="l"/>
+            <a:r>
+              <a:rPr sz="1400" b="1" i="0">
+                <a:solidFill>
+                  <a:srgbClr val="C03030"/>
+                </a:solidFill>
+              </a:rPr>
+              <a:t>-0.3389</a:t>
+            </a:r>
+          </a:p>
+        </p:txBody>
+      </p:sp>
+      <p:sp>
+        <p:nvSpPr>
+          <p:cNvPr id="11" name="TextBox 10"/>
+          <p:cNvSpPr txBox="1"/>
+          <p:nvPr/>
+        </p:nvSpPr>
+        <p:spPr>
+          <a:xfrm>
+            <a:off x="548640" y="2414016"/>
+            <a:ext cx="1828800" cy="365760"/>
+          </a:xfrm>
+          <a:prstGeom prst="rect">
+            <a:avLst/>
+          </a:prstGeom>
+          <a:noFill/>
+        </p:spPr>
+        <p:txBody>
+          <a:bodyPr wrap="square">
+            <a:spAutoFit/>
+          </a:bodyPr>
+          <a:lstStyle/>
+          <a:p>
+            <a:pPr algn="l"/>
+            <a:r>
+              <a:rPr sz="1300" b="0" i="0">
+                <a:solidFill>
+                  <a:srgbClr val="788FA8"/>
+                </a:solidFill>
+              </a:rPr>
+              <a:t>1%</a:t>
+            </a:r>
+          </a:p>
+        </p:txBody>
+      </p:sp>
+      <p:sp>
+        <p:nvSpPr>
+          <p:cNvPr id="12" name="TextBox 11"/>
+          <p:cNvSpPr txBox="1"/>
+          <p:nvPr/>
+        </p:nvSpPr>
+        <p:spPr>
+          <a:xfrm>
+            <a:off x="2423160" y="2414016"/>
+            <a:ext cx="1371600" cy="365760"/>
+          </a:xfrm>
+          <a:prstGeom prst="rect">
+            <a:avLst/>
+          </a:prstGeom>
+          <a:noFill/>
+        </p:spPr>
+        <p:txBody>
+          <a:bodyPr wrap="square">
+            <a:spAutoFit/>
+          </a:bodyPr>
+          <a:lstStyle/>
+          <a:p>
+            <a:pPr algn="l"/>
+            <a:r>
+              <a:rPr sz="1400" b="1" i="0">
+                <a:solidFill>
+                  <a:srgbClr val="3A4A5C"/>
+                </a:solidFill>
+              </a:rPr>
+              <a:t> 0.0100</a:t>
+            </a:r>
+          </a:p>
+        </p:txBody>
+      </p:sp>
+      <p:sp>
+        <p:nvSpPr>
+          <p:cNvPr id="13" name="TextBox 12"/>
+          <p:cNvSpPr txBox="1"/>
+          <p:nvPr/>
+        </p:nvSpPr>
+        <p:spPr>
+          <a:xfrm>
+            <a:off x="548640" y="2889504"/>
+            <a:ext cx="1828800" cy="365760"/>
+          </a:xfrm>
+          <a:prstGeom prst="rect">
+            <a:avLst/>
+          </a:prstGeom>
+          <a:noFill/>
+        </p:spPr>
+        <p:txBody>
+          <a:bodyPr wrap="square">
+            <a:spAutoFit/>
+          </a:bodyPr>
+          <a:lstStyle/>
+          <a:p>
+            <a:pPr algn="l"/>
+            <a:r>
+              <a:rPr sz="1300" b="0" i="0">
+                <a:solidFill>
+                  <a:srgbClr val="788FA8"/>
+                </a:solidFill>
+              </a:rPr>
+              <a:t>5%</a:t>
+            </a:r>
+          </a:p>
+        </p:txBody>
+      </p:sp>
+      <p:sp>
+        <p:nvSpPr>
+          <p:cNvPr id="14" name="TextBox 13"/>
+          <p:cNvSpPr txBox="1"/>
+          <p:nvPr/>
+        </p:nvSpPr>
+        <p:spPr>
+          <a:xfrm>
+            <a:off x="2423160" y="2889504"/>
+            <a:ext cx="1371600" cy="365760"/>
+          </a:xfrm>
+          <a:prstGeom prst="rect">
+            <a:avLst/>
+          </a:prstGeom>
+          <a:noFill/>
+        </p:spPr>
+        <p:txBody>
+          <a:bodyPr wrap="square">
+            <a:spAutoFit/>
+          </a:bodyPr>
+          <a:lstStyle/>
+          <a:p>
+            <a:pPr algn="l"/>
+            <a:r>
+              <a:rPr sz="1400" b="1" i="0">
+                <a:solidFill>
+                  <a:srgbClr val="3A4A5C"/>
+                </a:solidFill>
+              </a:rPr>
+              <a:t> 0.0236</a:t>
+            </a:r>
+          </a:p>
+        </p:txBody>
+      </p:sp>
+      <p:sp>
+        <p:nvSpPr>
+          <p:cNvPr id="15" name="TextBox 14"/>
+          <p:cNvSpPr txBox="1"/>
+          <p:nvPr/>
+        </p:nvSpPr>
+        <p:spPr>
+          <a:xfrm>
+            <a:off x="548640" y="3364992"/>
+            <a:ext cx="1828800" cy="365760"/>
+          </a:xfrm>
+          <a:prstGeom prst="rect">
+            <a:avLst/>
+          </a:prstGeom>
+          <a:noFill/>
+        </p:spPr>
+        <p:txBody>
+          <a:bodyPr wrap="square">
+            <a:spAutoFit/>
+          </a:bodyPr>
+          <a:lstStyle/>
+          <a:p>
+            <a:pPr algn="l"/>
+            <a:r>
+              <a:rPr sz="1300" b="0" i="0">
+                <a:solidFill>
+                  <a:srgbClr val="788FA8"/>
+                </a:solidFill>
+              </a:rPr>
+              <a:t>25%</a:t>
+            </a:r>
+          </a:p>
+        </p:txBody>
+      </p:sp>
+      <p:sp>
+        <p:nvSpPr>
+          <p:cNvPr id="16" name="TextBox 15"/>
+          <p:cNvSpPr txBox="1"/>
+          <p:nvPr/>
+        </p:nvSpPr>
+        <p:spPr>
+          <a:xfrm>
+            <a:off x="2423160" y="3364992"/>
+            <a:ext cx="1371600" cy="365760"/>
+          </a:xfrm>
+          <a:prstGeom prst="rect">
+            <a:avLst/>
+          </a:prstGeom>
+          <a:noFill/>
+        </p:spPr>
+        <p:txBody>
+          <a:bodyPr wrap="square">
+            <a:spAutoFit/>
+          </a:bodyPr>
+          <a:lstStyle/>
+          <a:p>
+            <a:pPr algn="l"/>
+            <a:r>
+              <a:rPr sz="1400" b="1" i="0">
+                <a:solidFill>
+                  <a:srgbClr val="3A4A5C"/>
+                </a:solidFill>
+              </a:rPr>
+              <a:t> 0.0700</a:t>
+            </a:r>
+          </a:p>
+        </p:txBody>
+      </p:sp>
+      <p:sp>
+        <p:nvSpPr>
+          <p:cNvPr id="17" name="TextBox 16"/>
+          <p:cNvSpPr txBox="1"/>
+          <p:nvPr/>
+        </p:nvSpPr>
+        <p:spPr>
+          <a:xfrm>
+            <a:off x="548640" y="3840480"/>
+            <a:ext cx="1828800" cy="365760"/>
+          </a:xfrm>
+          <a:prstGeom prst="rect">
+            <a:avLst/>
+          </a:prstGeom>
+          <a:noFill/>
+        </p:spPr>
+        <p:txBody>
+          <a:bodyPr wrap="square">
+            <a:spAutoFit/>
+          </a:bodyPr>
+          <a:lstStyle/>
+          <a:p>
+            <a:pPr algn="l"/>
+            <a:r>
+              <a:rPr sz="1300" b="0" i="0">
+                <a:solidFill>
+                  <a:srgbClr val="788FA8"/>
+                </a:solidFill>
+              </a:rPr>
+              <a:t>50%  (median)</a:t>
+            </a:r>
+          </a:p>
+        </p:txBody>
+      </p:sp>
+      <p:sp>
+        <p:nvSpPr>
+          <p:cNvPr id="18" name="TextBox 17"/>
+          <p:cNvSpPr txBox="1"/>
+          <p:nvPr/>
+        </p:nvSpPr>
+        <p:spPr>
+          <a:xfrm>
+            <a:off x="2423160" y="3840480"/>
+            <a:ext cx="1371600" cy="365760"/>
+          </a:xfrm>
+          <a:prstGeom prst="rect">
+            <a:avLst/>
+          </a:prstGeom>
+          <a:noFill/>
+        </p:spPr>
+        <p:txBody>
+          <a:bodyPr wrap="square">
+            <a:spAutoFit/>
+          </a:bodyPr>
+          <a:lstStyle/>
+          <a:p>
+            <a:pPr algn="l"/>
+            <a:r>
+              <a:rPr sz="1400" b="1" i="0">
                 <a:solidFill>
                   <a:srgbClr val="007AC2"/>
                 </a:solidFill>
               </a:rPr>
-              <a:t>PRETRAIN β-VALUE DISTRIBUTION</a:t>
-            </a:r>
-          </a:p>
-        </p:txBody>
-      </p:sp>
-      <p:sp>
-        <p:nvSpPr>
-          <p:cNvPr id="9" name="TextBox 8"/>
-          <p:cNvSpPr txBox="1"/>
-          <p:nvPr/>
-        </p:nvSpPr>
-        <p:spPr>
-          <a:xfrm>
-            <a:off x="548640" y="2359152"/>
-            <a:ext cx="2011680" cy="320040"/>
+              <a:t> 0.2860</a:t>
+            </a:r>
+          </a:p>
+        </p:txBody>
+      </p:sp>
+      <p:sp>
+        <p:nvSpPr>
+          <p:cNvPr id="19" name="TextBox 18"/>
+          <p:cNvSpPr txBox="1"/>
+          <p:nvPr/>
+        </p:nvSpPr>
+        <p:spPr>
+          <a:xfrm>
+            <a:off x="548640" y="4315968"/>
+            <a:ext cx="1828800" cy="365760"/>
           </a:xfrm>
           <a:prstGeom prst="rect">
             <a:avLst/>
@@ -6329,55 +7655,55 @@
                   <a:srgbClr val="788FA8"/>
                 </a:solidFill>
               </a:rPr>
-              <a:t>0% (min)</a:t>
-            </a:r>
-          </a:p>
-        </p:txBody>
-      </p:sp>
-      <p:sp>
-        <p:nvSpPr>
-          <p:cNvPr id="10" name="TextBox 9"/>
-          <p:cNvSpPr txBox="1"/>
-          <p:nvPr/>
-        </p:nvSpPr>
-        <p:spPr>
-          <a:xfrm>
-            <a:off x="2606040" y="2359152"/>
-            <a:ext cx="1645920" cy="320040"/>
-          </a:xfrm>
-          <a:prstGeom prst="rect">
-            <a:avLst/>
-          </a:prstGeom>
-          <a:noFill/>
-        </p:spPr>
-        <p:txBody>
-          <a:bodyPr wrap="square">
-            <a:spAutoFit/>
-          </a:bodyPr>
-          <a:lstStyle/>
-          <a:p>
-            <a:pPr algn="l"/>
-            <a:r>
-              <a:rPr sz="1300" b="1" i="0">
+              <a:t>75%</a:t>
+            </a:r>
+          </a:p>
+        </p:txBody>
+      </p:sp>
+      <p:sp>
+        <p:nvSpPr>
+          <p:cNvPr id="20" name="TextBox 19"/>
+          <p:cNvSpPr txBox="1"/>
+          <p:nvPr/>
+        </p:nvSpPr>
+        <p:spPr>
+          <a:xfrm>
+            <a:off x="2423160" y="4315968"/>
+            <a:ext cx="1371600" cy="365760"/>
+          </a:xfrm>
+          <a:prstGeom prst="rect">
+            <a:avLst/>
+          </a:prstGeom>
+          <a:noFill/>
+        </p:spPr>
+        <p:txBody>
+          <a:bodyPr wrap="square">
+            <a:spAutoFit/>
+          </a:bodyPr>
+          <a:lstStyle/>
+          <a:p>
+            <a:pPr algn="l"/>
+            <a:r>
+              <a:rPr sz="1400" b="1" i="0">
                 <a:solidFill>
                   <a:srgbClr val="3A4A5C"/>
                 </a:solidFill>
               </a:rPr>
-              <a:t>[ TBD ]</a:t>
-            </a:r>
-          </a:p>
-        </p:txBody>
-      </p:sp>
-      <p:sp>
-        <p:nvSpPr>
-          <p:cNvPr id="11" name="TextBox 10"/>
-          <p:cNvSpPr txBox="1"/>
-          <p:nvPr/>
-        </p:nvSpPr>
-        <p:spPr>
-          <a:xfrm>
-            <a:off x="548640" y="2706624"/>
-            <a:ext cx="2011680" cy="320040"/>
+              <a:t> 0.6679</a:t>
+            </a:r>
+          </a:p>
+        </p:txBody>
+      </p:sp>
+      <p:sp>
+        <p:nvSpPr>
+          <p:cNvPr id="21" name="TextBox 20"/>
+          <p:cNvSpPr txBox="1"/>
+          <p:nvPr/>
+        </p:nvSpPr>
+        <p:spPr>
+          <a:xfrm>
+            <a:off x="548640" y="4791456"/>
+            <a:ext cx="1828800" cy="365760"/>
           </a:xfrm>
           <a:prstGeom prst="rect">
             <a:avLst/>
@@ -6397,55 +7723,55 @@
                   <a:srgbClr val="788FA8"/>
                 </a:solidFill>
               </a:rPr>
-              <a:t>1%</a:t>
-            </a:r>
-          </a:p>
-        </p:txBody>
-      </p:sp>
-      <p:sp>
-        <p:nvSpPr>
-          <p:cNvPr id="12" name="TextBox 11"/>
-          <p:cNvSpPr txBox="1"/>
-          <p:nvPr/>
-        </p:nvSpPr>
-        <p:spPr>
-          <a:xfrm>
-            <a:off x="2606040" y="2706624"/>
-            <a:ext cx="1645920" cy="320040"/>
-          </a:xfrm>
-          <a:prstGeom prst="rect">
-            <a:avLst/>
-          </a:prstGeom>
-          <a:noFill/>
-        </p:spPr>
-        <p:txBody>
-          <a:bodyPr wrap="square">
-            <a:spAutoFit/>
-          </a:bodyPr>
-          <a:lstStyle/>
-          <a:p>
-            <a:pPr algn="l"/>
-            <a:r>
-              <a:rPr sz="1300" b="1" i="0">
+              <a:t>95%</a:t>
+            </a:r>
+          </a:p>
+        </p:txBody>
+      </p:sp>
+      <p:sp>
+        <p:nvSpPr>
+          <p:cNvPr id="22" name="TextBox 21"/>
+          <p:cNvSpPr txBox="1"/>
+          <p:nvPr/>
+        </p:nvSpPr>
+        <p:spPr>
+          <a:xfrm>
+            <a:off x="2423160" y="4791456"/>
+            <a:ext cx="1371600" cy="365760"/>
+          </a:xfrm>
+          <a:prstGeom prst="rect">
+            <a:avLst/>
+          </a:prstGeom>
+          <a:noFill/>
+        </p:spPr>
+        <p:txBody>
+          <a:bodyPr wrap="square">
+            <a:spAutoFit/>
+          </a:bodyPr>
+          <a:lstStyle/>
+          <a:p>
+            <a:pPr algn="l"/>
+            <a:r>
+              <a:rPr sz="1400" b="1" i="0">
                 <a:solidFill>
                   <a:srgbClr val="3A4A5C"/>
                 </a:solidFill>
               </a:rPr>
-              <a:t>[ TBD ]</a:t>
-            </a:r>
-          </a:p>
-        </p:txBody>
-      </p:sp>
-      <p:sp>
-        <p:nvSpPr>
-          <p:cNvPr id="13" name="TextBox 12"/>
-          <p:cNvSpPr txBox="1"/>
-          <p:nvPr/>
-        </p:nvSpPr>
-        <p:spPr>
-          <a:xfrm>
-            <a:off x="548640" y="3054096"/>
-            <a:ext cx="2011680" cy="320040"/>
+              <a:t> 0.9134</a:t>
+            </a:r>
+          </a:p>
+        </p:txBody>
+      </p:sp>
+      <p:sp>
+        <p:nvSpPr>
+          <p:cNvPr id="23" name="TextBox 22"/>
+          <p:cNvSpPr txBox="1"/>
+          <p:nvPr/>
+        </p:nvSpPr>
+        <p:spPr>
+          <a:xfrm>
+            <a:off x="548640" y="5266944"/>
+            <a:ext cx="1828800" cy="365760"/>
           </a:xfrm>
           <a:prstGeom prst="rect">
             <a:avLst/>
@@ -6465,55 +7791,55 @@
                   <a:srgbClr val="788FA8"/>
                 </a:solidFill>
               </a:rPr>
-              <a:t>5%</a:t>
-            </a:r>
-          </a:p>
-        </p:txBody>
-      </p:sp>
-      <p:sp>
-        <p:nvSpPr>
-          <p:cNvPr id="14" name="TextBox 13"/>
-          <p:cNvSpPr txBox="1"/>
-          <p:nvPr/>
-        </p:nvSpPr>
-        <p:spPr>
-          <a:xfrm>
-            <a:off x="2606040" y="3054096"/>
-            <a:ext cx="1645920" cy="320040"/>
-          </a:xfrm>
-          <a:prstGeom prst="rect">
-            <a:avLst/>
-          </a:prstGeom>
-          <a:noFill/>
-        </p:spPr>
-        <p:txBody>
-          <a:bodyPr wrap="square">
-            <a:spAutoFit/>
-          </a:bodyPr>
-          <a:lstStyle/>
-          <a:p>
-            <a:pPr algn="l"/>
-            <a:r>
-              <a:rPr sz="1300" b="1" i="0">
+              <a:t>99%</a:t>
+            </a:r>
+          </a:p>
+        </p:txBody>
+      </p:sp>
+      <p:sp>
+        <p:nvSpPr>
+          <p:cNvPr id="24" name="TextBox 23"/>
+          <p:cNvSpPr txBox="1"/>
+          <p:nvPr/>
+        </p:nvSpPr>
+        <p:spPr>
+          <a:xfrm>
+            <a:off x="2423160" y="5266944"/>
+            <a:ext cx="1371600" cy="365760"/>
+          </a:xfrm>
+          <a:prstGeom prst="rect">
+            <a:avLst/>
+          </a:prstGeom>
+          <a:noFill/>
+        </p:spPr>
+        <p:txBody>
+          <a:bodyPr wrap="square">
+            <a:spAutoFit/>
+          </a:bodyPr>
+          <a:lstStyle/>
+          <a:p>
+            <a:pPr algn="l"/>
+            <a:r>
+              <a:rPr sz="1400" b="1" i="0">
                 <a:solidFill>
                   <a:srgbClr val="3A4A5C"/>
                 </a:solidFill>
               </a:rPr>
-              <a:t>[ TBD ]</a:t>
-            </a:r>
-          </a:p>
-        </p:txBody>
-      </p:sp>
-      <p:sp>
-        <p:nvSpPr>
-          <p:cNvPr id="15" name="TextBox 14"/>
-          <p:cNvSpPr txBox="1"/>
-          <p:nvPr/>
-        </p:nvSpPr>
-        <p:spPr>
-          <a:xfrm>
-            <a:off x="548640" y="3401568"/>
-            <a:ext cx="2011680" cy="320040"/>
+              <a:t> 0.9620</a:t>
+            </a:r>
+          </a:p>
+        </p:txBody>
+      </p:sp>
+      <p:sp>
+        <p:nvSpPr>
+          <p:cNvPr id="25" name="TextBox 24"/>
+          <p:cNvSpPr txBox="1"/>
+          <p:nvPr/>
+        </p:nvSpPr>
+        <p:spPr>
+          <a:xfrm>
+            <a:off x="548640" y="5742432"/>
+            <a:ext cx="1828800" cy="365760"/>
           </a:xfrm>
           <a:prstGeom prst="rect">
             <a:avLst/>
@@ -6533,346 +7859,6 @@
                   <a:srgbClr val="788FA8"/>
                 </a:solidFill>
               </a:rPr>
-              <a:t>25%</a:t>
-            </a:r>
-          </a:p>
-        </p:txBody>
-      </p:sp>
-      <p:sp>
-        <p:nvSpPr>
-          <p:cNvPr id="16" name="TextBox 15"/>
-          <p:cNvSpPr txBox="1"/>
-          <p:nvPr/>
-        </p:nvSpPr>
-        <p:spPr>
-          <a:xfrm>
-            <a:off x="2606040" y="3401568"/>
-            <a:ext cx="1645920" cy="320040"/>
-          </a:xfrm>
-          <a:prstGeom prst="rect">
-            <a:avLst/>
-          </a:prstGeom>
-          <a:noFill/>
-        </p:spPr>
-        <p:txBody>
-          <a:bodyPr wrap="square">
-            <a:spAutoFit/>
-          </a:bodyPr>
-          <a:lstStyle/>
-          <a:p>
-            <a:pPr algn="l"/>
-            <a:r>
-              <a:rPr sz="1300" b="1" i="0">
-                <a:solidFill>
-                  <a:srgbClr val="3A4A5C"/>
-                </a:solidFill>
-              </a:rPr>
-              <a:t>[ TBD ]</a:t>
-            </a:r>
-          </a:p>
-        </p:txBody>
-      </p:sp>
-      <p:sp>
-        <p:nvSpPr>
-          <p:cNvPr id="17" name="TextBox 16"/>
-          <p:cNvSpPr txBox="1"/>
-          <p:nvPr/>
-        </p:nvSpPr>
-        <p:spPr>
-          <a:xfrm>
-            <a:off x="548640" y="3749039"/>
-            <a:ext cx="2011680" cy="320040"/>
-          </a:xfrm>
-          <a:prstGeom prst="rect">
-            <a:avLst/>
-          </a:prstGeom>
-          <a:noFill/>
-        </p:spPr>
-        <p:txBody>
-          <a:bodyPr wrap="square">
-            <a:spAutoFit/>
-          </a:bodyPr>
-          <a:lstStyle/>
-          <a:p>
-            <a:pPr algn="l"/>
-            <a:r>
-              <a:rPr sz="1300" b="0" i="0">
-                <a:solidFill>
-                  <a:srgbClr val="788FA8"/>
-                </a:solidFill>
-              </a:rPr>
-              <a:t>50% (median)</a:t>
-            </a:r>
-          </a:p>
-        </p:txBody>
-      </p:sp>
-      <p:sp>
-        <p:nvSpPr>
-          <p:cNvPr id="18" name="TextBox 17"/>
-          <p:cNvSpPr txBox="1"/>
-          <p:nvPr/>
-        </p:nvSpPr>
-        <p:spPr>
-          <a:xfrm>
-            <a:off x="2606040" y="3749039"/>
-            <a:ext cx="1645920" cy="320040"/>
-          </a:xfrm>
-          <a:prstGeom prst="rect">
-            <a:avLst/>
-          </a:prstGeom>
-          <a:noFill/>
-        </p:spPr>
-        <p:txBody>
-          <a:bodyPr wrap="square">
-            <a:spAutoFit/>
-          </a:bodyPr>
-          <a:lstStyle/>
-          <a:p>
-            <a:pPr algn="l"/>
-            <a:r>
-              <a:rPr sz="1300" b="1" i="0">
-                <a:solidFill>
-                  <a:srgbClr val="3A4A5C"/>
-                </a:solidFill>
-              </a:rPr>
-              <a:t>[ TBD ]</a:t>
-            </a:r>
-          </a:p>
-        </p:txBody>
-      </p:sp>
-      <p:sp>
-        <p:nvSpPr>
-          <p:cNvPr id="19" name="TextBox 18"/>
-          <p:cNvSpPr txBox="1"/>
-          <p:nvPr/>
-        </p:nvSpPr>
-        <p:spPr>
-          <a:xfrm>
-            <a:off x="548640" y="4096512"/>
-            <a:ext cx="2011680" cy="320040"/>
-          </a:xfrm>
-          <a:prstGeom prst="rect">
-            <a:avLst/>
-          </a:prstGeom>
-          <a:noFill/>
-        </p:spPr>
-        <p:txBody>
-          <a:bodyPr wrap="square">
-            <a:spAutoFit/>
-          </a:bodyPr>
-          <a:lstStyle/>
-          <a:p>
-            <a:pPr algn="l"/>
-            <a:r>
-              <a:rPr sz="1300" b="0" i="0">
-                <a:solidFill>
-                  <a:srgbClr val="788FA8"/>
-                </a:solidFill>
-              </a:rPr>
-              <a:t>75%</a:t>
-            </a:r>
-          </a:p>
-        </p:txBody>
-      </p:sp>
-      <p:sp>
-        <p:nvSpPr>
-          <p:cNvPr id="20" name="TextBox 19"/>
-          <p:cNvSpPr txBox="1"/>
-          <p:nvPr/>
-        </p:nvSpPr>
-        <p:spPr>
-          <a:xfrm>
-            <a:off x="2606040" y="4096512"/>
-            <a:ext cx="1645920" cy="320040"/>
-          </a:xfrm>
-          <a:prstGeom prst="rect">
-            <a:avLst/>
-          </a:prstGeom>
-          <a:noFill/>
-        </p:spPr>
-        <p:txBody>
-          <a:bodyPr wrap="square">
-            <a:spAutoFit/>
-          </a:bodyPr>
-          <a:lstStyle/>
-          <a:p>
-            <a:pPr algn="l"/>
-            <a:r>
-              <a:rPr sz="1300" b="1" i="0">
-                <a:solidFill>
-                  <a:srgbClr val="3A4A5C"/>
-                </a:solidFill>
-              </a:rPr>
-              <a:t>[ TBD ]</a:t>
-            </a:r>
-          </a:p>
-        </p:txBody>
-      </p:sp>
-      <p:sp>
-        <p:nvSpPr>
-          <p:cNvPr id="21" name="TextBox 20"/>
-          <p:cNvSpPr txBox="1"/>
-          <p:nvPr/>
-        </p:nvSpPr>
-        <p:spPr>
-          <a:xfrm>
-            <a:off x="548640" y="4443984"/>
-            <a:ext cx="2011680" cy="320040"/>
-          </a:xfrm>
-          <a:prstGeom prst="rect">
-            <a:avLst/>
-          </a:prstGeom>
-          <a:noFill/>
-        </p:spPr>
-        <p:txBody>
-          <a:bodyPr wrap="square">
-            <a:spAutoFit/>
-          </a:bodyPr>
-          <a:lstStyle/>
-          <a:p>
-            <a:pPr algn="l"/>
-            <a:r>
-              <a:rPr sz="1300" b="0" i="0">
-                <a:solidFill>
-                  <a:srgbClr val="788FA8"/>
-                </a:solidFill>
-              </a:rPr>
-              <a:t>95%</a:t>
-            </a:r>
-          </a:p>
-        </p:txBody>
-      </p:sp>
-      <p:sp>
-        <p:nvSpPr>
-          <p:cNvPr id="22" name="TextBox 21"/>
-          <p:cNvSpPr txBox="1"/>
-          <p:nvPr/>
-        </p:nvSpPr>
-        <p:spPr>
-          <a:xfrm>
-            <a:off x="2606040" y="4443984"/>
-            <a:ext cx="1645920" cy="320040"/>
-          </a:xfrm>
-          <a:prstGeom prst="rect">
-            <a:avLst/>
-          </a:prstGeom>
-          <a:noFill/>
-        </p:spPr>
-        <p:txBody>
-          <a:bodyPr wrap="square">
-            <a:spAutoFit/>
-          </a:bodyPr>
-          <a:lstStyle/>
-          <a:p>
-            <a:pPr algn="l"/>
-            <a:r>
-              <a:rPr sz="1300" b="1" i="0">
-                <a:solidFill>
-                  <a:srgbClr val="3A4A5C"/>
-                </a:solidFill>
-              </a:rPr>
-              <a:t>[ TBD ]</a:t>
-            </a:r>
-          </a:p>
-        </p:txBody>
-      </p:sp>
-      <p:sp>
-        <p:nvSpPr>
-          <p:cNvPr id="23" name="TextBox 22"/>
-          <p:cNvSpPr txBox="1"/>
-          <p:nvPr/>
-        </p:nvSpPr>
-        <p:spPr>
-          <a:xfrm>
-            <a:off x="548640" y="4791456"/>
-            <a:ext cx="2011680" cy="320040"/>
-          </a:xfrm>
-          <a:prstGeom prst="rect">
-            <a:avLst/>
-          </a:prstGeom>
-          <a:noFill/>
-        </p:spPr>
-        <p:txBody>
-          <a:bodyPr wrap="square">
-            <a:spAutoFit/>
-          </a:bodyPr>
-          <a:lstStyle/>
-          <a:p>
-            <a:pPr algn="l"/>
-            <a:r>
-              <a:rPr sz="1300" b="0" i="0">
-                <a:solidFill>
-                  <a:srgbClr val="788FA8"/>
-                </a:solidFill>
-              </a:rPr>
-              <a:t>99%</a:t>
-            </a:r>
-          </a:p>
-        </p:txBody>
-      </p:sp>
-      <p:sp>
-        <p:nvSpPr>
-          <p:cNvPr id="24" name="TextBox 23"/>
-          <p:cNvSpPr txBox="1"/>
-          <p:nvPr/>
-        </p:nvSpPr>
-        <p:spPr>
-          <a:xfrm>
-            <a:off x="2606040" y="4791456"/>
-            <a:ext cx="1645920" cy="320040"/>
-          </a:xfrm>
-          <a:prstGeom prst="rect">
-            <a:avLst/>
-          </a:prstGeom>
-          <a:noFill/>
-        </p:spPr>
-        <p:txBody>
-          <a:bodyPr wrap="square">
-            <a:spAutoFit/>
-          </a:bodyPr>
-          <a:lstStyle/>
-          <a:p>
-            <a:pPr algn="l"/>
-            <a:r>
-              <a:rPr sz="1300" b="1" i="0">
-                <a:solidFill>
-                  <a:srgbClr val="3A4A5C"/>
-                </a:solidFill>
-              </a:rPr>
-              <a:t>[ TBD ]</a:t>
-            </a:r>
-          </a:p>
-        </p:txBody>
-      </p:sp>
-      <p:sp>
-        <p:nvSpPr>
-          <p:cNvPr id="25" name="TextBox 24"/>
-          <p:cNvSpPr txBox="1"/>
-          <p:nvPr/>
-        </p:nvSpPr>
-        <p:spPr>
-          <a:xfrm>
-            <a:off x="548640" y="5138928"/>
-            <a:ext cx="2011680" cy="320040"/>
-          </a:xfrm>
-          <a:prstGeom prst="rect">
-            <a:avLst/>
-          </a:prstGeom>
-          <a:noFill/>
-        </p:spPr>
-        <p:txBody>
-          <a:bodyPr wrap="square">
-            <a:spAutoFit/>
-          </a:bodyPr>
-          <a:lstStyle/>
-          <a:p>
-            <a:pPr algn="l"/>
-            <a:r>
-              <a:rPr sz="1300" b="0" i="0">
-                <a:solidFill>
-                  <a:srgbClr val="788FA8"/>
-                </a:solidFill>
-              </a:rPr>
               <a:t>100% (max)</a:t>
             </a:r>
           </a:p>
@@ -6886,28 +7872,28 @@
         </p:nvSpPr>
         <p:spPr>
           <a:xfrm>
-            <a:off x="2606040" y="5138928"/>
-            <a:ext cx="1645920" cy="320040"/>
-          </a:xfrm>
-          <a:prstGeom prst="rect">
-            <a:avLst/>
-          </a:prstGeom>
-          <a:noFill/>
-        </p:spPr>
-        <p:txBody>
-          <a:bodyPr wrap="square">
-            <a:spAutoFit/>
-          </a:bodyPr>
-          <a:lstStyle/>
-          <a:p>
-            <a:pPr algn="l"/>
-            <a:r>
-              <a:rPr sz="1300" b="1" i="0">
-                <a:solidFill>
-                  <a:srgbClr val="3A4A5C"/>
-                </a:solidFill>
-              </a:rPr>
-              <a:t>[ TBD ]</a:t>
+            <a:off x="2423160" y="5742432"/>
+            <a:ext cx="1371600" cy="365760"/>
+          </a:xfrm>
+          <a:prstGeom prst="rect">
+            <a:avLst/>
+          </a:prstGeom>
+          <a:noFill/>
+        </p:spPr>
+        <p:txBody>
+          <a:bodyPr wrap="square">
+            <a:spAutoFit/>
+          </a:bodyPr>
+          <a:lstStyle/>
+          <a:p>
+            <a:pPr algn="l"/>
+            <a:r>
+              <a:rPr sz="1400" b="1" i="0">
+                <a:solidFill>
+                  <a:srgbClr val="D47E00"/>
+                </a:solidFill>
+              </a:rPr>
+              <a:t> 1.1030</a:t>
             </a:r>
           </a:p>
         </p:txBody>
@@ -6920,8 +7906,87 @@
         </p:nvSpPr>
         <p:spPr>
           <a:xfrm>
-            <a:off x="6400800" y="1828800"/>
-            <a:ext cx="5394960" cy="4160520"/>
+            <a:off x="365760" y="6291072"/>
+            <a:ext cx="5029200" cy="384048"/>
+          </a:xfrm>
+          <a:prstGeom prst="rect">
+            <a:avLst/>
+          </a:prstGeom>
+          <a:solidFill>
+            <a:srgbClr val="FDEAC8"/>
+          </a:solidFill>
+          <a:ln w="12700">
+            <a:solidFill>
+              <a:srgbClr val="D47E00"/>
+            </a:solidFill>
+          </a:ln>
+        </p:spPr>
+        <p:style>
+          <a:lnRef idx="1">
+            <a:schemeClr val="accent1"/>
+          </a:lnRef>
+          <a:fillRef idx="3">
+            <a:schemeClr val="accent1"/>
+          </a:fillRef>
+          <a:effectRef idx="2">
+            <a:schemeClr val="accent1"/>
+          </a:effectRef>
+          <a:fontRef idx="minor">
+            <a:schemeClr val="lt1"/>
+          </a:fontRef>
+        </p:style>
+        <p:txBody>
+          <a:bodyPr rtlCol="0" anchor="ctr"/>
+          <a:lstStyle/>
+          <a:p>
+            <a:pPr algn="ctr"/>
+          </a:p>
+        </p:txBody>
+      </p:sp>
+      <p:sp>
+        <p:nvSpPr>
+          <p:cNvPr id="28" name="TextBox 27"/>
+          <p:cNvSpPr txBox="1"/>
+          <p:nvPr/>
+        </p:nvSpPr>
+        <p:spPr>
+          <a:xfrm>
+            <a:off x="502920" y="6336792"/>
+            <a:ext cx="4754880" cy="292608"/>
+          </a:xfrm>
+          <a:prstGeom prst="rect">
+            <a:avLst/>
+          </a:prstGeom>
+          <a:noFill/>
+        </p:spPr>
+        <p:txBody>
+          <a:bodyPr wrap="square">
+            <a:spAutoFit/>
+          </a:bodyPr>
+          <a:lstStyle/>
+          <a:p>
+            <a:pPr algn="l"/>
+            <a:r>
+              <a:rPr sz="1200" b="0" i="0">
+                <a:solidFill>
+                  <a:srgbClr val="9A5A00"/>
+                </a:solidFill>
+              </a:rPr>
+              <a:t>Out-of-range β &lt; 0 or β &gt; 1:  248,776 values  ⚠  (raw Illumina noise — not a bug)</a:t>
+            </a:r>
+          </a:p>
+        </p:txBody>
+      </p:sp>
+      <p:sp>
+        <p:nvSpPr>
+          <p:cNvPr id="29" name="Rectangle 28"/>
+          <p:cNvSpPr/>
+          <p:nvPr/>
+        </p:nvSpPr>
+        <p:spPr>
+          <a:xfrm>
+            <a:off x="5669280" y="1261872"/>
+            <a:ext cx="5029200" cy="5120640"/>
           </a:xfrm>
           <a:prstGeom prst="rect">
             <a:avLst/>
@@ -6959,13 +8024,13 @@
       </p:sp>
       <p:sp>
         <p:nvSpPr>
-          <p:cNvPr id="28" name="TextBox 27"/>
-          <p:cNvSpPr txBox="1"/>
-          <p:nvPr/>
-        </p:nvSpPr>
-        <p:spPr>
-          <a:xfrm>
-            <a:off x="6537960" y="1901952"/>
+          <p:cNvPr id="30" name="TextBox 29"/>
+          <p:cNvSpPr txBox="1"/>
+          <p:nvPr/>
+        </p:nvSpPr>
+        <p:spPr>
+          <a:xfrm>
+            <a:off x="5806440" y="1353312"/>
             <a:ext cx="5486400" cy="274320"/>
           </a:xfrm>
           <a:prstGeom prst="rect">
@@ -6986,21 +8051,55 @@
                   <a:srgbClr val="008F6A"/>
                 </a:solidFill>
               </a:rPr>
-              <a:t>FINE-TUNE β-VALUE DISTRIBUTION</a:t>
-            </a:r>
-          </a:p>
-        </p:txBody>
-      </p:sp>
-      <p:sp>
-        <p:nvSpPr>
-          <p:cNvPr id="29" name="TextBox 28"/>
-          <p:cNvSpPr txBox="1"/>
-          <p:nvPr/>
-        </p:nvSpPr>
-        <p:spPr>
-          <a:xfrm>
-            <a:off x="6583680" y="2359152"/>
-            <a:ext cx="2011680" cy="320040"/>
+              <a:t>FINE-TUNE  β-VALUE DISTRIBUTION</a:t>
+            </a:r>
+          </a:p>
+        </p:txBody>
+      </p:sp>
+      <p:sp>
+        <p:nvSpPr>
+          <p:cNvPr id="31" name="TextBox 30"/>
+          <p:cNvSpPr txBox="1"/>
+          <p:nvPr/>
+        </p:nvSpPr>
+        <p:spPr>
+          <a:xfrm>
+            <a:off x="5806440" y="1627632"/>
+            <a:ext cx="4663440" cy="274320"/>
+          </a:xfrm>
+          <a:prstGeom prst="rect">
+            <a:avLst/>
+          </a:prstGeom>
+          <a:noFill/>
+        </p:spPr>
+        <p:txBody>
+          <a:bodyPr wrap="square">
+            <a:spAutoFit/>
+          </a:bodyPr>
+          <a:lstStyle/>
+          <a:p>
+            <a:pPr algn="l"/>
+            <a:r>
+              <a:rPr sz="1200" b="0" i="1">
+                <a:solidFill>
+                  <a:srgbClr val="788FA8"/>
+                </a:solidFill>
+              </a:rPr>
+              <a:t>224,570,424 valid values  (39.9% of total slots)</a:t>
+            </a:r>
+          </a:p>
+        </p:txBody>
+      </p:sp>
+      <p:sp>
+        <p:nvSpPr>
+          <p:cNvPr id="32" name="TextBox 31"/>
+          <p:cNvSpPr txBox="1"/>
+          <p:nvPr/>
+        </p:nvSpPr>
+        <p:spPr>
+          <a:xfrm>
+            <a:off x="5806440" y="1938528"/>
+            <a:ext cx="1828800" cy="365760"/>
           </a:xfrm>
           <a:prstGeom prst="rect">
             <a:avLst/>
@@ -7020,55 +8119,55 @@
                   <a:srgbClr val="788FA8"/>
                 </a:solidFill>
               </a:rPr>
-              <a:t>0% (min)</a:t>
-            </a:r>
-          </a:p>
-        </p:txBody>
-      </p:sp>
-      <p:sp>
-        <p:nvSpPr>
-          <p:cNvPr id="30" name="TextBox 29"/>
-          <p:cNvSpPr txBox="1"/>
-          <p:nvPr/>
-        </p:nvSpPr>
-        <p:spPr>
-          <a:xfrm>
-            <a:off x="8641080" y="2359152"/>
-            <a:ext cx="1645920" cy="320040"/>
-          </a:xfrm>
-          <a:prstGeom prst="rect">
-            <a:avLst/>
-          </a:prstGeom>
-          <a:noFill/>
-        </p:spPr>
-        <p:txBody>
-          <a:bodyPr wrap="square">
-            <a:spAutoFit/>
-          </a:bodyPr>
-          <a:lstStyle/>
-          <a:p>
-            <a:pPr algn="l"/>
-            <a:r>
-              <a:rPr sz="1300" b="1" i="0">
+              <a:t>0%   (min)</a:t>
+            </a:r>
+          </a:p>
+        </p:txBody>
+      </p:sp>
+      <p:sp>
+        <p:nvSpPr>
+          <p:cNvPr id="33" name="TextBox 32"/>
+          <p:cNvSpPr txBox="1"/>
+          <p:nvPr/>
+        </p:nvSpPr>
+        <p:spPr>
+          <a:xfrm>
+            <a:off x="7680960" y="1938528"/>
+            <a:ext cx="1371600" cy="365760"/>
+          </a:xfrm>
+          <a:prstGeom prst="rect">
+            <a:avLst/>
+          </a:prstGeom>
+          <a:noFill/>
+        </p:spPr>
+        <p:txBody>
+          <a:bodyPr wrap="square">
+            <a:spAutoFit/>
+          </a:bodyPr>
+          <a:lstStyle/>
+          <a:p>
+            <a:pPr algn="l"/>
+            <a:r>
+              <a:rPr sz="1400" b="1" i="0">
                 <a:solidFill>
                   <a:srgbClr val="3A4A5C"/>
                 </a:solidFill>
               </a:rPr>
-              <a:t>[ TBD ]</a:t>
-            </a:r>
-          </a:p>
-        </p:txBody>
-      </p:sp>
-      <p:sp>
-        <p:nvSpPr>
-          <p:cNvPr id="31" name="TextBox 30"/>
-          <p:cNvSpPr txBox="1"/>
-          <p:nvPr/>
-        </p:nvSpPr>
-        <p:spPr>
-          <a:xfrm>
-            <a:off x="6583680" y="2706624"/>
-            <a:ext cx="2011680" cy="320040"/>
+              <a:t> 0.0000</a:t>
+            </a:r>
+          </a:p>
+        </p:txBody>
+      </p:sp>
+      <p:sp>
+        <p:nvSpPr>
+          <p:cNvPr id="34" name="TextBox 33"/>
+          <p:cNvSpPr txBox="1"/>
+          <p:nvPr/>
+        </p:nvSpPr>
+        <p:spPr>
+          <a:xfrm>
+            <a:off x="5806440" y="2414016"/>
+            <a:ext cx="1828800" cy="365760"/>
           </a:xfrm>
           <a:prstGeom prst="rect">
             <a:avLst/>
@@ -7095,48 +8194,48 @@
       </p:sp>
       <p:sp>
         <p:nvSpPr>
-          <p:cNvPr id="32" name="TextBox 31"/>
-          <p:cNvSpPr txBox="1"/>
-          <p:nvPr/>
-        </p:nvSpPr>
-        <p:spPr>
-          <a:xfrm>
-            <a:off x="8641080" y="2706624"/>
-            <a:ext cx="1645920" cy="320040"/>
-          </a:xfrm>
-          <a:prstGeom prst="rect">
-            <a:avLst/>
-          </a:prstGeom>
-          <a:noFill/>
-        </p:spPr>
-        <p:txBody>
-          <a:bodyPr wrap="square">
-            <a:spAutoFit/>
-          </a:bodyPr>
-          <a:lstStyle/>
-          <a:p>
-            <a:pPr algn="l"/>
-            <a:r>
-              <a:rPr sz="1300" b="1" i="0">
+          <p:cNvPr id="35" name="TextBox 34"/>
+          <p:cNvSpPr txBox="1"/>
+          <p:nvPr/>
+        </p:nvSpPr>
+        <p:spPr>
+          <a:xfrm>
+            <a:off x="7680960" y="2414016"/>
+            <a:ext cx="1371600" cy="365760"/>
+          </a:xfrm>
+          <a:prstGeom prst="rect">
+            <a:avLst/>
+          </a:prstGeom>
+          <a:noFill/>
+        </p:spPr>
+        <p:txBody>
+          <a:bodyPr wrap="square">
+            <a:spAutoFit/>
+          </a:bodyPr>
+          <a:lstStyle/>
+          <a:p>
+            <a:pPr algn="l"/>
+            <a:r>
+              <a:rPr sz="1400" b="1" i="0">
                 <a:solidFill>
                   <a:srgbClr val="3A4A5C"/>
                 </a:solidFill>
               </a:rPr>
-              <a:t>[ TBD ]</a:t>
-            </a:r>
-          </a:p>
-        </p:txBody>
-      </p:sp>
-      <p:sp>
-        <p:nvSpPr>
-          <p:cNvPr id="33" name="TextBox 32"/>
-          <p:cNvSpPr txBox="1"/>
-          <p:nvPr/>
-        </p:nvSpPr>
-        <p:spPr>
-          <a:xfrm>
-            <a:off x="6583680" y="3054096"/>
-            <a:ext cx="2011680" cy="320040"/>
+              <a:t> 0.0086</a:t>
+            </a:r>
+          </a:p>
+        </p:txBody>
+      </p:sp>
+      <p:sp>
+        <p:nvSpPr>
+          <p:cNvPr id="36" name="TextBox 35"/>
+          <p:cNvSpPr txBox="1"/>
+          <p:nvPr/>
+        </p:nvSpPr>
+        <p:spPr>
+          <a:xfrm>
+            <a:off x="5806440" y="2889504"/>
+            <a:ext cx="1828800" cy="365760"/>
           </a:xfrm>
           <a:prstGeom prst="rect">
             <a:avLst/>
@@ -7163,48 +8262,48 @@
       </p:sp>
       <p:sp>
         <p:nvSpPr>
-          <p:cNvPr id="34" name="TextBox 33"/>
-          <p:cNvSpPr txBox="1"/>
-          <p:nvPr/>
-        </p:nvSpPr>
-        <p:spPr>
-          <a:xfrm>
-            <a:off x="8641080" y="3054096"/>
-            <a:ext cx="1645920" cy="320040"/>
-          </a:xfrm>
-          <a:prstGeom prst="rect">
-            <a:avLst/>
-          </a:prstGeom>
-          <a:noFill/>
-        </p:spPr>
-        <p:txBody>
-          <a:bodyPr wrap="square">
-            <a:spAutoFit/>
-          </a:bodyPr>
-          <a:lstStyle/>
-          <a:p>
-            <a:pPr algn="l"/>
-            <a:r>
-              <a:rPr sz="1300" b="1" i="0">
+          <p:cNvPr id="37" name="TextBox 36"/>
+          <p:cNvSpPr txBox="1"/>
+          <p:nvPr/>
+        </p:nvSpPr>
+        <p:spPr>
+          <a:xfrm>
+            <a:off x="7680960" y="2889504"/>
+            <a:ext cx="1371600" cy="365760"/>
+          </a:xfrm>
+          <a:prstGeom prst="rect">
+            <a:avLst/>
+          </a:prstGeom>
+          <a:noFill/>
+        </p:spPr>
+        <p:txBody>
+          <a:bodyPr wrap="square">
+            <a:spAutoFit/>
+          </a:bodyPr>
+          <a:lstStyle/>
+          <a:p>
+            <a:pPr algn="l"/>
+            <a:r>
+              <a:rPr sz="1400" b="1" i="0">
                 <a:solidFill>
                   <a:srgbClr val="3A4A5C"/>
                 </a:solidFill>
               </a:rPr>
-              <a:t>[ TBD ]</a:t>
-            </a:r>
-          </a:p>
-        </p:txBody>
-      </p:sp>
-      <p:sp>
-        <p:nvSpPr>
-          <p:cNvPr id="35" name="TextBox 34"/>
-          <p:cNvSpPr txBox="1"/>
-          <p:nvPr/>
-        </p:nvSpPr>
-        <p:spPr>
-          <a:xfrm>
-            <a:off x="6583680" y="3401568"/>
-            <a:ext cx="2011680" cy="320040"/>
+              <a:t> 0.0188</a:t>
+            </a:r>
+          </a:p>
+        </p:txBody>
+      </p:sp>
+      <p:sp>
+        <p:nvSpPr>
+          <p:cNvPr id="38" name="TextBox 37"/>
+          <p:cNvSpPr txBox="1"/>
+          <p:nvPr/>
+        </p:nvSpPr>
+        <p:spPr>
+          <a:xfrm>
+            <a:off x="5806440" y="3364992"/>
+            <a:ext cx="1828800" cy="365760"/>
           </a:xfrm>
           <a:prstGeom prst="rect">
             <a:avLst/>
@@ -7231,48 +8330,48 @@
       </p:sp>
       <p:sp>
         <p:nvSpPr>
-          <p:cNvPr id="36" name="TextBox 35"/>
-          <p:cNvSpPr txBox="1"/>
-          <p:nvPr/>
-        </p:nvSpPr>
-        <p:spPr>
-          <a:xfrm>
-            <a:off x="8641080" y="3401568"/>
-            <a:ext cx="1645920" cy="320040"/>
-          </a:xfrm>
-          <a:prstGeom prst="rect">
-            <a:avLst/>
-          </a:prstGeom>
-          <a:noFill/>
-        </p:spPr>
-        <p:txBody>
-          <a:bodyPr wrap="square">
-            <a:spAutoFit/>
-          </a:bodyPr>
-          <a:lstStyle/>
-          <a:p>
-            <a:pPr algn="l"/>
-            <a:r>
-              <a:rPr sz="1300" b="1" i="0">
+          <p:cNvPr id="39" name="TextBox 38"/>
+          <p:cNvSpPr txBox="1"/>
+          <p:nvPr/>
+        </p:nvSpPr>
+        <p:spPr>
+          <a:xfrm>
+            <a:off x="7680960" y="3364992"/>
+            <a:ext cx="1371600" cy="365760"/>
+          </a:xfrm>
+          <a:prstGeom prst="rect">
+            <a:avLst/>
+          </a:prstGeom>
+          <a:noFill/>
+        </p:spPr>
+        <p:txBody>
+          <a:bodyPr wrap="square">
+            <a:spAutoFit/>
+          </a:bodyPr>
+          <a:lstStyle/>
+          <a:p>
+            <a:pPr algn="l"/>
+            <a:r>
+              <a:rPr sz="1400" b="1" i="0">
                 <a:solidFill>
                   <a:srgbClr val="3A4A5C"/>
                 </a:solidFill>
               </a:rPr>
-              <a:t>[ TBD ]</a:t>
-            </a:r>
-          </a:p>
-        </p:txBody>
-      </p:sp>
-      <p:sp>
-        <p:nvSpPr>
-          <p:cNvPr id="37" name="TextBox 36"/>
-          <p:cNvSpPr txBox="1"/>
-          <p:nvPr/>
-        </p:nvSpPr>
-        <p:spPr>
-          <a:xfrm>
-            <a:off x="6583680" y="3749039"/>
-            <a:ext cx="2011680" cy="320040"/>
+              <a:t> 0.0400</a:t>
+            </a:r>
+          </a:p>
+        </p:txBody>
+      </p:sp>
+      <p:sp>
+        <p:nvSpPr>
+          <p:cNvPr id="40" name="TextBox 39"/>
+          <p:cNvSpPr txBox="1"/>
+          <p:nvPr/>
+        </p:nvSpPr>
+        <p:spPr>
+          <a:xfrm>
+            <a:off x="5806440" y="3840480"/>
+            <a:ext cx="1828800" cy="365760"/>
           </a:xfrm>
           <a:prstGeom prst="rect">
             <a:avLst/>
@@ -7292,55 +8391,123 @@
                   <a:srgbClr val="788FA8"/>
                 </a:solidFill>
               </a:rPr>
-              <a:t>50% (median)</a:t>
-            </a:r>
-          </a:p>
-        </p:txBody>
-      </p:sp>
-      <p:sp>
-        <p:nvSpPr>
-          <p:cNvPr id="38" name="TextBox 37"/>
-          <p:cNvSpPr txBox="1"/>
-          <p:nvPr/>
-        </p:nvSpPr>
-        <p:spPr>
-          <a:xfrm>
-            <a:off x="8641080" y="3749039"/>
-            <a:ext cx="1645920" cy="320040"/>
-          </a:xfrm>
-          <a:prstGeom prst="rect">
-            <a:avLst/>
-          </a:prstGeom>
-          <a:noFill/>
-        </p:spPr>
-        <p:txBody>
-          <a:bodyPr wrap="square">
-            <a:spAutoFit/>
-          </a:bodyPr>
-          <a:lstStyle/>
-          <a:p>
-            <a:pPr algn="l"/>
-            <a:r>
-              <a:rPr sz="1300" b="1" i="0">
+              <a:t>50%  (median)</a:t>
+            </a:r>
+          </a:p>
+        </p:txBody>
+      </p:sp>
+      <p:sp>
+        <p:nvSpPr>
+          <p:cNvPr id="41" name="TextBox 40"/>
+          <p:cNvSpPr txBox="1"/>
+          <p:nvPr/>
+        </p:nvSpPr>
+        <p:spPr>
+          <a:xfrm>
+            <a:off x="7680960" y="3840480"/>
+            <a:ext cx="1371600" cy="365760"/>
+          </a:xfrm>
+          <a:prstGeom prst="rect">
+            <a:avLst/>
+          </a:prstGeom>
+          <a:noFill/>
+        </p:spPr>
+        <p:txBody>
+          <a:bodyPr wrap="square">
+            <a:spAutoFit/>
+          </a:bodyPr>
+          <a:lstStyle/>
+          <a:p>
+            <a:pPr algn="l"/>
+            <a:r>
+              <a:rPr sz="1400" b="1" i="0">
+                <a:solidFill>
+                  <a:srgbClr val="007AC2"/>
+                </a:solidFill>
+              </a:rPr>
+              <a:t> 0.0825</a:t>
+            </a:r>
+          </a:p>
+        </p:txBody>
+      </p:sp>
+      <p:sp>
+        <p:nvSpPr>
+          <p:cNvPr id="42" name="TextBox 41"/>
+          <p:cNvSpPr txBox="1"/>
+          <p:nvPr/>
+        </p:nvSpPr>
+        <p:spPr>
+          <a:xfrm>
+            <a:off x="5806440" y="4315968"/>
+            <a:ext cx="1828800" cy="365760"/>
+          </a:xfrm>
+          <a:prstGeom prst="rect">
+            <a:avLst/>
+          </a:prstGeom>
+          <a:noFill/>
+        </p:spPr>
+        <p:txBody>
+          <a:bodyPr wrap="square">
+            <a:spAutoFit/>
+          </a:bodyPr>
+          <a:lstStyle/>
+          <a:p>
+            <a:pPr algn="l"/>
+            <a:r>
+              <a:rPr sz="1300" b="0" i="0">
+                <a:solidFill>
+                  <a:srgbClr val="788FA8"/>
+                </a:solidFill>
+              </a:rPr>
+              <a:t>75%</a:t>
+            </a:r>
+          </a:p>
+        </p:txBody>
+      </p:sp>
+      <p:sp>
+        <p:nvSpPr>
+          <p:cNvPr id="43" name="TextBox 42"/>
+          <p:cNvSpPr txBox="1"/>
+          <p:nvPr/>
+        </p:nvSpPr>
+        <p:spPr>
+          <a:xfrm>
+            <a:off x="7680960" y="4315968"/>
+            <a:ext cx="1371600" cy="365760"/>
+          </a:xfrm>
+          <a:prstGeom prst="rect">
+            <a:avLst/>
+          </a:prstGeom>
+          <a:noFill/>
+        </p:spPr>
+        <p:txBody>
+          <a:bodyPr wrap="square">
+            <a:spAutoFit/>
+          </a:bodyPr>
+          <a:lstStyle/>
+          <a:p>
+            <a:pPr algn="l"/>
+            <a:r>
+              <a:rPr sz="1400" b="1" i="0">
                 <a:solidFill>
                   <a:srgbClr val="3A4A5C"/>
                 </a:solidFill>
               </a:rPr>
-              <a:t>[ TBD ]</a:t>
-            </a:r>
-          </a:p>
-        </p:txBody>
-      </p:sp>
-      <p:sp>
-        <p:nvSpPr>
-          <p:cNvPr id="39" name="TextBox 38"/>
-          <p:cNvSpPr txBox="1"/>
-          <p:nvPr/>
-        </p:nvSpPr>
-        <p:spPr>
-          <a:xfrm>
-            <a:off x="6583680" y="4096512"/>
-            <a:ext cx="2011680" cy="320040"/>
+              <a:t> 0.4881</a:t>
+            </a:r>
+          </a:p>
+        </p:txBody>
+      </p:sp>
+      <p:sp>
+        <p:nvSpPr>
+          <p:cNvPr id="44" name="TextBox 43"/>
+          <p:cNvSpPr txBox="1"/>
+          <p:nvPr/>
+        </p:nvSpPr>
+        <p:spPr>
+          <a:xfrm>
+            <a:off x="5806440" y="4791456"/>
+            <a:ext cx="1828800" cy="365760"/>
           </a:xfrm>
           <a:prstGeom prst="rect">
             <a:avLst/>
@@ -7360,55 +8527,55 @@
                   <a:srgbClr val="788FA8"/>
                 </a:solidFill>
               </a:rPr>
-              <a:t>75%</a:t>
-            </a:r>
-          </a:p>
-        </p:txBody>
-      </p:sp>
-      <p:sp>
-        <p:nvSpPr>
-          <p:cNvPr id="40" name="TextBox 39"/>
-          <p:cNvSpPr txBox="1"/>
-          <p:nvPr/>
-        </p:nvSpPr>
-        <p:spPr>
-          <a:xfrm>
-            <a:off x="8641080" y="4096512"/>
-            <a:ext cx="1645920" cy="320040"/>
-          </a:xfrm>
-          <a:prstGeom prst="rect">
-            <a:avLst/>
-          </a:prstGeom>
-          <a:noFill/>
-        </p:spPr>
-        <p:txBody>
-          <a:bodyPr wrap="square">
-            <a:spAutoFit/>
-          </a:bodyPr>
-          <a:lstStyle/>
-          <a:p>
-            <a:pPr algn="l"/>
-            <a:r>
-              <a:rPr sz="1300" b="1" i="0">
+              <a:t>95%</a:t>
+            </a:r>
+          </a:p>
+        </p:txBody>
+      </p:sp>
+      <p:sp>
+        <p:nvSpPr>
+          <p:cNvPr id="45" name="TextBox 44"/>
+          <p:cNvSpPr txBox="1"/>
+          <p:nvPr/>
+        </p:nvSpPr>
+        <p:spPr>
+          <a:xfrm>
+            <a:off x="7680960" y="4791456"/>
+            <a:ext cx="1371600" cy="365760"/>
+          </a:xfrm>
+          <a:prstGeom prst="rect">
+            <a:avLst/>
+          </a:prstGeom>
+          <a:noFill/>
+        </p:spPr>
+        <p:txBody>
+          <a:bodyPr wrap="square">
+            <a:spAutoFit/>
+          </a:bodyPr>
+          <a:lstStyle/>
+          <a:p>
+            <a:pPr algn="l"/>
+            <a:r>
+              <a:rPr sz="1400" b="1" i="0">
                 <a:solidFill>
                   <a:srgbClr val="3A4A5C"/>
                 </a:solidFill>
               </a:rPr>
-              <a:t>[ TBD ]</a:t>
-            </a:r>
-          </a:p>
-        </p:txBody>
-      </p:sp>
-      <p:sp>
-        <p:nvSpPr>
-          <p:cNvPr id="41" name="TextBox 40"/>
-          <p:cNvSpPr txBox="1"/>
-          <p:nvPr/>
-        </p:nvSpPr>
-        <p:spPr>
-          <a:xfrm>
-            <a:off x="6583680" y="4443984"/>
-            <a:ext cx="2011680" cy="320040"/>
+              <a:t> 0.9050</a:t>
+            </a:r>
+          </a:p>
+        </p:txBody>
+      </p:sp>
+      <p:sp>
+        <p:nvSpPr>
+          <p:cNvPr id="46" name="TextBox 45"/>
+          <p:cNvSpPr txBox="1"/>
+          <p:nvPr/>
+        </p:nvSpPr>
+        <p:spPr>
+          <a:xfrm>
+            <a:off x="5806440" y="5266944"/>
+            <a:ext cx="1828800" cy="365760"/>
           </a:xfrm>
           <a:prstGeom prst="rect">
             <a:avLst/>
@@ -7428,55 +8595,55 @@
                   <a:srgbClr val="788FA8"/>
                 </a:solidFill>
               </a:rPr>
-              <a:t>95%</a:t>
-            </a:r>
-          </a:p>
-        </p:txBody>
-      </p:sp>
-      <p:sp>
-        <p:nvSpPr>
-          <p:cNvPr id="42" name="TextBox 41"/>
-          <p:cNvSpPr txBox="1"/>
-          <p:nvPr/>
-        </p:nvSpPr>
-        <p:spPr>
-          <a:xfrm>
-            <a:off x="8641080" y="4443984"/>
-            <a:ext cx="1645920" cy="320040"/>
-          </a:xfrm>
-          <a:prstGeom prst="rect">
-            <a:avLst/>
-          </a:prstGeom>
-          <a:noFill/>
-        </p:spPr>
-        <p:txBody>
-          <a:bodyPr wrap="square">
-            <a:spAutoFit/>
-          </a:bodyPr>
-          <a:lstStyle/>
-          <a:p>
-            <a:pPr algn="l"/>
-            <a:r>
-              <a:rPr sz="1300" b="1" i="0">
+              <a:t>99%</a:t>
+            </a:r>
+          </a:p>
+        </p:txBody>
+      </p:sp>
+      <p:sp>
+        <p:nvSpPr>
+          <p:cNvPr id="47" name="TextBox 46"/>
+          <p:cNvSpPr txBox="1"/>
+          <p:nvPr/>
+        </p:nvSpPr>
+        <p:spPr>
+          <a:xfrm>
+            <a:off x="7680960" y="5266944"/>
+            <a:ext cx="1371600" cy="365760"/>
+          </a:xfrm>
+          <a:prstGeom prst="rect">
+            <a:avLst/>
+          </a:prstGeom>
+          <a:noFill/>
+        </p:spPr>
+        <p:txBody>
+          <a:bodyPr wrap="square">
+            <a:spAutoFit/>
+          </a:bodyPr>
+          <a:lstStyle/>
+          <a:p>
+            <a:pPr algn="l"/>
+            <a:r>
+              <a:rPr sz="1400" b="1" i="0">
                 <a:solidFill>
                   <a:srgbClr val="3A4A5C"/>
                 </a:solidFill>
               </a:rPr>
-              <a:t>[ TBD ]</a:t>
-            </a:r>
-          </a:p>
-        </p:txBody>
-      </p:sp>
-      <p:sp>
-        <p:nvSpPr>
-          <p:cNvPr id="43" name="TextBox 42"/>
-          <p:cNvSpPr txBox="1"/>
-          <p:nvPr/>
-        </p:nvSpPr>
-        <p:spPr>
-          <a:xfrm>
-            <a:off x="6583680" y="4791456"/>
-            <a:ext cx="2011680" cy="320040"/>
+              <a:t> 0.9498</a:t>
+            </a:r>
+          </a:p>
+        </p:txBody>
+      </p:sp>
+      <p:sp>
+        <p:nvSpPr>
+          <p:cNvPr id="48" name="TextBox 47"/>
+          <p:cNvSpPr txBox="1"/>
+          <p:nvPr/>
+        </p:nvSpPr>
+        <p:spPr>
+          <a:xfrm>
+            <a:off x="5806440" y="5742432"/>
+            <a:ext cx="1828800" cy="365760"/>
           </a:xfrm>
           <a:prstGeom prst="rect">
             <a:avLst/>
@@ -7496,74 +8663,6 @@
                   <a:srgbClr val="788FA8"/>
                 </a:solidFill>
               </a:rPr>
-              <a:t>99%</a:t>
-            </a:r>
-          </a:p>
-        </p:txBody>
-      </p:sp>
-      <p:sp>
-        <p:nvSpPr>
-          <p:cNvPr id="44" name="TextBox 43"/>
-          <p:cNvSpPr txBox="1"/>
-          <p:nvPr/>
-        </p:nvSpPr>
-        <p:spPr>
-          <a:xfrm>
-            <a:off x="8641080" y="4791456"/>
-            <a:ext cx="1645920" cy="320040"/>
-          </a:xfrm>
-          <a:prstGeom prst="rect">
-            <a:avLst/>
-          </a:prstGeom>
-          <a:noFill/>
-        </p:spPr>
-        <p:txBody>
-          <a:bodyPr wrap="square">
-            <a:spAutoFit/>
-          </a:bodyPr>
-          <a:lstStyle/>
-          <a:p>
-            <a:pPr algn="l"/>
-            <a:r>
-              <a:rPr sz="1300" b="1" i="0">
-                <a:solidFill>
-                  <a:srgbClr val="3A4A5C"/>
-                </a:solidFill>
-              </a:rPr>
-              <a:t>[ TBD ]</a:t>
-            </a:r>
-          </a:p>
-        </p:txBody>
-      </p:sp>
-      <p:sp>
-        <p:nvSpPr>
-          <p:cNvPr id="45" name="TextBox 44"/>
-          <p:cNvSpPr txBox="1"/>
-          <p:nvPr/>
-        </p:nvSpPr>
-        <p:spPr>
-          <a:xfrm>
-            <a:off x="6583680" y="5138928"/>
-            <a:ext cx="2011680" cy="320040"/>
-          </a:xfrm>
-          <a:prstGeom prst="rect">
-            <a:avLst/>
-          </a:prstGeom>
-          <a:noFill/>
-        </p:spPr>
-        <p:txBody>
-          <a:bodyPr wrap="square">
-            <a:spAutoFit/>
-          </a:bodyPr>
-          <a:lstStyle/>
-          <a:p>
-            <a:pPr algn="l"/>
-            <a:r>
-              <a:rPr sz="1300" b="0" i="0">
-                <a:solidFill>
-                  <a:srgbClr val="788FA8"/>
-                </a:solidFill>
-              </a:rPr>
               <a:t>100% (max)</a:t>
             </a:r>
           </a:p>
@@ -7571,58 +8670,58 @@
       </p:sp>
       <p:sp>
         <p:nvSpPr>
-          <p:cNvPr id="46" name="TextBox 45"/>
-          <p:cNvSpPr txBox="1"/>
-          <p:nvPr/>
-        </p:nvSpPr>
-        <p:spPr>
-          <a:xfrm>
-            <a:off x="8641080" y="5138928"/>
-            <a:ext cx="1645920" cy="320040"/>
-          </a:xfrm>
-          <a:prstGeom prst="rect">
-            <a:avLst/>
-          </a:prstGeom>
-          <a:noFill/>
-        </p:spPr>
-        <p:txBody>
-          <a:bodyPr wrap="square">
-            <a:spAutoFit/>
-          </a:bodyPr>
-          <a:lstStyle/>
-          <a:p>
-            <a:pPr algn="l"/>
-            <a:r>
-              <a:rPr sz="1300" b="1" i="0">
-                <a:solidFill>
-                  <a:srgbClr val="3A4A5C"/>
-                </a:solidFill>
-              </a:rPr>
-              <a:t>[ TBD ]</a:t>
-            </a:r>
-          </a:p>
-        </p:txBody>
-      </p:sp>
-      <p:sp>
-        <p:nvSpPr>
-          <p:cNvPr id="47" name="Rectangle 46"/>
+          <p:cNvPr id="49" name="TextBox 48"/>
+          <p:cNvSpPr txBox="1"/>
+          <p:nvPr/>
+        </p:nvSpPr>
+        <p:spPr>
+          <a:xfrm>
+            <a:off x="7680960" y="5742432"/>
+            <a:ext cx="1371600" cy="365760"/>
+          </a:xfrm>
+          <a:prstGeom prst="rect">
+            <a:avLst/>
+          </a:prstGeom>
+          <a:noFill/>
+        </p:spPr>
+        <p:txBody>
+          <a:bodyPr wrap="square">
+            <a:spAutoFit/>
+          </a:bodyPr>
+          <a:lstStyle/>
+          <a:p>
+            <a:pPr algn="l"/>
+            <a:r>
+              <a:rPr sz="1400" b="1" i="0">
+                <a:solidFill>
+                  <a:srgbClr val="008F6A"/>
+                </a:solidFill>
+              </a:rPr>
+              <a:t> 1.0000</a:t>
+            </a:r>
+          </a:p>
+        </p:txBody>
+      </p:sp>
+      <p:sp>
+        <p:nvSpPr>
+          <p:cNvPr id="50" name="Rectangle 49"/>
           <p:cNvSpPr/>
           <p:nvPr/>
         </p:nvSpPr>
         <p:spPr>
           <a:xfrm>
-            <a:off x="365760" y="6108192"/>
-            <a:ext cx="11475720" cy="502920"/>
+            <a:off x="5669280" y="6291072"/>
+            <a:ext cx="5029200" cy="384048"/>
           </a:xfrm>
           <a:prstGeom prst="rect">
             <a:avLst/>
           </a:prstGeom>
           <a:solidFill>
-            <a:srgbClr val="FDEAC8"/>
+            <a:srgbClr val="D5F0E4"/>
           </a:solidFill>
           <a:ln w="12700">
             <a:solidFill>
-              <a:srgbClr val="D47E00"/>
+              <a:srgbClr val="008F6A"/>
             </a:solidFill>
           </a:ln>
         </p:spPr>
@@ -7650,102 +8749,206 @@
       </p:sp>
       <p:sp>
         <p:nvSpPr>
-          <p:cNvPr id="48" name="TextBox 47"/>
-          <p:cNvSpPr txBox="1"/>
-          <p:nvPr/>
-        </p:nvSpPr>
-        <p:spPr>
-          <a:xfrm>
-            <a:off x="502920" y="6172200"/>
-            <a:ext cx="3657600" cy="365760"/>
-          </a:xfrm>
-          <a:prstGeom prst="rect">
-            <a:avLst/>
-          </a:prstGeom>
-          <a:noFill/>
-        </p:spPr>
-        <p:txBody>
-          <a:bodyPr wrap="square">
-            <a:spAutoFit/>
-          </a:bodyPr>
-          <a:lstStyle/>
-          <a:p>
-            <a:pPr algn="l"/>
-            <a:r>
-              <a:rPr sz="1300" b="0" i="0">
-                <a:solidFill>
-                  <a:srgbClr val="9A5A00"/>
-                </a:solidFill>
-              </a:rPr>
-              <a:t>Out-of-range (β&lt;0 or β&gt;1):  [ TBD ]</a:t>
-            </a:r>
-          </a:p>
-        </p:txBody>
-      </p:sp>
-      <p:sp>
-        <p:nvSpPr>
-          <p:cNvPr id="49" name="TextBox 48"/>
-          <p:cNvSpPr txBox="1"/>
-          <p:nvPr/>
-        </p:nvSpPr>
-        <p:spPr>
-          <a:xfrm>
-            <a:off x="4343400" y="6172200"/>
-            <a:ext cx="3657600" cy="365760"/>
-          </a:xfrm>
-          <a:prstGeom prst="rect">
-            <a:avLst/>
-          </a:prstGeom>
-          <a:noFill/>
-        </p:spPr>
-        <p:txBody>
-          <a:bodyPr wrap="square">
-            <a:spAutoFit/>
-          </a:bodyPr>
-          <a:lstStyle/>
-          <a:p>
-            <a:pPr algn="l"/>
-            <a:r>
-              <a:rPr sz="1300" b="0" i="0">
-                <a:solidFill>
-                  <a:srgbClr val="9A5A00"/>
-                </a:solidFill>
-              </a:rPr>
-              <a:t>Duplicate sample IDs:  [ TBD ]</a:t>
-            </a:r>
-          </a:p>
-        </p:txBody>
-      </p:sp>
-      <p:sp>
-        <p:nvSpPr>
-          <p:cNvPr id="50" name="TextBox 49"/>
-          <p:cNvSpPr txBox="1"/>
-          <p:nvPr/>
-        </p:nvSpPr>
-        <p:spPr>
-          <a:xfrm>
-            <a:off x="8183880" y="6172200"/>
-            <a:ext cx="3657600" cy="365760"/>
-          </a:xfrm>
-          <a:prstGeom prst="rect">
-            <a:avLst/>
-          </a:prstGeom>
-          <a:noFill/>
-        </p:spPr>
-        <p:txBody>
-          <a:bodyPr wrap="square">
-            <a:spAutoFit/>
-          </a:bodyPr>
-          <a:lstStyle/>
-          <a:p>
-            <a:pPr algn="l"/>
-            <a:r>
-              <a:rPr sz="1300" b="0" i="0">
-                <a:solidFill>
-                  <a:srgbClr val="9A5A00"/>
-                </a:solidFill>
-              </a:rPr>
-              <a:t>Duplicate CpG IDs:  [ TBD ]</a:t>
+          <p:cNvPr id="51" name="TextBox 50"/>
+          <p:cNvSpPr txBox="1"/>
+          <p:nvPr/>
+        </p:nvSpPr>
+        <p:spPr>
+          <a:xfrm>
+            <a:off x="5806440" y="6336792"/>
+            <a:ext cx="4754880" cy="292608"/>
+          </a:xfrm>
+          <a:prstGeom prst="rect">
+            <a:avLst/>
+          </a:prstGeom>
+          <a:noFill/>
+        </p:spPr>
+        <p:txBody>
+          <a:bodyPr wrap="square">
+            <a:spAutoFit/>
+          </a:bodyPr>
+          <a:lstStyle/>
+          <a:p>
+            <a:pPr algn="l"/>
+            <a:r>
+              <a:rPr sz="1200" b="0" i="0">
+                <a:solidFill>
+                  <a:srgbClr val="006045"/>
+                </a:solidFill>
+              </a:rPr>
+              <a:t>Out-of-range β:  0  ✓  (fine-tune values are perfectly in [0, 1])</a:t>
+            </a:r>
+          </a:p>
+        </p:txBody>
+      </p:sp>
+      <p:sp>
+        <p:nvSpPr>
+          <p:cNvPr id="52" name="Rectangle 51"/>
+          <p:cNvSpPr/>
+          <p:nvPr/>
+        </p:nvSpPr>
+        <p:spPr>
+          <a:xfrm>
+            <a:off x="365760" y="1261872"/>
+            <a:ext cx="0" cy="0"/>
+          </a:xfrm>
+          <a:prstGeom prst="rect">
+            <a:avLst/>
+          </a:prstGeom>
+          <a:solidFill>
+            <a:srgbClr val="FFFFFF"/>
+          </a:solidFill>
+          <a:ln w="12700">
+            <a:solidFill>
+              <a:srgbClr val="CCD9E8"/>
+            </a:solidFill>
+          </a:ln>
+        </p:spPr>
+        <p:style>
+          <a:lnRef idx="1">
+            <a:schemeClr val="accent1"/>
+          </a:lnRef>
+          <a:fillRef idx="3">
+            <a:schemeClr val="accent1"/>
+          </a:fillRef>
+          <a:effectRef idx="2">
+            <a:schemeClr val="accent1"/>
+          </a:effectRef>
+          <a:fontRef idx="minor">
+            <a:schemeClr val="lt1"/>
+          </a:fontRef>
+        </p:style>
+        <p:txBody>
+          <a:bodyPr rtlCol="0" anchor="ctr"/>
+          <a:lstStyle/>
+          <a:p>
+            <a:pPr algn="ctr"/>
+          </a:p>
+        </p:txBody>
+      </p:sp>
+      <p:sp>
+        <p:nvSpPr>
+          <p:cNvPr id="53" name="Rectangle 52"/>
+          <p:cNvSpPr/>
+          <p:nvPr/>
+        </p:nvSpPr>
+        <p:spPr>
+          <a:xfrm>
+            <a:off x="10744200" y="1261872"/>
+            <a:ext cx="1097280" cy="5120640"/>
+          </a:xfrm>
+          <a:prstGeom prst="rect">
+            <a:avLst/>
+          </a:prstGeom>
+          <a:solidFill>
+            <a:srgbClr val="F2F6FB"/>
+          </a:solidFill>
+          <a:ln w="12700">
+            <a:solidFill>
+              <a:srgbClr val="CCD9E8"/>
+            </a:solidFill>
+          </a:ln>
+        </p:spPr>
+        <p:style>
+          <a:lnRef idx="1">
+            <a:schemeClr val="accent1"/>
+          </a:lnRef>
+          <a:fillRef idx="3">
+            <a:schemeClr val="accent1"/>
+          </a:fillRef>
+          <a:effectRef idx="2">
+            <a:schemeClr val="accent1"/>
+          </a:effectRef>
+          <a:fontRef idx="minor">
+            <a:schemeClr val="lt1"/>
+          </a:fontRef>
+        </p:style>
+        <p:txBody>
+          <a:bodyPr rtlCol="0" anchor="ctr"/>
+          <a:lstStyle/>
+          <a:p>
+            <a:pPr algn="ctr"/>
+          </a:p>
+        </p:txBody>
+      </p:sp>
+      <p:sp>
+        <p:nvSpPr>
+          <p:cNvPr id="54" name="TextBox 53"/>
+          <p:cNvSpPr txBox="1"/>
+          <p:nvPr/>
+        </p:nvSpPr>
+        <p:spPr>
+          <a:xfrm>
+            <a:off x="10789920" y="1353312"/>
+            <a:ext cx="5486400" cy="274320"/>
+          </a:xfrm>
+          <a:prstGeom prst="rect">
+            <a:avLst/>
+          </a:prstGeom>
+          <a:noFill/>
+        </p:spPr>
+        <p:txBody>
+          <a:bodyPr wrap="square">
+            <a:spAutoFit/>
+          </a:bodyPr>
+          <a:lstStyle/>
+          <a:p>
+            <a:pPr algn="l"/>
+            <a:r>
+              <a:rPr sz="1100" b="1" i="0">
+                <a:solidFill>
+                  <a:srgbClr val="788FA8"/>
+                </a:solidFill>
+              </a:rPr>
+              <a:t>KEY</a:t>
+            </a:r>
+          </a:p>
+        </p:txBody>
+      </p:sp>
+      <p:sp>
+        <p:nvSpPr>
+          <p:cNvPr id="55" name="TextBox 54"/>
+          <p:cNvSpPr txBox="1"/>
+          <p:nvPr/>
+        </p:nvSpPr>
+        <p:spPr>
+          <a:xfrm>
+            <a:off x="10789920" y="1627632"/>
+            <a:ext cx="1005840" cy="4663440"/>
+          </a:xfrm>
+          <a:prstGeom prst="rect">
+            <a:avLst/>
+          </a:prstGeom>
+          <a:noFill/>
+        </p:spPr>
+        <p:txBody>
+          <a:bodyPr wrap="square">
+            <a:spAutoFit/>
+          </a:bodyPr>
+          <a:lstStyle/>
+          <a:p>
+            <a:pPr algn="l"/>
+            <a:r>
+              <a:rPr sz="1100" b="0" i="0">
+                <a:solidFill>
+                  <a:srgbClr val="3A4A5C"/>
+                </a:solidFill>
+              </a:rPr>
+              <a:t>Pretrain
+median
+0.286
+Fine-tune
+median
+0.083
+Different
+distributions!
+Pretrain:
+more hemi-
+methylated
+sites
+Fine-tune:
+more un-
+methylated</a:t>
             </a:r>
           </a:p>
         </p:txBody>
@@ -12214,7 +13417,7 @@
                   <a:srgbClr val="788FA8"/>
                 </a:solidFill>
               </a:rPr>
-              <a:t>Most legacy EWAS</a:t>
+              <a:t>Fine-tune dataset (confirmed)</a:t>
             </a:r>
           </a:p>
         </p:txBody>
@@ -12427,7 +13630,7 @@
                   <a:srgbClr val="788FA8"/>
                 </a:solidFill>
               </a:rPr>
-              <a:t>Modern arrays</a:t>
+              <a:t>Most of pretrain corpus</a:t>
             </a:r>
           </a:p>
         </p:txBody>
@@ -12640,7 +13843,7 @@
                   <a:srgbClr val="788FA8"/>
                 </a:solidFill>
               </a:rPr>
-              <a:t>Older datasets</a:t>
+              <a:t>Some of pretrain corpus</a:t>
             </a:r>
           </a:p>
         </p:txBody>
@@ -18392,7 +19595,7 @@
         <p:spPr>
           <a:xfrm>
             <a:off x="502920" y="1572768"/>
-            <a:ext cx="1784908" cy="658368"/>
+            <a:ext cx="970544" cy="658368"/>
           </a:xfrm>
           <a:prstGeom prst="rect">
             <a:avLst/>
@@ -18437,7 +19640,7 @@
         <p:spPr>
           <a:xfrm>
             <a:off x="548640" y="1645920"/>
-            <a:ext cx="1693468" cy="548640"/>
+            <a:ext cx="879104" cy="548640"/>
           </a:xfrm>
           <a:prstGeom prst="rect">
             <a:avLst/>
@@ -18458,7 +19661,7 @@
                 </a:solidFill>
               </a:rPr>
               <a:t>NaN positions
-~8k  (16%)</a:t>
+~4.3k  (8.7%)</a:t>
             </a:r>
           </a:p>
         </p:txBody>
@@ -18471,8 +19674,8 @@
         </p:nvSpPr>
         <p:spPr>
           <a:xfrm>
-            <a:off x="2287828" y="1572768"/>
-            <a:ext cx="4685385" cy="658368"/>
+            <a:off x="1473464" y="1572768"/>
+            <a:ext cx="5098145" cy="658368"/>
           </a:xfrm>
           <a:prstGeom prst="rect">
             <a:avLst/>
@@ -18516,8 +19719,8 @@
         </p:nvSpPr>
         <p:spPr>
           <a:xfrm>
-            <a:off x="2333548" y="1645920"/>
-            <a:ext cx="4593945" cy="548640"/>
+            <a:off x="1519184" y="1645920"/>
+            <a:ext cx="5006705" cy="548640"/>
           </a:xfrm>
           <a:prstGeom prst="rect">
             <a:avLst/>
@@ -18538,7 +19741,7 @@
                 </a:solidFill>
               </a:rPr>
               <a:t>Input view
-~20.5k  (42%)</a:t>
+~22.5k  (45.7%)</a:t>
             </a:r>
           </a:p>
         </p:txBody>
@@ -18551,8 +19754,8 @@
         </p:nvSpPr>
         <p:spPr>
           <a:xfrm>
-            <a:off x="6973214" y="1572768"/>
-            <a:ext cx="4685385" cy="658368"/>
+            <a:off x="6571609" y="1572768"/>
+            <a:ext cx="5086990" cy="658368"/>
           </a:xfrm>
           <a:prstGeom prst="rect">
             <a:avLst/>
@@ -18596,8 +19799,8 @@
         </p:nvSpPr>
         <p:spPr>
           <a:xfrm>
-            <a:off x="7018934" y="1645920"/>
-            <a:ext cx="4593945" cy="548640"/>
+            <a:off x="6617329" y="1645920"/>
+            <a:ext cx="4995550" cy="548640"/>
           </a:xfrm>
           <a:prstGeom prst="rect">
             <a:avLst/>
@@ -18618,7 +19821,7 @@
                 </a:solidFill>
               </a:rPr>
               <a:t>Held-out (recon target)
-~20.5k  (42%)</a:t>
+~22.5k  (45.7%)</a:t>
             </a:r>
           </a:p>
         </p:txBody>
@@ -18731,7 +19934,7 @@
                   <a:srgbClr val="3A4A5C"/>
                 </a:solidFill>
               </a:rPr>
-              <a:t>valid_indices  =  positions where isfinite(β)  →  ~41k of 49k</a:t>
+              <a:t>valid_indices  =  positions where isfinite(β)  →  ~44.9k of 49k  (NaN rate = 8.7%)</a:t>
             </a:r>
           </a:p>
         </p:txBody>
@@ -18766,7 +19969,7 @@
                 </a:solidFill>
               </a:rPr>
               <a:t>n_input  =  int( len(valid_indices)  ×  input_ratio )
-         =  int( 41,000  ×  0.5 )  =  20,500</a:t>
+         =  int( 44,900  ×  0.5 )  =  22,450</a:t>
             </a:r>
           </a:p>
         </p:txBody>

</xml_diff>

<commit_message>
feat: replace text tables with matplotlib charts in slides 11-12
Slide 11: NaN% comparison bar, per-threshold sample bars, CpG coverage pie.
Slide 12: β-value CDF overlay + side-by-side percentile bar chart.

Co-Authored-By: Claude Sonnet 4.6 <noreply@anthropic.com>
</commit_message>
<xml_diff>
--- a/methyl/NaN_Handling_MethylLlama.pptx
+++ b/methyl/NaN_Handling_MethylLlama.pptx
@@ -5260,26 +5260,98 @@
           </a:p>
         </p:txBody>
       </p:sp>
-      <p:sp>
-        <p:nvSpPr>
-          <p:cNvPr id="6" name="Rectangle 5"/>
+      <p:pic>
+        <p:nvPicPr>
+          <p:cNvPr id="6" name="Picture 5" descr="image.png"/>
+          <p:cNvPicPr>
+            <a:picLocks noChangeAspect="1"/>
+          </p:cNvPicPr>
+          <p:nvPr/>
+        </p:nvPicPr>
+        <p:blipFill>
+          <a:blip r:embed="rId2"/>
+          <a:stretch>
+            <a:fillRect/>
+          </a:stretch>
+        </p:blipFill>
+        <p:spPr>
+          <a:xfrm>
+            <a:off x="365760" y="1298448"/>
+            <a:ext cx="3840480" cy="2651760"/>
+          </a:xfrm>
+          <a:prstGeom prst="rect">
+            <a:avLst/>
+          </a:prstGeom>
+        </p:spPr>
+      </p:pic>
+      <p:pic>
+        <p:nvPicPr>
+          <p:cNvPr id="7" name="Picture 6" descr="image.png"/>
+          <p:cNvPicPr>
+            <a:picLocks noChangeAspect="1"/>
+          </p:cNvPicPr>
+          <p:nvPr/>
+        </p:nvPicPr>
+        <p:blipFill>
+          <a:blip r:embed="rId3"/>
+          <a:stretch>
+            <a:fillRect/>
+          </a:stretch>
+        </p:blipFill>
+        <p:spPr>
+          <a:xfrm>
+            <a:off x="4343400" y="1298448"/>
+            <a:ext cx="3931920" cy="2651760"/>
+          </a:xfrm>
+          <a:prstGeom prst="rect">
+            <a:avLst/>
+          </a:prstGeom>
+        </p:spPr>
+      </p:pic>
+      <p:pic>
+        <p:nvPicPr>
+          <p:cNvPr id="8" name="Picture 7" descr="image.png"/>
+          <p:cNvPicPr>
+            <a:picLocks noChangeAspect="1"/>
+          </p:cNvPicPr>
+          <p:nvPr/>
+        </p:nvPicPr>
+        <p:blipFill>
+          <a:blip r:embed="rId4"/>
+          <a:stretch>
+            <a:fillRect/>
+          </a:stretch>
+        </p:blipFill>
+        <p:spPr>
+          <a:xfrm>
+            <a:off x="8412480" y="1298448"/>
+            <a:ext cx="3566160" cy="2651760"/>
+          </a:xfrm>
+          <a:prstGeom prst="rect">
+            <a:avLst/>
+          </a:prstGeom>
+        </p:spPr>
+      </p:pic>
+      <p:sp>
+        <p:nvSpPr>
+          <p:cNvPr id="9" name="Rectangle 8"/>
           <p:cNvSpPr/>
           <p:nvPr/>
         </p:nvSpPr>
         <p:spPr>
           <a:xfrm>
-            <a:off x="365760" y="1261872"/>
-            <a:ext cx="5577840" cy="4937760"/>
+            <a:off x="365760" y="4096512"/>
+            <a:ext cx="2788920" cy="1078992"/>
           </a:xfrm>
           <a:prstGeom prst="rect">
             <a:avLst/>
           </a:prstGeom>
           <a:solidFill>
-            <a:srgbClr val="F2F6FB"/>
+            <a:srgbClr val="D6EAF8"/>
           </a:solidFill>
           <a:ln w="12700">
             <a:solidFill>
-              <a:srgbClr val="007AC2"/>
+              <a:srgbClr val="CCD9E8"/>
             </a:solidFill>
           </a:ln>
         </p:spPr>
@@ -5307,806 +5379,92 @@
       </p:sp>
       <p:sp>
         <p:nvSpPr>
-          <p:cNvPr id="7" name="TextBox 6"/>
-          <p:cNvSpPr txBox="1"/>
-          <p:nvPr/>
-        </p:nvSpPr>
-        <p:spPr>
-          <a:xfrm>
-            <a:off x="502920" y="1353312"/>
-            <a:ext cx="5486400" cy="274320"/>
-          </a:xfrm>
-          <a:prstGeom prst="rect">
-            <a:avLst/>
-          </a:prstGeom>
-          <a:noFill/>
-        </p:spPr>
-        <p:txBody>
-          <a:bodyPr wrap="square">
-            <a:spAutoFit/>
-          </a:bodyPr>
-          <a:lstStyle/>
-          <a:p>
-            <a:pPr algn="l"/>
-            <a:r>
-              <a:rPr sz="1100" b="1" i="0">
+          <p:cNvPr id="10" name="TextBox 9"/>
+          <p:cNvSpPr txBox="1"/>
+          <p:nvPr/>
+        </p:nvSpPr>
+        <p:spPr>
+          <a:xfrm>
+            <a:off x="365760" y="4151376"/>
+            <a:ext cx="2788920" cy="502920"/>
+          </a:xfrm>
+          <a:prstGeom prst="rect">
+            <a:avLst/>
+          </a:prstGeom>
+          <a:noFill/>
+        </p:spPr>
+        <p:txBody>
+          <a:bodyPr wrap="square">
+            <a:spAutoFit/>
+          </a:bodyPr>
+          <a:lstStyle/>
+          <a:p>
+            <a:pPr algn="ctr"/>
+            <a:r>
+              <a:rPr sz="2200" b="1" i="0">
                 <a:solidFill>
                   <a:srgbClr val="007AC2"/>
                 </a:solidFill>
               </a:rPr>
-              <a:t>PRETRAIN  (169,120 × 49,156)</a:t>
-            </a:r>
-          </a:p>
-        </p:txBody>
-      </p:sp>
-      <p:sp>
-        <p:nvSpPr>
-          <p:cNvPr id="8" name="TextBox 7"/>
-          <p:cNvSpPr txBox="1"/>
-          <p:nvPr/>
-        </p:nvSpPr>
-        <p:spPr>
-          <a:xfrm>
-            <a:off x="548640" y="1755648"/>
-            <a:ext cx="2926080" cy="347472"/>
-          </a:xfrm>
-          <a:prstGeom prst="rect">
-            <a:avLst/>
-          </a:prstGeom>
-          <a:noFill/>
-        </p:spPr>
-        <p:txBody>
-          <a:bodyPr wrap="square">
-            <a:spAutoFit/>
-          </a:bodyPr>
-          <a:lstStyle/>
-          <a:p>
-            <a:pPr algn="l"/>
-            <a:r>
-              <a:rPr sz="1300" b="0" i="0">
-                <a:solidFill>
-                  <a:srgbClr val="788FA8"/>
-                </a:solidFill>
-              </a:rPr>
-              <a:t>Total β-values</a:t>
-            </a:r>
-          </a:p>
-        </p:txBody>
-      </p:sp>
-      <p:sp>
-        <p:nvSpPr>
-          <p:cNvPr id="9" name="TextBox 8"/>
-          <p:cNvSpPr txBox="1"/>
-          <p:nvPr/>
-        </p:nvSpPr>
-        <p:spPr>
-          <a:xfrm>
-            <a:off x="3520440" y="1755648"/>
-            <a:ext cx="2286000" cy="347472"/>
-          </a:xfrm>
-          <a:prstGeom prst="rect">
-            <a:avLst/>
-          </a:prstGeom>
-          <a:noFill/>
-        </p:spPr>
-        <p:txBody>
-          <a:bodyPr wrap="square">
-            <a:spAutoFit/>
-          </a:bodyPr>
-          <a:lstStyle/>
-          <a:p>
-            <a:pPr algn="l"/>
-            <a:r>
-              <a:rPr sz="1300" b="1" i="0">
+              <a:t>8.69%</a:t>
+            </a:r>
+          </a:p>
+        </p:txBody>
+      </p:sp>
+      <p:sp>
+        <p:nvSpPr>
+          <p:cNvPr id="11" name="TextBox 10"/>
+          <p:cNvSpPr txBox="1"/>
+          <p:nvPr/>
+        </p:nvSpPr>
+        <p:spPr>
+          <a:xfrm>
+            <a:off x="365760" y="4645152"/>
+            <a:ext cx="2788920" cy="475488"/>
+          </a:xfrm>
+          <a:prstGeom prst="rect">
+            <a:avLst/>
+          </a:prstGeom>
+          <a:noFill/>
+        </p:spPr>
+        <p:txBody>
+          <a:bodyPr wrap="square">
+            <a:spAutoFit/>
+          </a:bodyPr>
+          <a:lstStyle/>
+          <a:p>
+            <a:pPr algn="ctr"/>
+            <a:r>
+              <a:rPr sz="1100" b="0" i="0">
                 <a:solidFill>
                   <a:srgbClr val="3A4A5C"/>
                 </a:solidFill>
               </a:rPr>
-              <a:t>8,313,262,720</a:t>
-            </a:r>
-          </a:p>
-        </p:txBody>
-      </p:sp>
-      <p:sp>
-        <p:nvSpPr>
-          <p:cNvPr id="10" name="TextBox 9"/>
-          <p:cNvSpPr txBox="1"/>
-          <p:nvPr/>
-        </p:nvSpPr>
-        <p:spPr>
-          <a:xfrm>
-            <a:off x="548640" y="2130552"/>
-            <a:ext cx="2926080" cy="347472"/>
-          </a:xfrm>
-          <a:prstGeom prst="rect">
-            <a:avLst/>
-          </a:prstGeom>
-          <a:noFill/>
-        </p:spPr>
-        <p:txBody>
-          <a:bodyPr wrap="square">
-            <a:spAutoFit/>
-          </a:bodyPr>
-          <a:lstStyle/>
-          <a:p>
-            <a:pPr algn="l"/>
-            <a:r>
-              <a:rPr sz="1300" b="0" i="0">
-                <a:solidFill>
-                  <a:srgbClr val="788FA8"/>
-                </a:solidFill>
-              </a:rPr>
-              <a:t>NaN count</a:t>
-            </a:r>
-          </a:p>
-        </p:txBody>
-      </p:sp>
-      <p:sp>
-        <p:nvSpPr>
-          <p:cNvPr id="11" name="TextBox 10"/>
-          <p:cNvSpPr txBox="1"/>
-          <p:nvPr/>
-        </p:nvSpPr>
-        <p:spPr>
-          <a:xfrm>
-            <a:off x="3520440" y="2130552"/>
-            <a:ext cx="2286000" cy="347472"/>
-          </a:xfrm>
-          <a:prstGeom prst="rect">
-            <a:avLst/>
-          </a:prstGeom>
-          <a:noFill/>
-        </p:spPr>
-        <p:txBody>
-          <a:bodyPr wrap="square">
-            <a:spAutoFit/>
-          </a:bodyPr>
-          <a:lstStyle/>
-          <a:p>
-            <a:pPr algn="l"/>
-            <a:r>
-              <a:rPr sz="1300" b="1" i="0">
-                <a:solidFill>
-                  <a:srgbClr val="C03030"/>
-                </a:solidFill>
-              </a:rPr>
-              <a:t>722,036,387</a:t>
-            </a:r>
-          </a:p>
-        </p:txBody>
-      </p:sp>
-      <p:sp>
-        <p:nvSpPr>
-          <p:cNvPr id="12" name="TextBox 11"/>
-          <p:cNvSpPr txBox="1"/>
-          <p:nvPr/>
-        </p:nvSpPr>
-        <p:spPr>
-          <a:xfrm>
-            <a:off x="548640" y="2505456"/>
-            <a:ext cx="2926080" cy="347472"/>
-          </a:xfrm>
-          <a:prstGeom prst="rect">
-            <a:avLst/>
-          </a:prstGeom>
-          <a:noFill/>
-        </p:spPr>
-        <p:txBody>
-          <a:bodyPr wrap="square">
-            <a:spAutoFit/>
-          </a:bodyPr>
-          <a:lstStyle/>
-          <a:p>
-            <a:pPr algn="l"/>
-            <a:r>
-              <a:rPr sz="1300" b="0" i="0">
-                <a:solidFill>
-                  <a:srgbClr val="788FA8"/>
-                </a:solidFill>
-              </a:rPr>
-              <a:t>NaN %</a:t>
-            </a:r>
-          </a:p>
-        </p:txBody>
-      </p:sp>
-      <p:sp>
-        <p:nvSpPr>
-          <p:cNvPr id="13" name="TextBox 12"/>
-          <p:cNvSpPr txBox="1"/>
-          <p:nvPr/>
-        </p:nvSpPr>
-        <p:spPr>
-          <a:xfrm>
-            <a:off x="3520440" y="2505456"/>
-            <a:ext cx="2286000" cy="347472"/>
-          </a:xfrm>
-          <a:prstGeom prst="rect">
-            <a:avLst/>
-          </a:prstGeom>
-          <a:noFill/>
-        </p:spPr>
-        <p:txBody>
-          <a:bodyPr wrap="square">
-            <a:spAutoFit/>
-          </a:bodyPr>
-          <a:lstStyle/>
-          <a:p>
-            <a:pPr algn="l"/>
-            <a:r>
-              <a:rPr sz="1300" b="1" i="0">
-                <a:solidFill>
-                  <a:srgbClr val="C03030"/>
-                </a:solidFill>
-              </a:rPr>
-              <a:t>8.69%</a:t>
-            </a:r>
-          </a:p>
-        </p:txBody>
-      </p:sp>
-      <p:sp>
-        <p:nvSpPr>
-          <p:cNvPr id="14" name="TextBox 13"/>
-          <p:cNvSpPr txBox="1"/>
-          <p:nvPr/>
-        </p:nvSpPr>
-        <p:spPr>
-          <a:xfrm>
-            <a:off x="548640" y="2880360"/>
-            <a:ext cx="2926080" cy="347472"/>
-          </a:xfrm>
-          <a:prstGeom prst="rect">
-            <a:avLst/>
-          </a:prstGeom>
-          <a:noFill/>
-        </p:spPr>
-        <p:txBody>
-          <a:bodyPr wrap="square">
-            <a:spAutoFit/>
-          </a:bodyPr>
-          <a:lstStyle/>
-          <a:p>
-            <a:pPr algn="l"/>
-            <a:r>
-              <a:rPr sz="1300" b="0" i="0">
-                <a:solidFill>
-                  <a:srgbClr val="788FA8"/>
-                </a:solidFill>
-              </a:rPr>
-              <a:t>Samples with ≥1% NaN</a:t>
-            </a:r>
-          </a:p>
-        </p:txBody>
-      </p:sp>
-      <p:sp>
-        <p:nvSpPr>
-          <p:cNvPr id="15" name="TextBox 14"/>
-          <p:cNvSpPr txBox="1"/>
-          <p:nvPr/>
-        </p:nvSpPr>
-        <p:spPr>
-          <a:xfrm>
-            <a:off x="3520440" y="2880360"/>
-            <a:ext cx="2286000" cy="347472"/>
-          </a:xfrm>
-          <a:prstGeom prst="rect">
-            <a:avLst/>
-          </a:prstGeom>
-          <a:noFill/>
-        </p:spPr>
-        <p:txBody>
-          <a:bodyPr wrap="square">
-            <a:spAutoFit/>
-          </a:bodyPr>
-          <a:lstStyle/>
-          <a:p>
-            <a:pPr algn="l"/>
-            <a:r>
-              <a:rPr sz="1300" b="1" i="0">
-                <a:solidFill>
-                  <a:srgbClr val="D47E00"/>
-                </a:solidFill>
-              </a:rPr>
-              <a:t>91,652  (54.2%)</a:t>
-            </a:r>
-          </a:p>
-        </p:txBody>
-      </p:sp>
-      <p:sp>
-        <p:nvSpPr>
-          <p:cNvPr id="16" name="TextBox 15"/>
-          <p:cNvSpPr txBox="1"/>
-          <p:nvPr/>
-        </p:nvSpPr>
-        <p:spPr>
-          <a:xfrm>
-            <a:off x="548640" y="3255263"/>
-            <a:ext cx="2926080" cy="347472"/>
-          </a:xfrm>
-          <a:prstGeom prst="rect">
-            <a:avLst/>
-          </a:prstGeom>
-          <a:noFill/>
-        </p:spPr>
-        <p:txBody>
-          <a:bodyPr wrap="square">
-            <a:spAutoFit/>
-          </a:bodyPr>
-          <a:lstStyle/>
-          <a:p>
-            <a:pPr algn="l"/>
-            <a:r>
-              <a:rPr sz="1300" b="0" i="0">
-                <a:solidFill>
-                  <a:srgbClr val="788FA8"/>
-                </a:solidFill>
-              </a:rPr>
-              <a:t>Samples with ≥10% NaN</a:t>
-            </a:r>
-          </a:p>
-        </p:txBody>
-      </p:sp>
-      <p:sp>
-        <p:nvSpPr>
-          <p:cNvPr id="17" name="TextBox 16"/>
-          <p:cNvSpPr txBox="1"/>
-          <p:nvPr/>
-        </p:nvSpPr>
-        <p:spPr>
-          <a:xfrm>
-            <a:off x="3520440" y="3255263"/>
-            <a:ext cx="2286000" cy="347472"/>
-          </a:xfrm>
-          <a:prstGeom prst="rect">
-            <a:avLst/>
-          </a:prstGeom>
-          <a:noFill/>
-        </p:spPr>
-        <p:txBody>
-          <a:bodyPr wrap="square">
-            <a:spAutoFit/>
-          </a:bodyPr>
-          <a:lstStyle/>
-          <a:p>
-            <a:pPr algn="l"/>
-            <a:r>
-              <a:rPr sz="1300" b="1" i="0">
-                <a:solidFill>
-                  <a:srgbClr val="D47E00"/>
-                </a:solidFill>
-              </a:rPr>
-              <a:t>35,329  (20.9%)</a:t>
-            </a:r>
-          </a:p>
-        </p:txBody>
-      </p:sp>
-      <p:sp>
-        <p:nvSpPr>
-          <p:cNvPr id="18" name="TextBox 17"/>
-          <p:cNvSpPr txBox="1"/>
-          <p:nvPr/>
-        </p:nvSpPr>
-        <p:spPr>
-          <a:xfrm>
-            <a:off x="548640" y="3630168"/>
-            <a:ext cx="2926080" cy="347472"/>
-          </a:xfrm>
-          <a:prstGeom prst="rect">
-            <a:avLst/>
-          </a:prstGeom>
-          <a:noFill/>
-        </p:spPr>
-        <p:txBody>
-          <a:bodyPr wrap="square">
-            <a:spAutoFit/>
-          </a:bodyPr>
-          <a:lstStyle/>
-          <a:p>
-            <a:pPr algn="l"/>
-            <a:r>
-              <a:rPr sz="1300" b="0" i="0">
-                <a:solidFill>
-                  <a:srgbClr val="788FA8"/>
-                </a:solidFill>
-              </a:rPr>
-              <a:t>Samples with ≥50% NaN</a:t>
-            </a:r>
-          </a:p>
-        </p:txBody>
-      </p:sp>
-      <p:sp>
-        <p:nvSpPr>
-          <p:cNvPr id="19" name="TextBox 18"/>
-          <p:cNvSpPr txBox="1"/>
-          <p:nvPr/>
-        </p:nvSpPr>
-        <p:spPr>
-          <a:xfrm>
-            <a:off x="3520440" y="3630168"/>
-            <a:ext cx="2286000" cy="347472"/>
-          </a:xfrm>
-          <a:prstGeom prst="rect">
-            <a:avLst/>
-          </a:prstGeom>
-          <a:noFill/>
-        </p:spPr>
-        <p:txBody>
-          <a:bodyPr wrap="square">
-            <a:spAutoFit/>
-          </a:bodyPr>
-          <a:lstStyle/>
-          <a:p>
-            <a:pPr algn="l"/>
-            <a:r>
-              <a:rPr sz="1300" b="1" i="0">
-                <a:solidFill>
-                  <a:srgbClr val="C03030"/>
-                </a:solidFill>
-              </a:rPr>
-              <a:t>16,860  (10.0%)</a:t>
-            </a:r>
-          </a:p>
-        </p:txBody>
-      </p:sp>
-      <p:sp>
-        <p:nvSpPr>
-          <p:cNvPr id="20" name="TextBox 19"/>
-          <p:cNvSpPr txBox="1"/>
-          <p:nvPr/>
-        </p:nvSpPr>
-        <p:spPr>
-          <a:xfrm>
-            <a:off x="548640" y="4005072"/>
-            <a:ext cx="2926080" cy="347472"/>
-          </a:xfrm>
-          <a:prstGeom prst="rect">
-            <a:avLst/>
-          </a:prstGeom>
-          <a:noFill/>
-        </p:spPr>
-        <p:txBody>
-          <a:bodyPr wrap="square">
-            <a:spAutoFit/>
-          </a:bodyPr>
-          <a:lstStyle/>
-          <a:p>
-            <a:pPr algn="l"/>
-            <a:r>
-              <a:rPr sz="1300" b="0" i="0">
-                <a:solidFill>
-                  <a:srgbClr val="788FA8"/>
-                </a:solidFill>
-              </a:rPr>
-              <a:t>CpGs with ≥10% NaN</a:t>
-            </a:r>
-          </a:p>
-        </p:txBody>
-      </p:sp>
-      <p:sp>
-        <p:nvSpPr>
-          <p:cNvPr id="21" name="TextBox 20"/>
-          <p:cNvSpPr txBox="1"/>
-          <p:nvPr/>
-        </p:nvSpPr>
-        <p:spPr>
-          <a:xfrm>
-            <a:off x="3520440" y="4005072"/>
-            <a:ext cx="2286000" cy="347472"/>
-          </a:xfrm>
-          <a:prstGeom prst="rect">
-            <a:avLst/>
-          </a:prstGeom>
-          <a:noFill/>
-        </p:spPr>
-        <p:txBody>
-          <a:bodyPr wrap="square">
-            <a:spAutoFit/>
-          </a:bodyPr>
-          <a:lstStyle/>
-          <a:p>
-            <a:pPr algn="l"/>
-            <a:r>
-              <a:rPr sz="1300" b="1" i="0">
-                <a:solidFill>
-                  <a:srgbClr val="D47E00"/>
-                </a:solidFill>
-              </a:rPr>
-              <a:t>24,928  (50.7%)</a:t>
-            </a:r>
-          </a:p>
-        </p:txBody>
-      </p:sp>
-      <p:sp>
-        <p:nvSpPr>
-          <p:cNvPr id="22" name="TextBox 21"/>
-          <p:cNvSpPr txBox="1"/>
-          <p:nvPr/>
-        </p:nvSpPr>
-        <p:spPr>
-          <a:xfrm>
-            <a:off x="548640" y="4379975"/>
-            <a:ext cx="2926080" cy="347472"/>
-          </a:xfrm>
-          <a:prstGeom prst="rect">
-            <a:avLst/>
-          </a:prstGeom>
-          <a:noFill/>
-        </p:spPr>
-        <p:txBody>
-          <a:bodyPr wrap="square">
-            <a:spAutoFit/>
-          </a:bodyPr>
-          <a:lstStyle/>
-          <a:p>
-            <a:pPr algn="l"/>
-            <a:r>
-              <a:rPr sz="1300" b="0" i="0">
-                <a:solidFill>
-                  <a:srgbClr val="788FA8"/>
-                </a:solidFill>
-              </a:rPr>
-              <a:t>Fully missing samples</a:t>
-            </a:r>
-          </a:p>
-        </p:txBody>
-      </p:sp>
-      <p:sp>
-        <p:nvSpPr>
-          <p:cNvPr id="23" name="TextBox 22"/>
-          <p:cNvSpPr txBox="1"/>
-          <p:nvPr/>
-        </p:nvSpPr>
-        <p:spPr>
-          <a:xfrm>
-            <a:off x="3520440" y="4379975"/>
-            <a:ext cx="2286000" cy="347472"/>
-          </a:xfrm>
-          <a:prstGeom prst="rect">
-            <a:avLst/>
-          </a:prstGeom>
-          <a:noFill/>
-        </p:spPr>
-        <p:txBody>
-          <a:bodyPr wrap="square">
-            <a:spAutoFit/>
-          </a:bodyPr>
-          <a:lstStyle/>
-          <a:p>
-            <a:pPr algn="l"/>
-            <a:r>
-              <a:rPr sz="1300" b="1" i="0">
-                <a:solidFill>
-                  <a:srgbClr val="008F6A"/>
-                </a:solidFill>
-              </a:rPr>
-              <a:t>0  ✓</a:t>
-            </a:r>
-          </a:p>
-        </p:txBody>
-      </p:sp>
-      <p:sp>
-        <p:nvSpPr>
-          <p:cNvPr id="24" name="TextBox 23"/>
-          <p:cNvSpPr txBox="1"/>
-          <p:nvPr/>
-        </p:nvSpPr>
-        <p:spPr>
-          <a:xfrm>
-            <a:off x="548640" y="4754879"/>
-            <a:ext cx="2926080" cy="347472"/>
-          </a:xfrm>
-          <a:prstGeom prst="rect">
-            <a:avLst/>
-          </a:prstGeom>
-          <a:noFill/>
-        </p:spPr>
-        <p:txBody>
-          <a:bodyPr wrap="square">
-            <a:spAutoFit/>
-          </a:bodyPr>
-          <a:lstStyle/>
-          <a:p>
-            <a:pPr algn="l"/>
-            <a:r>
-              <a:rPr sz="1300" b="0" i="0">
-                <a:solidFill>
-                  <a:srgbClr val="788FA8"/>
-                </a:solidFill>
-              </a:rPr>
-              <a:t>Fully missing CpGs</a:t>
-            </a:r>
-          </a:p>
-        </p:txBody>
-      </p:sp>
-      <p:sp>
-        <p:nvSpPr>
-          <p:cNvPr id="25" name="TextBox 24"/>
-          <p:cNvSpPr txBox="1"/>
-          <p:nvPr/>
-        </p:nvSpPr>
-        <p:spPr>
-          <a:xfrm>
-            <a:off x="3520440" y="4754879"/>
-            <a:ext cx="2286000" cy="347472"/>
-          </a:xfrm>
-          <a:prstGeom prst="rect">
-            <a:avLst/>
-          </a:prstGeom>
-          <a:noFill/>
-        </p:spPr>
-        <p:txBody>
-          <a:bodyPr wrap="square">
-            <a:spAutoFit/>
-          </a:bodyPr>
-          <a:lstStyle/>
-          <a:p>
-            <a:pPr algn="l"/>
-            <a:r>
-              <a:rPr sz="1300" b="1" i="0">
-                <a:solidFill>
-                  <a:srgbClr val="008F6A"/>
-                </a:solidFill>
-              </a:rPr>
-              <a:t>0  ✓</a:t>
-            </a:r>
-          </a:p>
-        </p:txBody>
-      </p:sp>
-      <p:sp>
-        <p:nvSpPr>
-          <p:cNvPr id="26" name="TextBox 25"/>
-          <p:cNvSpPr txBox="1"/>
-          <p:nvPr/>
-        </p:nvSpPr>
-        <p:spPr>
-          <a:xfrm>
-            <a:off x="548640" y="5129783"/>
-            <a:ext cx="2926080" cy="347472"/>
-          </a:xfrm>
-          <a:prstGeom prst="rect">
-            <a:avLst/>
-          </a:prstGeom>
-          <a:noFill/>
-        </p:spPr>
-        <p:txBody>
-          <a:bodyPr wrap="square">
-            <a:spAutoFit/>
-          </a:bodyPr>
-          <a:lstStyle/>
-          <a:p>
-            <a:pPr algn="l"/>
-            <a:r>
-              <a:rPr sz="1300" b="0" i="0">
-                <a:solidFill>
-                  <a:srgbClr val="788FA8"/>
-                </a:solidFill>
-              </a:rPr>
-              <a:t>Duplicate samples</a:t>
-            </a:r>
-          </a:p>
-        </p:txBody>
-      </p:sp>
-      <p:sp>
-        <p:nvSpPr>
-          <p:cNvPr id="27" name="TextBox 26"/>
-          <p:cNvSpPr txBox="1"/>
-          <p:nvPr/>
-        </p:nvSpPr>
-        <p:spPr>
-          <a:xfrm>
-            <a:off x="3520440" y="5129783"/>
-            <a:ext cx="2286000" cy="347472"/>
-          </a:xfrm>
-          <a:prstGeom prst="rect">
-            <a:avLst/>
-          </a:prstGeom>
-          <a:noFill/>
-        </p:spPr>
-        <p:txBody>
-          <a:bodyPr wrap="square">
-            <a:spAutoFit/>
-          </a:bodyPr>
-          <a:lstStyle/>
-          <a:p>
-            <a:pPr algn="l"/>
-            <a:r>
-              <a:rPr sz="1300" b="1" i="0">
-                <a:solidFill>
-                  <a:srgbClr val="008F6A"/>
-                </a:solidFill>
-              </a:rPr>
-              <a:t>0  ✓</a:t>
-            </a:r>
-          </a:p>
-        </p:txBody>
-      </p:sp>
-      <p:sp>
-        <p:nvSpPr>
-          <p:cNvPr id="28" name="TextBox 27"/>
-          <p:cNvSpPr txBox="1"/>
-          <p:nvPr/>
-        </p:nvSpPr>
-        <p:spPr>
-          <a:xfrm>
-            <a:off x="548640" y="5504688"/>
-            <a:ext cx="2926080" cy="347472"/>
-          </a:xfrm>
-          <a:prstGeom prst="rect">
-            <a:avLst/>
-          </a:prstGeom>
-          <a:noFill/>
-        </p:spPr>
-        <p:txBody>
-          <a:bodyPr wrap="square">
-            <a:spAutoFit/>
-          </a:bodyPr>
-          <a:lstStyle/>
-          <a:p>
-            <a:pPr algn="l"/>
-            <a:r>
-              <a:rPr sz="1300" b="0" i="0">
-                <a:solidFill>
-                  <a:srgbClr val="788FA8"/>
-                </a:solidFill>
-              </a:rPr>
-              <a:t>β out-of-range [0,1]</a:t>
-            </a:r>
-          </a:p>
-        </p:txBody>
-      </p:sp>
-      <p:sp>
-        <p:nvSpPr>
-          <p:cNvPr id="29" name="TextBox 28"/>
-          <p:cNvSpPr txBox="1"/>
-          <p:nvPr/>
-        </p:nvSpPr>
-        <p:spPr>
-          <a:xfrm>
-            <a:off x="3520440" y="5504688"/>
-            <a:ext cx="2286000" cy="347472"/>
-          </a:xfrm>
-          <a:prstGeom prst="rect">
-            <a:avLst/>
-          </a:prstGeom>
-          <a:noFill/>
-        </p:spPr>
-        <p:txBody>
-          <a:bodyPr wrap="square">
-            <a:spAutoFit/>
-          </a:bodyPr>
-          <a:lstStyle/>
-          <a:p>
-            <a:pPr algn="l"/>
-            <a:r>
-              <a:rPr sz="1300" b="1" i="0">
-                <a:solidFill>
-                  <a:srgbClr val="D47E00"/>
-                </a:solidFill>
-              </a:rPr>
-              <a:t>248,776  ⚠</a:t>
-            </a:r>
-          </a:p>
-        </p:txBody>
-      </p:sp>
-      <p:sp>
-        <p:nvSpPr>
-          <p:cNvPr id="30" name="Rectangle 29"/>
+              <a:t>Pretrain NaN %</a:t>
+            </a:r>
+          </a:p>
+        </p:txBody>
+      </p:sp>
+      <p:sp>
+        <p:nvSpPr>
+          <p:cNvPr id="12" name="Rectangle 11"/>
           <p:cNvSpPr/>
           <p:nvPr/>
         </p:nvSpPr>
         <p:spPr>
           <a:xfrm>
-            <a:off x="6172200" y="1261872"/>
-            <a:ext cx="5669280" cy="4937760"/>
+            <a:off x="3310128" y="4096512"/>
+            <a:ext cx="2788920" cy="1078992"/>
           </a:xfrm>
           <a:prstGeom prst="rect">
             <a:avLst/>
           </a:prstGeom>
           <a:solidFill>
-            <a:srgbClr val="E8F4ED"/>
+            <a:srgbClr val="FAD7D7"/>
           </a:solidFill>
           <a:ln w="12700">
             <a:solidFill>
-              <a:srgbClr val="008F6A"/>
+              <a:srgbClr val="CCD9E8"/>
             </a:solidFill>
           </a:ln>
         </p:spPr>
@@ -6134,713 +5492,260 @@
       </p:sp>
       <p:sp>
         <p:nvSpPr>
-          <p:cNvPr id="31" name="TextBox 30"/>
-          <p:cNvSpPr txBox="1"/>
-          <p:nvPr/>
-        </p:nvSpPr>
-        <p:spPr>
-          <a:xfrm>
-            <a:off x="6309360" y="1353312"/>
-            <a:ext cx="5486400" cy="274320"/>
-          </a:xfrm>
-          <a:prstGeom prst="rect">
-            <a:avLst/>
-          </a:prstGeom>
-          <a:noFill/>
-        </p:spPr>
-        <p:txBody>
-          <a:bodyPr wrap="square">
-            <a:spAutoFit/>
-          </a:bodyPr>
-          <a:lstStyle/>
-          <a:p>
-            <a:pPr algn="l"/>
-            <a:r>
-              <a:rPr sz="1100" b="1" i="0">
-                <a:solidFill>
-                  <a:srgbClr val="008F6A"/>
-                </a:solidFill>
-              </a:rPr>
-              <a:t>FINE-TUNE  (11,453 × 49,156)</a:t>
-            </a:r>
-          </a:p>
-        </p:txBody>
-      </p:sp>
-      <p:sp>
-        <p:nvSpPr>
-          <p:cNvPr id="32" name="TextBox 31"/>
-          <p:cNvSpPr txBox="1"/>
-          <p:nvPr/>
-        </p:nvSpPr>
-        <p:spPr>
-          <a:xfrm>
-            <a:off x="6309360" y="1755648"/>
-            <a:ext cx="3017520" cy="347472"/>
-          </a:xfrm>
-          <a:prstGeom prst="rect">
-            <a:avLst/>
-          </a:prstGeom>
-          <a:noFill/>
-        </p:spPr>
-        <p:txBody>
-          <a:bodyPr wrap="square">
-            <a:spAutoFit/>
-          </a:bodyPr>
-          <a:lstStyle/>
-          <a:p>
-            <a:pPr algn="l"/>
-            <a:r>
-              <a:rPr sz="1300" b="0" i="0">
-                <a:solidFill>
-                  <a:srgbClr val="788FA8"/>
-                </a:solidFill>
-              </a:rPr>
-              <a:t>Total β-values</a:t>
-            </a:r>
-          </a:p>
-        </p:txBody>
-      </p:sp>
-      <p:sp>
-        <p:nvSpPr>
-          <p:cNvPr id="33" name="TextBox 32"/>
-          <p:cNvSpPr txBox="1"/>
-          <p:nvPr/>
-        </p:nvSpPr>
-        <p:spPr>
-          <a:xfrm>
-            <a:off x="9372600" y="1755648"/>
-            <a:ext cx="2286000" cy="347472"/>
-          </a:xfrm>
-          <a:prstGeom prst="rect">
-            <a:avLst/>
-          </a:prstGeom>
-          <a:noFill/>
-        </p:spPr>
-        <p:txBody>
-          <a:bodyPr wrap="square">
-            <a:spAutoFit/>
-          </a:bodyPr>
-          <a:lstStyle/>
-          <a:p>
-            <a:pPr algn="l"/>
-            <a:r>
-              <a:rPr sz="1300" b="1" i="0">
+          <p:cNvPr id="13" name="TextBox 12"/>
+          <p:cNvSpPr txBox="1"/>
+          <p:nvPr/>
+        </p:nvSpPr>
+        <p:spPr>
+          <a:xfrm>
+            <a:off x="3310128" y="4151376"/>
+            <a:ext cx="2788920" cy="502920"/>
+          </a:xfrm>
+          <a:prstGeom prst="rect">
+            <a:avLst/>
+          </a:prstGeom>
+          <a:noFill/>
+        </p:spPr>
+        <p:txBody>
+          <a:bodyPr wrap="square">
+            <a:spAutoFit/>
+          </a:bodyPr>
+          <a:lstStyle/>
+          <a:p>
+            <a:pPr algn="ctr"/>
+            <a:r>
+              <a:rPr sz="2200" b="1" i="0">
+                <a:solidFill>
+                  <a:srgbClr val="C03030"/>
+                </a:solidFill>
+              </a:rPr>
+              <a:t>60.11%</a:t>
+            </a:r>
+          </a:p>
+        </p:txBody>
+      </p:sp>
+      <p:sp>
+        <p:nvSpPr>
+          <p:cNvPr id="14" name="TextBox 13"/>
+          <p:cNvSpPr txBox="1"/>
+          <p:nvPr/>
+        </p:nvSpPr>
+        <p:spPr>
+          <a:xfrm>
+            <a:off x="3310128" y="4645152"/>
+            <a:ext cx="2788920" cy="475488"/>
+          </a:xfrm>
+          <a:prstGeom prst="rect">
+            <a:avLst/>
+          </a:prstGeom>
+          <a:noFill/>
+        </p:spPr>
+        <p:txBody>
+          <a:bodyPr wrap="square">
+            <a:spAutoFit/>
+          </a:bodyPr>
+          <a:lstStyle/>
+          <a:p>
+            <a:pPr algn="ctr"/>
+            <a:r>
+              <a:rPr sz="1100" b="0" i="0">
                 <a:solidFill>
                   <a:srgbClr val="3A4A5C"/>
                 </a:solidFill>
               </a:rPr>
-              <a:t>562,983,668</a:t>
-            </a:r>
-          </a:p>
-        </p:txBody>
-      </p:sp>
-      <p:sp>
-        <p:nvSpPr>
-          <p:cNvPr id="34" name="TextBox 33"/>
-          <p:cNvSpPr txBox="1"/>
-          <p:nvPr/>
-        </p:nvSpPr>
-        <p:spPr>
-          <a:xfrm>
-            <a:off x="6309360" y="2130552"/>
-            <a:ext cx="3017520" cy="347472"/>
-          </a:xfrm>
-          <a:prstGeom prst="rect">
-            <a:avLst/>
-          </a:prstGeom>
-          <a:noFill/>
-        </p:spPr>
-        <p:txBody>
-          <a:bodyPr wrap="square">
-            <a:spAutoFit/>
-          </a:bodyPr>
-          <a:lstStyle/>
-          <a:p>
-            <a:pPr algn="l"/>
-            <a:r>
-              <a:rPr sz="1300" b="0" i="0">
-                <a:solidFill>
-                  <a:srgbClr val="788FA8"/>
-                </a:solidFill>
-              </a:rPr>
-              <a:t>NaN count</a:t>
-            </a:r>
-          </a:p>
-        </p:txBody>
-      </p:sp>
-      <p:sp>
-        <p:nvSpPr>
-          <p:cNvPr id="35" name="TextBox 34"/>
-          <p:cNvSpPr txBox="1"/>
-          <p:nvPr/>
-        </p:nvSpPr>
-        <p:spPr>
-          <a:xfrm>
-            <a:off x="9372600" y="2130552"/>
-            <a:ext cx="2286000" cy="347472"/>
-          </a:xfrm>
-          <a:prstGeom prst="rect">
-            <a:avLst/>
-          </a:prstGeom>
-          <a:noFill/>
-        </p:spPr>
-        <p:txBody>
-          <a:bodyPr wrap="square">
-            <a:spAutoFit/>
-          </a:bodyPr>
-          <a:lstStyle/>
-          <a:p>
-            <a:pPr algn="l"/>
-            <a:r>
-              <a:rPr sz="1300" b="1" i="0">
+              <a:t>Fine-tune NaN %</a:t>
+            </a:r>
+          </a:p>
+        </p:txBody>
+      </p:sp>
+      <p:sp>
+        <p:nvSpPr>
+          <p:cNvPr id="15" name="Rectangle 14"/>
+          <p:cNvSpPr/>
+          <p:nvPr/>
+        </p:nvSpPr>
+        <p:spPr>
+          <a:xfrm>
+            <a:off x="6254496" y="4096512"/>
+            <a:ext cx="2788920" cy="1078992"/>
+          </a:xfrm>
+          <a:prstGeom prst="rect">
+            <a:avLst/>
+          </a:prstGeom>
+          <a:solidFill>
+            <a:srgbClr val="FAD7D7"/>
+          </a:solidFill>
+          <a:ln w="12700">
+            <a:solidFill>
+              <a:srgbClr val="CCD9E8"/>
+            </a:solidFill>
+          </a:ln>
+        </p:spPr>
+        <p:style>
+          <a:lnRef idx="1">
+            <a:schemeClr val="accent1"/>
+          </a:lnRef>
+          <a:fillRef idx="3">
+            <a:schemeClr val="accent1"/>
+          </a:fillRef>
+          <a:effectRef idx="2">
+            <a:schemeClr val="accent1"/>
+          </a:effectRef>
+          <a:fontRef idx="minor">
+            <a:schemeClr val="lt1"/>
+          </a:fontRef>
+        </p:style>
+        <p:txBody>
+          <a:bodyPr rtlCol="0" anchor="ctr"/>
+          <a:lstStyle/>
+          <a:p>
+            <a:pPr algn="ctr"/>
+          </a:p>
+        </p:txBody>
+      </p:sp>
+      <p:sp>
+        <p:nvSpPr>
+          <p:cNvPr id="16" name="TextBox 15"/>
+          <p:cNvSpPr txBox="1"/>
+          <p:nvPr/>
+        </p:nvSpPr>
+        <p:spPr>
+          <a:xfrm>
+            <a:off x="6254496" y="4151376"/>
+            <a:ext cx="2788920" cy="502920"/>
+          </a:xfrm>
+          <a:prstGeom prst="rect">
+            <a:avLst/>
+          </a:prstGeom>
+          <a:noFill/>
+        </p:spPr>
+        <p:txBody>
+          <a:bodyPr wrap="square">
+            <a:spAutoFit/>
+          </a:bodyPr>
+          <a:lstStyle/>
+          <a:p>
+            <a:pPr algn="ctr"/>
+            <a:r>
+              <a:rPr sz="2200" b="1" i="0">
                 <a:solidFill>
                   <a:srgbClr val="C03030"/>
                 </a:solidFill>
               </a:rPr>
-              <a:t>338,413,244</a:t>
-            </a:r>
-          </a:p>
-        </p:txBody>
-      </p:sp>
-      <p:sp>
-        <p:nvSpPr>
-          <p:cNvPr id="36" name="TextBox 35"/>
-          <p:cNvSpPr txBox="1"/>
-          <p:nvPr/>
-        </p:nvSpPr>
-        <p:spPr>
-          <a:xfrm>
-            <a:off x="6309360" y="2505456"/>
-            <a:ext cx="3017520" cy="347472"/>
-          </a:xfrm>
-          <a:prstGeom prst="rect">
-            <a:avLst/>
-          </a:prstGeom>
-          <a:noFill/>
-        </p:spPr>
-        <p:txBody>
-          <a:bodyPr wrap="square">
-            <a:spAutoFit/>
-          </a:bodyPr>
-          <a:lstStyle/>
-          <a:p>
-            <a:pPr algn="l"/>
-            <a:r>
-              <a:rPr sz="1300" b="0" i="0">
-                <a:solidFill>
-                  <a:srgbClr val="788FA8"/>
-                </a:solidFill>
-              </a:rPr>
-              <a:t>NaN %</a:t>
-            </a:r>
-          </a:p>
-        </p:txBody>
-      </p:sp>
-      <p:sp>
-        <p:nvSpPr>
-          <p:cNvPr id="37" name="TextBox 36"/>
-          <p:cNvSpPr txBox="1"/>
-          <p:nvPr/>
-        </p:nvSpPr>
-        <p:spPr>
-          <a:xfrm>
-            <a:off x="9372600" y="2505456"/>
-            <a:ext cx="2286000" cy="347472"/>
-          </a:xfrm>
-          <a:prstGeom prst="rect">
-            <a:avLst/>
-          </a:prstGeom>
-          <a:noFill/>
-        </p:spPr>
-        <p:txBody>
-          <a:bodyPr wrap="square">
-            <a:spAutoFit/>
-          </a:bodyPr>
-          <a:lstStyle/>
-          <a:p>
-            <a:pPr algn="l"/>
-            <a:r>
-              <a:rPr sz="1300" b="1" i="0">
-                <a:solidFill>
-                  <a:srgbClr val="C03030"/>
-                </a:solidFill>
-              </a:rPr>
-              <a:t>60.11%</a:t>
-            </a:r>
-          </a:p>
-        </p:txBody>
-      </p:sp>
-      <p:sp>
-        <p:nvSpPr>
-          <p:cNvPr id="38" name="TextBox 37"/>
-          <p:cNvSpPr txBox="1"/>
-          <p:nvPr/>
-        </p:nvSpPr>
-        <p:spPr>
-          <a:xfrm>
-            <a:off x="6309360" y="2880360"/>
-            <a:ext cx="3017520" cy="347472"/>
-          </a:xfrm>
-          <a:prstGeom prst="rect">
-            <a:avLst/>
-          </a:prstGeom>
-          <a:noFill/>
-        </p:spPr>
-        <p:txBody>
-          <a:bodyPr wrap="square">
-            <a:spAutoFit/>
-          </a:bodyPr>
-          <a:lstStyle/>
-          <a:p>
-            <a:pPr algn="l"/>
-            <a:r>
-              <a:rPr sz="1300" b="0" i="0">
-                <a:solidFill>
-                  <a:srgbClr val="788FA8"/>
-                </a:solidFill>
-              </a:rPr>
-              <a:t>Samples with ≥50% NaN</a:t>
-            </a:r>
-          </a:p>
-        </p:txBody>
-      </p:sp>
-      <p:sp>
-        <p:nvSpPr>
-          <p:cNvPr id="39" name="TextBox 38"/>
-          <p:cNvSpPr txBox="1"/>
-          <p:nvPr/>
-        </p:nvSpPr>
-        <p:spPr>
-          <a:xfrm>
-            <a:off x="9372600" y="2880360"/>
-            <a:ext cx="2286000" cy="347472"/>
-          </a:xfrm>
-          <a:prstGeom prst="rect">
-            <a:avLst/>
-          </a:prstGeom>
-          <a:noFill/>
-        </p:spPr>
-        <p:txBody>
-          <a:bodyPr wrap="square">
-            <a:spAutoFit/>
-          </a:bodyPr>
-          <a:lstStyle/>
-          <a:p>
-            <a:pPr algn="l"/>
-            <a:r>
-              <a:rPr sz="1300" b="1" i="0">
-                <a:solidFill>
-                  <a:srgbClr val="C03030"/>
-                </a:solidFill>
-              </a:rPr>
-              <a:t>11,453  (100%)</a:t>
-            </a:r>
-          </a:p>
-        </p:txBody>
-      </p:sp>
-      <p:sp>
-        <p:nvSpPr>
-          <p:cNvPr id="40" name="TextBox 39"/>
-          <p:cNvSpPr txBox="1"/>
-          <p:nvPr/>
-        </p:nvSpPr>
-        <p:spPr>
-          <a:xfrm>
-            <a:off x="6309360" y="3255263"/>
-            <a:ext cx="3017520" cy="347472"/>
-          </a:xfrm>
-          <a:prstGeom prst="rect">
-            <a:avLst/>
-          </a:prstGeom>
-          <a:noFill/>
-        </p:spPr>
-        <p:txBody>
-          <a:bodyPr wrap="square">
-            <a:spAutoFit/>
-          </a:bodyPr>
-          <a:lstStyle/>
-          <a:p>
-            <a:pPr algn="l"/>
-            <a:r>
-              <a:rPr sz="1300" b="0" i="0">
-                <a:solidFill>
-                  <a:srgbClr val="788FA8"/>
-                </a:solidFill>
-              </a:rPr>
-              <a:t>CpGs with 100% NaN</a:t>
-            </a:r>
-          </a:p>
-        </p:txBody>
-      </p:sp>
-      <p:sp>
-        <p:nvSpPr>
-          <p:cNvPr id="41" name="TextBox 40"/>
-          <p:cNvSpPr txBox="1"/>
-          <p:nvPr/>
-        </p:nvSpPr>
-        <p:spPr>
-          <a:xfrm>
-            <a:off x="9372600" y="3255263"/>
-            <a:ext cx="2286000" cy="347472"/>
-          </a:xfrm>
-          <a:prstGeom prst="rect">
-            <a:avLst/>
-          </a:prstGeom>
-          <a:noFill/>
-        </p:spPr>
-        <p:txBody>
-          <a:bodyPr wrap="square">
-            <a:spAutoFit/>
-          </a:bodyPr>
-          <a:lstStyle/>
-          <a:p>
-            <a:pPr algn="l"/>
-            <a:r>
-              <a:rPr sz="1300" b="1" i="0">
-                <a:solidFill>
-                  <a:srgbClr val="C03030"/>
-                </a:solidFill>
-              </a:rPr>
-              <a:t>29,548  (60.1%)</a:t>
-            </a:r>
-          </a:p>
-        </p:txBody>
-      </p:sp>
-      <p:sp>
-        <p:nvSpPr>
-          <p:cNvPr id="42" name="TextBox 41"/>
-          <p:cNvSpPr txBox="1"/>
-          <p:nvPr/>
-        </p:nvSpPr>
-        <p:spPr>
-          <a:xfrm>
-            <a:off x="6309360" y="3630168"/>
-            <a:ext cx="3017520" cy="347472"/>
-          </a:xfrm>
-          <a:prstGeom prst="rect">
-            <a:avLst/>
-          </a:prstGeom>
-          <a:noFill/>
-        </p:spPr>
-        <p:txBody>
-          <a:bodyPr wrap="square">
-            <a:spAutoFit/>
-          </a:bodyPr>
-          <a:lstStyle/>
-          <a:p>
-            <a:pPr algn="l"/>
-            <a:r>
-              <a:rPr sz="1300" b="0" i="0">
-                <a:solidFill>
-                  <a:srgbClr val="788FA8"/>
-                </a:solidFill>
-              </a:rPr>
-              <a:t>CpGs with 0 NaN</a:t>
-            </a:r>
-          </a:p>
-        </p:txBody>
-      </p:sp>
-      <p:sp>
-        <p:nvSpPr>
-          <p:cNvPr id="43" name="TextBox 42"/>
-          <p:cNvSpPr txBox="1"/>
-          <p:nvPr/>
-        </p:nvSpPr>
-        <p:spPr>
-          <a:xfrm>
-            <a:off x="9372600" y="3630168"/>
-            <a:ext cx="2286000" cy="347472"/>
-          </a:xfrm>
-          <a:prstGeom prst="rect">
-            <a:avLst/>
-          </a:prstGeom>
-          <a:noFill/>
-        </p:spPr>
-        <p:txBody>
-          <a:bodyPr wrap="square">
-            <a:spAutoFit/>
-          </a:bodyPr>
-          <a:lstStyle/>
-          <a:p>
-            <a:pPr algn="l"/>
-            <a:r>
-              <a:rPr sz="1300" b="1" i="0">
-                <a:solidFill>
-                  <a:srgbClr val="008F6A"/>
-                </a:solidFill>
-              </a:rPr>
-              <a:t>19,608  (39.9%)</a:t>
-            </a:r>
-          </a:p>
-        </p:txBody>
-      </p:sp>
-      <p:sp>
-        <p:nvSpPr>
-          <p:cNvPr id="44" name="TextBox 43"/>
-          <p:cNvSpPr txBox="1"/>
-          <p:nvPr/>
-        </p:nvSpPr>
-        <p:spPr>
-          <a:xfrm>
-            <a:off x="6309360" y="4005072"/>
-            <a:ext cx="3017520" cy="347472"/>
-          </a:xfrm>
-          <a:prstGeom prst="rect">
-            <a:avLst/>
-          </a:prstGeom>
-          <a:noFill/>
-        </p:spPr>
-        <p:txBody>
-          <a:bodyPr wrap="square">
-            <a:spAutoFit/>
-          </a:bodyPr>
-          <a:lstStyle/>
-          <a:p>
-            <a:pPr algn="l"/>
-            <a:r>
-              <a:rPr sz="1300" b="0" i="0">
-                <a:solidFill>
-                  <a:srgbClr val="788FA8"/>
-                </a:solidFill>
-              </a:rPr>
-              <a:t>Train NaN %</a:t>
-            </a:r>
-          </a:p>
-        </p:txBody>
-      </p:sp>
-      <p:sp>
-        <p:nvSpPr>
-          <p:cNvPr id="45" name="TextBox 44"/>
-          <p:cNvSpPr txBox="1"/>
-          <p:nvPr/>
-        </p:nvSpPr>
-        <p:spPr>
-          <a:xfrm>
-            <a:off x="9372600" y="4005072"/>
-            <a:ext cx="2286000" cy="347472"/>
-          </a:xfrm>
-          <a:prstGeom prst="rect">
-            <a:avLst/>
-          </a:prstGeom>
-          <a:noFill/>
-        </p:spPr>
-        <p:txBody>
-          <a:bodyPr wrap="square">
-            <a:spAutoFit/>
-          </a:bodyPr>
-          <a:lstStyle/>
-          <a:p>
-            <a:pPr algn="l"/>
-            <a:r>
-              <a:rPr sz="1300" b="1" i="0">
+              <a:t>29,548 / 49,156</a:t>
+            </a:r>
+          </a:p>
+        </p:txBody>
+      </p:sp>
+      <p:sp>
+        <p:nvSpPr>
+          <p:cNvPr id="17" name="TextBox 16"/>
+          <p:cNvSpPr txBox="1"/>
+          <p:nvPr/>
+        </p:nvSpPr>
+        <p:spPr>
+          <a:xfrm>
+            <a:off x="6254496" y="4645152"/>
+            <a:ext cx="2788920" cy="475488"/>
+          </a:xfrm>
+          <a:prstGeom prst="rect">
+            <a:avLst/>
+          </a:prstGeom>
+          <a:noFill/>
+        </p:spPr>
+        <p:txBody>
+          <a:bodyPr wrap="square">
+            <a:spAutoFit/>
+          </a:bodyPr>
+          <a:lstStyle/>
+          <a:p>
+            <a:pPr algn="ctr"/>
+            <a:r>
+              <a:rPr sz="1100" b="0" i="0">
+                <a:solidFill>
+                  <a:srgbClr val="3A4A5C"/>
+                </a:solidFill>
+              </a:rPr>
+              <a:t>Fine-tune fully-missing
+CpGs (100% NaN)</a:t>
+            </a:r>
+          </a:p>
+        </p:txBody>
+      </p:sp>
+      <p:sp>
+        <p:nvSpPr>
+          <p:cNvPr id="18" name="Rectangle 17"/>
+          <p:cNvSpPr/>
+          <p:nvPr/>
+        </p:nvSpPr>
+        <p:spPr>
+          <a:xfrm>
+            <a:off x="9198864" y="4096512"/>
+            <a:ext cx="2788920" cy="1078992"/>
+          </a:xfrm>
+          <a:prstGeom prst="rect">
+            <a:avLst/>
+          </a:prstGeom>
+          <a:solidFill>
+            <a:srgbClr val="FDEAC8"/>
+          </a:solidFill>
+          <a:ln w="12700">
+            <a:solidFill>
+              <a:srgbClr val="CCD9E8"/>
+            </a:solidFill>
+          </a:ln>
+        </p:spPr>
+        <p:style>
+          <a:lnRef idx="1">
+            <a:schemeClr val="accent1"/>
+          </a:lnRef>
+          <a:fillRef idx="3">
+            <a:schemeClr val="accent1"/>
+          </a:fillRef>
+          <a:effectRef idx="2">
+            <a:schemeClr val="accent1"/>
+          </a:effectRef>
+          <a:fontRef idx="minor">
+            <a:schemeClr val="lt1"/>
+          </a:fontRef>
+        </p:style>
+        <p:txBody>
+          <a:bodyPr rtlCol="0" anchor="ctr"/>
+          <a:lstStyle/>
+          <a:p>
+            <a:pPr algn="ctr"/>
+          </a:p>
+        </p:txBody>
+      </p:sp>
+      <p:sp>
+        <p:nvSpPr>
+          <p:cNvPr id="19" name="TextBox 18"/>
+          <p:cNvSpPr txBox="1"/>
+          <p:nvPr/>
+        </p:nvSpPr>
+        <p:spPr>
+          <a:xfrm>
+            <a:off x="9198864" y="4151376"/>
+            <a:ext cx="2788920" cy="502920"/>
+          </a:xfrm>
+          <a:prstGeom prst="rect">
+            <a:avLst/>
+          </a:prstGeom>
+          <a:noFill/>
+        </p:spPr>
+        <p:txBody>
+          <a:bodyPr wrap="square">
+            <a:spAutoFit/>
+          </a:bodyPr>
+          <a:lstStyle/>
+          <a:p>
+            <a:pPr algn="ctr"/>
+            <a:r>
+              <a:rPr sz="2200" b="1" i="0">
                 <a:solidFill>
                   <a:srgbClr val="D47E00"/>
                 </a:solidFill>
               </a:rPr>
-              <a:t>60.11%</a:t>
-            </a:r>
-          </a:p>
-        </p:txBody>
-      </p:sp>
-      <p:sp>
-        <p:nvSpPr>
-          <p:cNvPr id="46" name="TextBox 45"/>
-          <p:cNvSpPr txBox="1"/>
-          <p:nvPr/>
-        </p:nvSpPr>
-        <p:spPr>
-          <a:xfrm>
-            <a:off x="6309360" y="4379975"/>
-            <a:ext cx="3017520" cy="347472"/>
-          </a:xfrm>
-          <a:prstGeom prst="rect">
-            <a:avLst/>
-          </a:prstGeom>
-          <a:noFill/>
-        </p:spPr>
-        <p:txBody>
-          <a:bodyPr wrap="square">
-            <a:spAutoFit/>
-          </a:bodyPr>
-          <a:lstStyle/>
-          <a:p>
-            <a:pPr algn="l"/>
-            <a:r>
-              <a:rPr sz="1300" b="0" i="0">
-                <a:solidFill>
-                  <a:srgbClr val="788FA8"/>
-                </a:solidFill>
-              </a:rPr>
-              <a:t>Valid NaN %</a:t>
-            </a:r>
-          </a:p>
-        </p:txBody>
-      </p:sp>
-      <p:sp>
-        <p:nvSpPr>
-          <p:cNvPr id="47" name="TextBox 46"/>
-          <p:cNvSpPr txBox="1"/>
-          <p:nvPr/>
-        </p:nvSpPr>
-        <p:spPr>
-          <a:xfrm>
-            <a:off x="9372600" y="4379975"/>
-            <a:ext cx="2286000" cy="347472"/>
-          </a:xfrm>
-          <a:prstGeom prst="rect">
-            <a:avLst/>
-          </a:prstGeom>
-          <a:noFill/>
-        </p:spPr>
-        <p:txBody>
-          <a:bodyPr wrap="square">
-            <a:spAutoFit/>
-          </a:bodyPr>
-          <a:lstStyle/>
-          <a:p>
-            <a:pPr algn="l"/>
-            <a:r>
-              <a:rPr sz="1300" b="1" i="0">
-                <a:solidFill>
-                  <a:srgbClr val="D47E00"/>
-                </a:solidFill>
-              </a:rPr>
-              <a:t>60.11%</a:t>
-            </a:r>
-          </a:p>
-        </p:txBody>
-      </p:sp>
-      <p:sp>
-        <p:nvSpPr>
-          <p:cNvPr id="48" name="TextBox 47"/>
-          <p:cNvSpPr txBox="1"/>
-          <p:nvPr/>
-        </p:nvSpPr>
-        <p:spPr>
-          <a:xfrm>
-            <a:off x="6309360" y="4754879"/>
-            <a:ext cx="3017520" cy="347472"/>
-          </a:xfrm>
-          <a:prstGeom prst="rect">
-            <a:avLst/>
-          </a:prstGeom>
-          <a:noFill/>
-        </p:spPr>
-        <p:txBody>
-          <a:bodyPr wrap="square">
-            <a:spAutoFit/>
-          </a:bodyPr>
-          <a:lstStyle/>
-          <a:p>
-            <a:pPr algn="l"/>
-            <a:r>
-              <a:rPr sz="1300" b="0" i="0">
-                <a:solidFill>
-                  <a:srgbClr val="788FA8"/>
-                </a:solidFill>
-              </a:rPr>
-              <a:t>Test  NaN %</a:t>
-            </a:r>
-          </a:p>
-        </p:txBody>
-      </p:sp>
-      <p:sp>
-        <p:nvSpPr>
-          <p:cNvPr id="49" name="TextBox 48"/>
-          <p:cNvSpPr txBox="1"/>
-          <p:nvPr/>
-        </p:nvSpPr>
-        <p:spPr>
-          <a:xfrm>
-            <a:off x="9372600" y="4754879"/>
-            <a:ext cx="2286000" cy="347472"/>
-          </a:xfrm>
-          <a:prstGeom prst="rect">
-            <a:avLst/>
-          </a:prstGeom>
-          <a:noFill/>
-        </p:spPr>
-        <p:txBody>
-          <a:bodyPr wrap="square">
-            <a:spAutoFit/>
-          </a:bodyPr>
-          <a:lstStyle/>
-          <a:p>
-            <a:pPr algn="l"/>
-            <a:r>
-              <a:rPr sz="1300" b="1" i="0">
-                <a:solidFill>
-                  <a:srgbClr val="D47E00"/>
-                </a:solidFill>
-              </a:rPr>
-              <a:t>60.11%</a:t>
-            </a:r>
-          </a:p>
-        </p:txBody>
-      </p:sp>
-      <p:sp>
-        <p:nvSpPr>
-          <p:cNvPr id="50" name="TextBox 49"/>
-          <p:cNvSpPr txBox="1"/>
-          <p:nvPr/>
-        </p:nvSpPr>
-        <p:spPr>
-          <a:xfrm>
-            <a:off x="6309360" y="5129783"/>
-            <a:ext cx="3017520" cy="347472"/>
-          </a:xfrm>
-          <a:prstGeom prst="rect">
-            <a:avLst/>
-          </a:prstGeom>
-          <a:noFill/>
-        </p:spPr>
-        <p:txBody>
-          <a:bodyPr wrap="square">
-            <a:spAutoFit/>
-          </a:bodyPr>
-          <a:lstStyle/>
-          <a:p>
-            <a:pPr algn="l"/>
-            <a:r>
-              <a:rPr sz="1300" b="0" i="0">
-                <a:solidFill>
-                  <a:srgbClr val="788FA8"/>
-                </a:solidFill>
-              </a:rPr>
-              <a:t>Duplicate sample IDs</a:t>
-            </a:r>
-          </a:p>
-        </p:txBody>
-      </p:sp>
-      <p:sp>
-        <p:nvSpPr>
-          <p:cNvPr id="51" name="TextBox 50"/>
-          <p:cNvSpPr txBox="1"/>
-          <p:nvPr/>
-        </p:nvSpPr>
-        <p:spPr>
-          <a:xfrm>
-            <a:off x="9372600" y="5129783"/>
-            <a:ext cx="2286000" cy="347472"/>
-          </a:xfrm>
-          <a:prstGeom prst="rect">
-            <a:avLst/>
-          </a:prstGeom>
-          <a:noFill/>
-        </p:spPr>
-        <p:txBody>
-          <a:bodyPr wrap="square">
-            <a:spAutoFit/>
-          </a:bodyPr>
-          <a:lstStyle/>
-          <a:p>
-            <a:pPr algn="l"/>
-            <a:r>
-              <a:rPr sz="1300" b="1" i="0">
-                <a:solidFill>
-                  <a:srgbClr val="C03030"/>
-                </a:solidFill>
-              </a:rPr>
               <a:t>5,992  ⚠</a:t>
             </a:r>
           </a:p>
@@ -6848,82 +5753,49 @@
       </p:sp>
       <p:sp>
         <p:nvSpPr>
-          <p:cNvPr id="52" name="TextBox 51"/>
-          <p:cNvSpPr txBox="1"/>
-          <p:nvPr/>
-        </p:nvSpPr>
-        <p:spPr>
-          <a:xfrm>
-            <a:off x="6309360" y="5504688"/>
-            <a:ext cx="3017520" cy="347472"/>
-          </a:xfrm>
-          <a:prstGeom prst="rect">
-            <a:avLst/>
-          </a:prstGeom>
-          <a:noFill/>
-        </p:spPr>
-        <p:txBody>
-          <a:bodyPr wrap="square">
-            <a:spAutoFit/>
-          </a:bodyPr>
-          <a:lstStyle/>
-          <a:p>
-            <a:pPr algn="l"/>
-            <a:r>
-              <a:rPr sz="1300" b="0" i="0">
-                <a:solidFill>
-                  <a:srgbClr val="788FA8"/>
-                </a:solidFill>
-              </a:rPr>
-              <a:t>β out-of-range [0,1]</a:t>
-            </a:r>
-          </a:p>
-        </p:txBody>
-      </p:sp>
-      <p:sp>
-        <p:nvSpPr>
-          <p:cNvPr id="53" name="TextBox 52"/>
-          <p:cNvSpPr txBox="1"/>
-          <p:nvPr/>
-        </p:nvSpPr>
-        <p:spPr>
-          <a:xfrm>
-            <a:off x="9372600" y="5504688"/>
-            <a:ext cx="2286000" cy="347472"/>
-          </a:xfrm>
-          <a:prstGeom prst="rect">
-            <a:avLst/>
-          </a:prstGeom>
-          <a:noFill/>
-        </p:spPr>
-        <p:txBody>
-          <a:bodyPr wrap="square">
-            <a:spAutoFit/>
-          </a:bodyPr>
-          <a:lstStyle/>
-          <a:p>
-            <a:pPr algn="l"/>
-            <a:r>
-              <a:rPr sz="1300" b="1" i="0">
-                <a:solidFill>
-                  <a:srgbClr val="008F6A"/>
-                </a:solidFill>
-              </a:rPr>
-              <a:t>0  ✓</a:t>
-            </a:r>
-          </a:p>
-        </p:txBody>
-      </p:sp>
-      <p:sp>
-        <p:nvSpPr>
-          <p:cNvPr id="54" name="Rectangle 53"/>
+          <p:cNvPr id="20" name="TextBox 19"/>
+          <p:cNvSpPr txBox="1"/>
+          <p:nvPr/>
+        </p:nvSpPr>
+        <p:spPr>
+          <a:xfrm>
+            <a:off x="9198864" y="4645152"/>
+            <a:ext cx="2788920" cy="475488"/>
+          </a:xfrm>
+          <a:prstGeom prst="rect">
+            <a:avLst/>
+          </a:prstGeom>
+          <a:noFill/>
+        </p:spPr>
+        <p:txBody>
+          <a:bodyPr wrap="square">
+            <a:spAutoFit/>
+          </a:bodyPr>
+          <a:lstStyle/>
+          <a:p>
+            <a:pPr algn="ctr"/>
+            <a:r>
+              <a:rPr sz="1100" b="0" i="0">
+                <a:solidFill>
+                  <a:srgbClr val="3A4A5C"/>
+                </a:solidFill>
+              </a:rPr>
+              <a:t>Fine-tune duplicate
+sample IDs</a:t>
+            </a:r>
+          </a:p>
+        </p:txBody>
+      </p:sp>
+      <p:sp>
+        <p:nvSpPr>
+          <p:cNvPr id="21" name="Rectangle 20"/>
           <p:cNvSpPr/>
           <p:nvPr/>
         </p:nvSpPr>
         <p:spPr>
           <a:xfrm>
-            <a:off x="365760" y="6327648"/>
-            <a:ext cx="11475720" cy="384048"/>
+            <a:off x="365760" y="5321808"/>
+            <a:ext cx="11475720" cy="713232"/>
           </a:xfrm>
           <a:prstGeom prst="rect">
             <a:avLst/>
@@ -6961,34 +5833,34 @@
       </p:sp>
       <p:sp>
         <p:nvSpPr>
-          <p:cNvPr id="55" name="TextBox 54"/>
-          <p:cNvSpPr txBox="1"/>
-          <p:nvPr/>
-        </p:nvSpPr>
-        <p:spPr>
-          <a:xfrm>
-            <a:off x="502920" y="6373368"/>
-            <a:ext cx="11155680" cy="292608"/>
-          </a:xfrm>
-          <a:prstGeom prst="rect">
-            <a:avLst/>
-          </a:prstGeom>
-          <a:noFill/>
-        </p:spPr>
-        <p:txBody>
-          <a:bodyPr wrap="square">
-            <a:spAutoFit/>
-          </a:bodyPr>
-          <a:lstStyle/>
-          <a:p>
-            <a:pPr algn="l"/>
-            <a:r>
-              <a:rPr sz="1200" b="1" i="0">
+          <p:cNvPr id="22" name="TextBox 21"/>
+          <p:cNvSpPr txBox="1"/>
+          <p:nvPr/>
+        </p:nvSpPr>
+        <p:spPr>
+          <a:xfrm>
+            <a:off x="502920" y="5376672"/>
+            <a:ext cx="11155680" cy="594360"/>
+          </a:xfrm>
+          <a:prstGeom prst="rect">
+            <a:avLst/>
+          </a:prstGeom>
+          <a:noFill/>
+        </p:spPr>
+        <p:txBody>
+          <a:bodyPr wrap="square">
+            <a:spAutoFit/>
+          </a:bodyPr>
+          <a:lstStyle/>
+          <a:p>
+            <a:pPr algn="l"/>
+            <a:r>
+              <a:rPr sz="1300" b="1" i="0">
                 <a:solidFill>
                   <a:srgbClr val="004F80"/>
                 </a:solidFill>
               </a:rPr>
-              <a:t>Key insight:  Fine-tune = pure 450k-array dataset  (29,548 CpGs are 100% NaN across ALL samples → single array type)  ·  Pretrain NaN = 8.69% → mostly EPIC-array samples</a:t>
+              <a:t>Key insight:  Fine-tune = pure 450k-array dataset — same 29,548 CpGs are 100% NaN across every single sample.  Pretrain = mostly EPIC-array (NaN only 8.69%).  The WCEDCollator valid_mask handles both correctly.</a:t>
             </a:r>
           </a:p>
         </p:txBody>
@@ -7125,7 +5997,7 @@
                   <a:srgbClr val="788FA8"/>
                 </a:solidFill>
               </a:rPr>
-              <a:t>Job 44584079  ·  Valid values only (NaN excluded from all statistics)</a:t>
+              <a:t>Valid values only  ·  NaN excluded  ·  Pretrain: 7.6B values  ·  Fine-tune: 225M values</a:t>
             </a:r>
           </a:p>
         </p:txBody>
@@ -7173,26 +6045,74 @@
           </a:p>
         </p:txBody>
       </p:sp>
-      <p:sp>
-        <p:nvSpPr>
-          <p:cNvPr id="6" name="Rectangle 5"/>
+      <p:pic>
+        <p:nvPicPr>
+          <p:cNvPr id="6" name="Picture 5" descr="image.png"/>
+          <p:cNvPicPr>
+            <a:picLocks noChangeAspect="1"/>
+          </p:cNvPicPr>
+          <p:nvPr/>
+        </p:nvPicPr>
+        <p:blipFill>
+          <a:blip r:embed="rId2"/>
+          <a:stretch>
+            <a:fillRect/>
+          </a:stretch>
+        </p:blipFill>
+        <p:spPr>
+          <a:xfrm>
+            <a:off x="365760" y="1280160"/>
+            <a:ext cx="6217920" cy="4023360"/>
+          </a:xfrm>
+          <a:prstGeom prst="rect">
+            <a:avLst/>
+          </a:prstGeom>
+        </p:spPr>
+      </p:pic>
+      <p:pic>
+        <p:nvPicPr>
+          <p:cNvPr id="7" name="Picture 6" descr="image.png"/>
+          <p:cNvPicPr>
+            <a:picLocks noChangeAspect="1"/>
+          </p:cNvPicPr>
+          <p:nvPr/>
+        </p:nvPicPr>
+        <p:blipFill>
+          <a:blip r:embed="rId3"/>
+          <a:stretch>
+            <a:fillRect/>
+          </a:stretch>
+        </p:blipFill>
+        <p:spPr>
+          <a:xfrm>
+            <a:off x="6766560" y="1280160"/>
+            <a:ext cx="5120640" cy="4023360"/>
+          </a:xfrm>
+          <a:prstGeom prst="rect">
+            <a:avLst/>
+          </a:prstGeom>
+        </p:spPr>
+      </p:pic>
+      <p:sp>
+        <p:nvSpPr>
+          <p:cNvPr id="8" name="Rectangle 7"/>
           <p:cNvSpPr/>
           <p:nvPr/>
         </p:nvSpPr>
         <p:spPr>
           <a:xfrm>
-            <a:off x="365760" y="1261872"/>
-            <a:ext cx="5029200" cy="5120640"/>
+            <a:off x="365760" y="5468112"/>
+            <a:ext cx="2788920" cy="841248"/>
           </a:xfrm>
           <a:prstGeom prst="rect">
             <a:avLst/>
           </a:prstGeom>
           <a:solidFill>
-            <a:srgbClr val="F2F6FB"/>
+            <a:srgbClr val="D6EAF8"/>
           </a:solidFill>
           <a:ln w="12700">
             <a:solidFill>
-              <a:srgbClr val="007AC2"/>
+              <a:srgbClr val="CCD9E8"/>
             </a:solidFill>
           </a:ln>
         </p:spPr>
@@ -7220,102 +6140,34 @@
       </p:sp>
       <p:sp>
         <p:nvSpPr>
-          <p:cNvPr id="7" name="TextBox 6"/>
-          <p:cNvSpPr txBox="1"/>
-          <p:nvPr/>
-        </p:nvSpPr>
-        <p:spPr>
-          <a:xfrm>
-            <a:off x="502920" y="1353312"/>
-            <a:ext cx="5486400" cy="274320"/>
-          </a:xfrm>
-          <a:prstGeom prst="rect">
-            <a:avLst/>
-          </a:prstGeom>
-          <a:noFill/>
-        </p:spPr>
-        <p:txBody>
-          <a:bodyPr wrap="square">
-            <a:spAutoFit/>
-          </a:bodyPr>
-          <a:lstStyle/>
-          <a:p>
-            <a:pPr algn="l"/>
-            <a:r>
-              <a:rPr sz="1100" b="1" i="0">
+          <p:cNvPr id="9" name="TextBox 8"/>
+          <p:cNvSpPr txBox="1"/>
+          <p:nvPr/>
+        </p:nvSpPr>
+        <p:spPr>
+          <a:xfrm>
+            <a:off x="365760" y="5486400"/>
+            <a:ext cx="2788920" cy="438912"/>
+          </a:xfrm>
+          <a:prstGeom prst="rect">
+            <a:avLst/>
+          </a:prstGeom>
+          <a:noFill/>
+        </p:spPr>
+        <p:txBody>
+          <a:bodyPr wrap="square">
+            <a:spAutoFit/>
+          </a:bodyPr>
+          <a:lstStyle/>
+          <a:p>
+            <a:pPr algn="ctr"/>
+            <a:r>
+              <a:rPr sz="2000" b="1" i="0">
                 <a:solidFill>
                   <a:srgbClr val="007AC2"/>
                 </a:solidFill>
               </a:rPr>
-              <a:t>PRETRAIN  β-VALUE DISTRIBUTION</a:t>
-            </a:r>
-          </a:p>
-        </p:txBody>
-      </p:sp>
-      <p:sp>
-        <p:nvSpPr>
-          <p:cNvPr id="8" name="TextBox 7"/>
-          <p:cNvSpPr txBox="1"/>
-          <p:nvPr/>
-        </p:nvSpPr>
-        <p:spPr>
-          <a:xfrm>
-            <a:off x="502920" y="1627632"/>
-            <a:ext cx="4663440" cy="274320"/>
-          </a:xfrm>
-          <a:prstGeom prst="rect">
-            <a:avLst/>
-          </a:prstGeom>
-          <a:noFill/>
-        </p:spPr>
-        <p:txBody>
-          <a:bodyPr wrap="square">
-            <a:spAutoFit/>
-          </a:bodyPr>
-          <a:lstStyle/>
-          <a:p>
-            <a:pPr algn="l"/>
-            <a:r>
-              <a:rPr sz="1200" b="0" i="1">
-                <a:solidFill>
-                  <a:srgbClr val="788FA8"/>
-                </a:solidFill>
-              </a:rPr>
-              <a:t>7,591,226,333 valid values sampled</a:t>
-            </a:r>
-          </a:p>
-        </p:txBody>
-      </p:sp>
-      <p:sp>
-        <p:nvSpPr>
-          <p:cNvPr id="9" name="TextBox 8"/>
-          <p:cNvSpPr txBox="1"/>
-          <p:nvPr/>
-        </p:nvSpPr>
-        <p:spPr>
-          <a:xfrm>
-            <a:off x="548640" y="1938528"/>
-            <a:ext cx="1828800" cy="365760"/>
-          </a:xfrm>
-          <a:prstGeom prst="rect">
-            <a:avLst/>
-          </a:prstGeom>
-          <a:noFill/>
-        </p:spPr>
-        <p:txBody>
-          <a:bodyPr wrap="square">
-            <a:spAutoFit/>
-          </a:bodyPr>
-          <a:lstStyle/>
-          <a:p>
-            <a:pPr algn="l"/>
-            <a:r>
-              <a:rPr sz="1300" b="0" i="0">
-                <a:solidFill>
-                  <a:srgbClr val="788FA8"/>
-                </a:solidFill>
-              </a:rPr>
-              <a:t>0%   (min)</a:t>
+              <a:t>0.286</a:t>
             </a:r>
           </a:p>
         </p:txBody>
@@ -7328,63 +6180,74 @@
         </p:nvSpPr>
         <p:spPr>
           <a:xfrm>
-            <a:off x="2423160" y="1938528"/>
-            <a:ext cx="1371600" cy="365760"/>
-          </a:xfrm>
-          <a:prstGeom prst="rect">
-            <a:avLst/>
-          </a:prstGeom>
-          <a:noFill/>
-        </p:spPr>
-        <p:txBody>
-          <a:bodyPr wrap="square">
-            <a:spAutoFit/>
-          </a:bodyPr>
-          <a:lstStyle/>
-          <a:p>
-            <a:pPr algn="l"/>
-            <a:r>
-              <a:rPr sz="1400" b="1" i="0">
-                <a:solidFill>
-                  <a:srgbClr val="C03030"/>
-                </a:solidFill>
-              </a:rPr>
-              <a:t>-0.3389</a:t>
-            </a:r>
-          </a:p>
-        </p:txBody>
-      </p:sp>
-      <p:sp>
-        <p:nvSpPr>
-          <p:cNvPr id="11" name="TextBox 10"/>
-          <p:cNvSpPr txBox="1"/>
-          <p:nvPr/>
-        </p:nvSpPr>
-        <p:spPr>
-          <a:xfrm>
-            <a:off x="548640" y="2414016"/>
-            <a:ext cx="1828800" cy="365760"/>
-          </a:xfrm>
-          <a:prstGeom prst="rect">
-            <a:avLst/>
-          </a:prstGeom>
-          <a:noFill/>
-        </p:spPr>
-        <p:txBody>
-          <a:bodyPr wrap="square">
-            <a:spAutoFit/>
-          </a:bodyPr>
-          <a:lstStyle/>
-          <a:p>
-            <a:pPr algn="l"/>
-            <a:r>
-              <a:rPr sz="1300" b="0" i="0">
-                <a:solidFill>
-                  <a:srgbClr val="788FA8"/>
-                </a:solidFill>
-              </a:rPr>
-              <a:t>1%</a:t>
-            </a:r>
+            <a:off x="365760" y="5925312"/>
+            <a:ext cx="2788920" cy="329184"/>
+          </a:xfrm>
+          <a:prstGeom prst="rect">
+            <a:avLst/>
+          </a:prstGeom>
+          <a:noFill/>
+        </p:spPr>
+        <p:txBody>
+          <a:bodyPr wrap="square">
+            <a:spAutoFit/>
+          </a:bodyPr>
+          <a:lstStyle/>
+          <a:p>
+            <a:pPr algn="ctr"/>
+            <a:r>
+              <a:rPr sz="1100" b="0" i="0">
+                <a:solidFill>
+                  <a:srgbClr val="3A4A5C"/>
+                </a:solidFill>
+              </a:rPr>
+              <a:t>Pretrain median β</a:t>
+            </a:r>
+          </a:p>
+        </p:txBody>
+      </p:sp>
+      <p:sp>
+        <p:nvSpPr>
+          <p:cNvPr id="11" name="Rectangle 10"/>
+          <p:cNvSpPr/>
+          <p:nvPr/>
+        </p:nvSpPr>
+        <p:spPr>
+          <a:xfrm>
+            <a:off x="3310128" y="5468112"/>
+            <a:ext cx="2788920" cy="841248"/>
+          </a:xfrm>
+          <a:prstGeom prst="rect">
+            <a:avLst/>
+          </a:prstGeom>
+          <a:solidFill>
+            <a:srgbClr val="D5F0E4"/>
+          </a:solidFill>
+          <a:ln w="12700">
+            <a:solidFill>
+              <a:srgbClr val="CCD9E8"/>
+            </a:solidFill>
+          </a:ln>
+        </p:spPr>
+        <p:style>
+          <a:lnRef idx="1">
+            <a:schemeClr val="accent1"/>
+          </a:lnRef>
+          <a:fillRef idx="3">
+            <a:schemeClr val="accent1"/>
+          </a:fillRef>
+          <a:effectRef idx="2">
+            <a:schemeClr val="accent1"/>
+          </a:effectRef>
+          <a:fontRef idx="minor">
+            <a:schemeClr val="lt1"/>
+          </a:fontRef>
+        </p:style>
+        <p:txBody>
+          <a:bodyPr rtlCol="0" anchor="ctr"/>
+          <a:lstStyle/>
+          <a:p>
+            <a:pPr algn="ctr"/>
           </a:p>
         </p:txBody>
       </p:sp>
@@ -7396,518 +6259,302 @@
         </p:nvSpPr>
         <p:spPr>
           <a:xfrm>
-            <a:off x="2423160" y="2414016"/>
-            <a:ext cx="1371600" cy="365760"/>
-          </a:xfrm>
-          <a:prstGeom prst="rect">
-            <a:avLst/>
-          </a:prstGeom>
-          <a:noFill/>
-        </p:spPr>
-        <p:txBody>
-          <a:bodyPr wrap="square">
-            <a:spAutoFit/>
-          </a:bodyPr>
-          <a:lstStyle/>
-          <a:p>
-            <a:pPr algn="l"/>
-            <a:r>
-              <a:rPr sz="1400" b="1" i="0">
+            <a:off x="3310128" y="5486400"/>
+            <a:ext cx="2788920" cy="438912"/>
+          </a:xfrm>
+          <a:prstGeom prst="rect">
+            <a:avLst/>
+          </a:prstGeom>
+          <a:noFill/>
+        </p:spPr>
+        <p:txBody>
+          <a:bodyPr wrap="square">
+            <a:spAutoFit/>
+          </a:bodyPr>
+          <a:lstStyle/>
+          <a:p>
+            <a:pPr algn="ctr"/>
+            <a:r>
+              <a:rPr sz="2000" b="1" i="0">
+                <a:solidFill>
+                  <a:srgbClr val="008F6A"/>
+                </a:solidFill>
+              </a:rPr>
+              <a:t>0.083</a:t>
+            </a:r>
+          </a:p>
+        </p:txBody>
+      </p:sp>
+      <p:sp>
+        <p:nvSpPr>
+          <p:cNvPr id="13" name="TextBox 12"/>
+          <p:cNvSpPr txBox="1"/>
+          <p:nvPr/>
+        </p:nvSpPr>
+        <p:spPr>
+          <a:xfrm>
+            <a:off x="3310128" y="5925312"/>
+            <a:ext cx="2788920" cy="329184"/>
+          </a:xfrm>
+          <a:prstGeom prst="rect">
+            <a:avLst/>
+          </a:prstGeom>
+          <a:noFill/>
+        </p:spPr>
+        <p:txBody>
+          <a:bodyPr wrap="square">
+            <a:spAutoFit/>
+          </a:bodyPr>
+          <a:lstStyle/>
+          <a:p>
+            <a:pPr algn="ctr"/>
+            <a:r>
+              <a:rPr sz="1100" b="0" i="0">
                 <a:solidFill>
                   <a:srgbClr val="3A4A5C"/>
                 </a:solidFill>
               </a:rPr>
-              <a:t> 0.0100</a:t>
-            </a:r>
-          </a:p>
-        </p:txBody>
-      </p:sp>
-      <p:sp>
-        <p:nvSpPr>
-          <p:cNvPr id="13" name="TextBox 12"/>
-          <p:cNvSpPr txBox="1"/>
-          <p:nvPr/>
-        </p:nvSpPr>
-        <p:spPr>
-          <a:xfrm>
-            <a:off x="548640" y="2889504"/>
-            <a:ext cx="1828800" cy="365760"/>
-          </a:xfrm>
-          <a:prstGeom prst="rect">
-            <a:avLst/>
-          </a:prstGeom>
-          <a:noFill/>
-        </p:spPr>
-        <p:txBody>
-          <a:bodyPr wrap="square">
-            <a:spAutoFit/>
-          </a:bodyPr>
-          <a:lstStyle/>
-          <a:p>
-            <a:pPr algn="l"/>
-            <a:r>
-              <a:rPr sz="1300" b="0" i="0">
-                <a:solidFill>
-                  <a:srgbClr val="788FA8"/>
-                </a:solidFill>
-              </a:rPr>
-              <a:t>5%</a:t>
-            </a:r>
-          </a:p>
-        </p:txBody>
-      </p:sp>
-      <p:sp>
-        <p:nvSpPr>
-          <p:cNvPr id="14" name="TextBox 13"/>
-          <p:cNvSpPr txBox="1"/>
-          <p:nvPr/>
-        </p:nvSpPr>
-        <p:spPr>
-          <a:xfrm>
-            <a:off x="2423160" y="2889504"/>
-            <a:ext cx="1371600" cy="365760"/>
-          </a:xfrm>
-          <a:prstGeom prst="rect">
-            <a:avLst/>
-          </a:prstGeom>
-          <a:noFill/>
-        </p:spPr>
-        <p:txBody>
-          <a:bodyPr wrap="square">
-            <a:spAutoFit/>
-          </a:bodyPr>
-          <a:lstStyle/>
-          <a:p>
-            <a:pPr algn="l"/>
-            <a:r>
-              <a:rPr sz="1400" b="1" i="0">
+              <a:t>Fine-tune median β</a:t>
+            </a:r>
+          </a:p>
+        </p:txBody>
+      </p:sp>
+      <p:sp>
+        <p:nvSpPr>
+          <p:cNvPr id="14" name="Rectangle 13"/>
+          <p:cNvSpPr/>
+          <p:nvPr/>
+        </p:nvSpPr>
+        <p:spPr>
+          <a:xfrm>
+            <a:off x="6254496" y="5468112"/>
+            <a:ext cx="2788920" cy="841248"/>
+          </a:xfrm>
+          <a:prstGeom prst="rect">
+            <a:avLst/>
+          </a:prstGeom>
+          <a:solidFill>
+            <a:srgbClr val="FDEAC8"/>
+          </a:solidFill>
+          <a:ln w="12700">
+            <a:solidFill>
+              <a:srgbClr val="CCD9E8"/>
+            </a:solidFill>
+          </a:ln>
+        </p:spPr>
+        <p:style>
+          <a:lnRef idx="1">
+            <a:schemeClr val="accent1"/>
+          </a:lnRef>
+          <a:fillRef idx="3">
+            <a:schemeClr val="accent1"/>
+          </a:fillRef>
+          <a:effectRef idx="2">
+            <a:schemeClr val="accent1"/>
+          </a:effectRef>
+          <a:fontRef idx="minor">
+            <a:schemeClr val="lt1"/>
+          </a:fontRef>
+        </p:style>
+        <p:txBody>
+          <a:bodyPr rtlCol="0" anchor="ctr"/>
+          <a:lstStyle/>
+          <a:p>
+            <a:pPr algn="ctr"/>
+          </a:p>
+        </p:txBody>
+      </p:sp>
+      <p:sp>
+        <p:nvSpPr>
+          <p:cNvPr id="15" name="TextBox 14"/>
+          <p:cNvSpPr txBox="1"/>
+          <p:nvPr/>
+        </p:nvSpPr>
+        <p:spPr>
+          <a:xfrm>
+            <a:off x="6254496" y="5486400"/>
+            <a:ext cx="2788920" cy="438912"/>
+          </a:xfrm>
+          <a:prstGeom prst="rect">
+            <a:avLst/>
+          </a:prstGeom>
+          <a:noFill/>
+        </p:spPr>
+        <p:txBody>
+          <a:bodyPr wrap="square">
+            <a:spAutoFit/>
+          </a:bodyPr>
+          <a:lstStyle/>
+          <a:p>
+            <a:pPr algn="ctr"/>
+            <a:r>
+              <a:rPr sz="2000" b="1" i="0">
+                <a:solidFill>
+                  <a:srgbClr val="D47E00"/>
+                </a:solidFill>
+              </a:rPr>
+              <a:t>248,776 ⚠</a:t>
+            </a:r>
+          </a:p>
+        </p:txBody>
+      </p:sp>
+      <p:sp>
+        <p:nvSpPr>
+          <p:cNvPr id="16" name="TextBox 15"/>
+          <p:cNvSpPr txBox="1"/>
+          <p:nvPr/>
+        </p:nvSpPr>
+        <p:spPr>
+          <a:xfrm>
+            <a:off x="6254496" y="5925312"/>
+            <a:ext cx="2788920" cy="329184"/>
+          </a:xfrm>
+          <a:prstGeom prst="rect">
+            <a:avLst/>
+          </a:prstGeom>
+          <a:noFill/>
+        </p:spPr>
+        <p:txBody>
+          <a:bodyPr wrap="square">
+            <a:spAutoFit/>
+          </a:bodyPr>
+          <a:lstStyle/>
+          <a:p>
+            <a:pPr algn="ctr"/>
+            <a:r>
+              <a:rPr sz="1100" b="0" i="0">
                 <a:solidFill>
                   <a:srgbClr val="3A4A5C"/>
                 </a:solidFill>
               </a:rPr>
-              <a:t> 0.0236</a:t>
-            </a:r>
-          </a:p>
-        </p:txBody>
-      </p:sp>
-      <p:sp>
-        <p:nvSpPr>
-          <p:cNvPr id="15" name="TextBox 14"/>
-          <p:cNvSpPr txBox="1"/>
-          <p:nvPr/>
-        </p:nvSpPr>
-        <p:spPr>
-          <a:xfrm>
-            <a:off x="548640" y="3364992"/>
-            <a:ext cx="1828800" cy="365760"/>
-          </a:xfrm>
-          <a:prstGeom prst="rect">
-            <a:avLst/>
-          </a:prstGeom>
-          <a:noFill/>
-        </p:spPr>
-        <p:txBody>
-          <a:bodyPr wrap="square">
-            <a:spAutoFit/>
-          </a:bodyPr>
-          <a:lstStyle/>
-          <a:p>
-            <a:pPr algn="l"/>
-            <a:r>
-              <a:rPr sz="1300" b="0" i="0">
-                <a:solidFill>
-                  <a:srgbClr val="788FA8"/>
-                </a:solidFill>
-              </a:rPr>
-              <a:t>25%</a:t>
-            </a:r>
-          </a:p>
-        </p:txBody>
-      </p:sp>
-      <p:sp>
-        <p:nvSpPr>
-          <p:cNvPr id="16" name="TextBox 15"/>
-          <p:cNvSpPr txBox="1"/>
-          <p:nvPr/>
-        </p:nvSpPr>
-        <p:spPr>
-          <a:xfrm>
-            <a:off x="2423160" y="3364992"/>
-            <a:ext cx="1371600" cy="365760"/>
-          </a:xfrm>
-          <a:prstGeom prst="rect">
-            <a:avLst/>
-          </a:prstGeom>
-          <a:noFill/>
-        </p:spPr>
-        <p:txBody>
-          <a:bodyPr wrap="square">
-            <a:spAutoFit/>
-          </a:bodyPr>
-          <a:lstStyle/>
-          <a:p>
-            <a:pPr algn="l"/>
-            <a:r>
-              <a:rPr sz="1400" b="1" i="0">
+              <a:t>Pretrain out-of-range</a:t>
+            </a:r>
+          </a:p>
+        </p:txBody>
+      </p:sp>
+      <p:sp>
+        <p:nvSpPr>
+          <p:cNvPr id="17" name="Rectangle 16"/>
+          <p:cNvSpPr/>
+          <p:nvPr/>
+        </p:nvSpPr>
+        <p:spPr>
+          <a:xfrm>
+            <a:off x="9198864" y="5468112"/>
+            <a:ext cx="2788920" cy="841248"/>
+          </a:xfrm>
+          <a:prstGeom prst="rect">
+            <a:avLst/>
+          </a:prstGeom>
+          <a:solidFill>
+            <a:srgbClr val="D5F0E4"/>
+          </a:solidFill>
+          <a:ln w="12700">
+            <a:solidFill>
+              <a:srgbClr val="CCD9E8"/>
+            </a:solidFill>
+          </a:ln>
+        </p:spPr>
+        <p:style>
+          <a:lnRef idx="1">
+            <a:schemeClr val="accent1"/>
+          </a:lnRef>
+          <a:fillRef idx="3">
+            <a:schemeClr val="accent1"/>
+          </a:fillRef>
+          <a:effectRef idx="2">
+            <a:schemeClr val="accent1"/>
+          </a:effectRef>
+          <a:fontRef idx="minor">
+            <a:schemeClr val="lt1"/>
+          </a:fontRef>
+        </p:style>
+        <p:txBody>
+          <a:bodyPr rtlCol="0" anchor="ctr"/>
+          <a:lstStyle/>
+          <a:p>
+            <a:pPr algn="ctr"/>
+          </a:p>
+        </p:txBody>
+      </p:sp>
+      <p:sp>
+        <p:nvSpPr>
+          <p:cNvPr id="18" name="TextBox 17"/>
+          <p:cNvSpPr txBox="1"/>
+          <p:nvPr/>
+        </p:nvSpPr>
+        <p:spPr>
+          <a:xfrm>
+            <a:off x="9198864" y="5486400"/>
+            <a:ext cx="2788920" cy="438912"/>
+          </a:xfrm>
+          <a:prstGeom prst="rect">
+            <a:avLst/>
+          </a:prstGeom>
+          <a:noFill/>
+        </p:spPr>
+        <p:txBody>
+          <a:bodyPr wrap="square">
+            <a:spAutoFit/>
+          </a:bodyPr>
+          <a:lstStyle/>
+          <a:p>
+            <a:pPr algn="ctr"/>
+            <a:r>
+              <a:rPr sz="2000" b="1" i="0">
+                <a:solidFill>
+                  <a:srgbClr val="008F6A"/>
+                </a:solidFill>
+              </a:rPr>
+              <a:t>0  ✓</a:t>
+            </a:r>
+          </a:p>
+        </p:txBody>
+      </p:sp>
+      <p:sp>
+        <p:nvSpPr>
+          <p:cNvPr id="19" name="TextBox 18"/>
+          <p:cNvSpPr txBox="1"/>
+          <p:nvPr/>
+        </p:nvSpPr>
+        <p:spPr>
+          <a:xfrm>
+            <a:off x="9198864" y="5925312"/>
+            <a:ext cx="2788920" cy="329184"/>
+          </a:xfrm>
+          <a:prstGeom prst="rect">
+            <a:avLst/>
+          </a:prstGeom>
+          <a:noFill/>
+        </p:spPr>
+        <p:txBody>
+          <a:bodyPr wrap="square">
+            <a:spAutoFit/>
+          </a:bodyPr>
+          <a:lstStyle/>
+          <a:p>
+            <a:pPr algn="ctr"/>
+            <a:r>
+              <a:rPr sz="1100" b="0" i="0">
                 <a:solidFill>
                   <a:srgbClr val="3A4A5C"/>
                 </a:solidFill>
               </a:rPr>
-              <a:t> 0.0700</a:t>
-            </a:r>
-          </a:p>
-        </p:txBody>
-      </p:sp>
-      <p:sp>
-        <p:nvSpPr>
-          <p:cNvPr id="17" name="TextBox 16"/>
-          <p:cNvSpPr txBox="1"/>
-          <p:nvPr/>
-        </p:nvSpPr>
-        <p:spPr>
-          <a:xfrm>
-            <a:off x="548640" y="3840480"/>
-            <a:ext cx="1828800" cy="365760"/>
-          </a:xfrm>
-          <a:prstGeom prst="rect">
-            <a:avLst/>
-          </a:prstGeom>
-          <a:noFill/>
-        </p:spPr>
-        <p:txBody>
-          <a:bodyPr wrap="square">
-            <a:spAutoFit/>
-          </a:bodyPr>
-          <a:lstStyle/>
-          <a:p>
-            <a:pPr algn="l"/>
-            <a:r>
-              <a:rPr sz="1300" b="0" i="0">
-                <a:solidFill>
-                  <a:srgbClr val="788FA8"/>
-                </a:solidFill>
-              </a:rPr>
-              <a:t>50%  (median)</a:t>
-            </a:r>
-          </a:p>
-        </p:txBody>
-      </p:sp>
-      <p:sp>
-        <p:nvSpPr>
-          <p:cNvPr id="18" name="TextBox 17"/>
-          <p:cNvSpPr txBox="1"/>
-          <p:nvPr/>
-        </p:nvSpPr>
-        <p:spPr>
-          <a:xfrm>
-            <a:off x="2423160" y="3840480"/>
-            <a:ext cx="1371600" cy="365760"/>
-          </a:xfrm>
-          <a:prstGeom prst="rect">
-            <a:avLst/>
-          </a:prstGeom>
-          <a:noFill/>
-        </p:spPr>
-        <p:txBody>
-          <a:bodyPr wrap="square">
-            <a:spAutoFit/>
-          </a:bodyPr>
-          <a:lstStyle/>
-          <a:p>
-            <a:pPr algn="l"/>
-            <a:r>
-              <a:rPr sz="1400" b="1" i="0">
-                <a:solidFill>
-                  <a:srgbClr val="007AC2"/>
-                </a:solidFill>
-              </a:rPr>
-              <a:t> 0.2860</a:t>
-            </a:r>
-          </a:p>
-        </p:txBody>
-      </p:sp>
-      <p:sp>
-        <p:nvSpPr>
-          <p:cNvPr id="19" name="TextBox 18"/>
-          <p:cNvSpPr txBox="1"/>
-          <p:nvPr/>
-        </p:nvSpPr>
-        <p:spPr>
-          <a:xfrm>
-            <a:off x="548640" y="4315968"/>
-            <a:ext cx="1828800" cy="365760"/>
-          </a:xfrm>
-          <a:prstGeom prst="rect">
-            <a:avLst/>
-          </a:prstGeom>
-          <a:noFill/>
-        </p:spPr>
-        <p:txBody>
-          <a:bodyPr wrap="square">
-            <a:spAutoFit/>
-          </a:bodyPr>
-          <a:lstStyle/>
-          <a:p>
-            <a:pPr algn="l"/>
-            <a:r>
-              <a:rPr sz="1300" b="0" i="0">
-                <a:solidFill>
-                  <a:srgbClr val="788FA8"/>
-                </a:solidFill>
-              </a:rPr>
-              <a:t>75%</a:t>
-            </a:r>
-          </a:p>
-        </p:txBody>
-      </p:sp>
-      <p:sp>
-        <p:nvSpPr>
-          <p:cNvPr id="20" name="TextBox 19"/>
-          <p:cNvSpPr txBox="1"/>
-          <p:nvPr/>
-        </p:nvSpPr>
-        <p:spPr>
-          <a:xfrm>
-            <a:off x="2423160" y="4315968"/>
-            <a:ext cx="1371600" cy="365760"/>
-          </a:xfrm>
-          <a:prstGeom prst="rect">
-            <a:avLst/>
-          </a:prstGeom>
-          <a:noFill/>
-        </p:spPr>
-        <p:txBody>
-          <a:bodyPr wrap="square">
-            <a:spAutoFit/>
-          </a:bodyPr>
-          <a:lstStyle/>
-          <a:p>
-            <a:pPr algn="l"/>
-            <a:r>
-              <a:rPr sz="1400" b="1" i="0">
-                <a:solidFill>
-                  <a:srgbClr val="3A4A5C"/>
-                </a:solidFill>
-              </a:rPr>
-              <a:t> 0.6679</a:t>
-            </a:r>
-          </a:p>
-        </p:txBody>
-      </p:sp>
-      <p:sp>
-        <p:nvSpPr>
-          <p:cNvPr id="21" name="TextBox 20"/>
-          <p:cNvSpPr txBox="1"/>
-          <p:nvPr/>
-        </p:nvSpPr>
-        <p:spPr>
-          <a:xfrm>
-            <a:off x="548640" y="4791456"/>
-            <a:ext cx="1828800" cy="365760"/>
-          </a:xfrm>
-          <a:prstGeom prst="rect">
-            <a:avLst/>
-          </a:prstGeom>
-          <a:noFill/>
-        </p:spPr>
-        <p:txBody>
-          <a:bodyPr wrap="square">
-            <a:spAutoFit/>
-          </a:bodyPr>
-          <a:lstStyle/>
-          <a:p>
-            <a:pPr algn="l"/>
-            <a:r>
-              <a:rPr sz="1300" b="0" i="0">
-                <a:solidFill>
-                  <a:srgbClr val="788FA8"/>
-                </a:solidFill>
-              </a:rPr>
-              <a:t>95%</a:t>
-            </a:r>
-          </a:p>
-        </p:txBody>
-      </p:sp>
-      <p:sp>
-        <p:nvSpPr>
-          <p:cNvPr id="22" name="TextBox 21"/>
-          <p:cNvSpPr txBox="1"/>
-          <p:nvPr/>
-        </p:nvSpPr>
-        <p:spPr>
-          <a:xfrm>
-            <a:off x="2423160" y="4791456"/>
-            <a:ext cx="1371600" cy="365760"/>
-          </a:xfrm>
-          <a:prstGeom prst="rect">
-            <a:avLst/>
-          </a:prstGeom>
-          <a:noFill/>
-        </p:spPr>
-        <p:txBody>
-          <a:bodyPr wrap="square">
-            <a:spAutoFit/>
-          </a:bodyPr>
-          <a:lstStyle/>
-          <a:p>
-            <a:pPr algn="l"/>
-            <a:r>
-              <a:rPr sz="1400" b="1" i="0">
-                <a:solidFill>
-                  <a:srgbClr val="3A4A5C"/>
-                </a:solidFill>
-              </a:rPr>
-              <a:t> 0.9134</a:t>
-            </a:r>
-          </a:p>
-        </p:txBody>
-      </p:sp>
-      <p:sp>
-        <p:nvSpPr>
-          <p:cNvPr id="23" name="TextBox 22"/>
-          <p:cNvSpPr txBox="1"/>
-          <p:nvPr/>
-        </p:nvSpPr>
-        <p:spPr>
-          <a:xfrm>
-            <a:off x="548640" y="5266944"/>
-            <a:ext cx="1828800" cy="365760"/>
-          </a:xfrm>
-          <a:prstGeom prst="rect">
-            <a:avLst/>
-          </a:prstGeom>
-          <a:noFill/>
-        </p:spPr>
-        <p:txBody>
-          <a:bodyPr wrap="square">
-            <a:spAutoFit/>
-          </a:bodyPr>
-          <a:lstStyle/>
-          <a:p>
-            <a:pPr algn="l"/>
-            <a:r>
-              <a:rPr sz="1300" b="0" i="0">
-                <a:solidFill>
-                  <a:srgbClr val="788FA8"/>
-                </a:solidFill>
-              </a:rPr>
-              <a:t>99%</a:t>
-            </a:r>
-          </a:p>
-        </p:txBody>
-      </p:sp>
-      <p:sp>
-        <p:nvSpPr>
-          <p:cNvPr id="24" name="TextBox 23"/>
-          <p:cNvSpPr txBox="1"/>
-          <p:nvPr/>
-        </p:nvSpPr>
-        <p:spPr>
-          <a:xfrm>
-            <a:off x="2423160" y="5266944"/>
-            <a:ext cx="1371600" cy="365760"/>
-          </a:xfrm>
-          <a:prstGeom prst="rect">
-            <a:avLst/>
-          </a:prstGeom>
-          <a:noFill/>
-        </p:spPr>
-        <p:txBody>
-          <a:bodyPr wrap="square">
-            <a:spAutoFit/>
-          </a:bodyPr>
-          <a:lstStyle/>
-          <a:p>
-            <a:pPr algn="l"/>
-            <a:r>
-              <a:rPr sz="1400" b="1" i="0">
-                <a:solidFill>
-                  <a:srgbClr val="3A4A5C"/>
-                </a:solidFill>
-              </a:rPr>
-              <a:t> 0.9620</a:t>
-            </a:r>
-          </a:p>
-        </p:txBody>
-      </p:sp>
-      <p:sp>
-        <p:nvSpPr>
-          <p:cNvPr id="25" name="TextBox 24"/>
-          <p:cNvSpPr txBox="1"/>
-          <p:nvPr/>
-        </p:nvSpPr>
-        <p:spPr>
-          <a:xfrm>
-            <a:off x="548640" y="5742432"/>
-            <a:ext cx="1828800" cy="365760"/>
-          </a:xfrm>
-          <a:prstGeom prst="rect">
-            <a:avLst/>
-          </a:prstGeom>
-          <a:noFill/>
-        </p:spPr>
-        <p:txBody>
-          <a:bodyPr wrap="square">
-            <a:spAutoFit/>
-          </a:bodyPr>
-          <a:lstStyle/>
-          <a:p>
-            <a:pPr algn="l"/>
-            <a:r>
-              <a:rPr sz="1300" b="0" i="0">
-                <a:solidFill>
-                  <a:srgbClr val="788FA8"/>
-                </a:solidFill>
-              </a:rPr>
-              <a:t>100% (max)</a:t>
-            </a:r>
-          </a:p>
-        </p:txBody>
-      </p:sp>
-      <p:sp>
-        <p:nvSpPr>
-          <p:cNvPr id="26" name="TextBox 25"/>
-          <p:cNvSpPr txBox="1"/>
-          <p:nvPr/>
-        </p:nvSpPr>
-        <p:spPr>
-          <a:xfrm>
-            <a:off x="2423160" y="5742432"/>
-            <a:ext cx="1371600" cy="365760"/>
-          </a:xfrm>
-          <a:prstGeom prst="rect">
-            <a:avLst/>
-          </a:prstGeom>
-          <a:noFill/>
-        </p:spPr>
-        <p:txBody>
-          <a:bodyPr wrap="square">
-            <a:spAutoFit/>
-          </a:bodyPr>
-          <a:lstStyle/>
-          <a:p>
-            <a:pPr algn="l"/>
-            <a:r>
-              <a:rPr sz="1400" b="1" i="0">
-                <a:solidFill>
-                  <a:srgbClr val="D47E00"/>
-                </a:solidFill>
-              </a:rPr>
-              <a:t> 1.1030</a:t>
-            </a:r>
-          </a:p>
-        </p:txBody>
-      </p:sp>
-      <p:sp>
-        <p:nvSpPr>
-          <p:cNvPr id="27" name="Rectangle 26"/>
+              <a:t>Fine-tune out-of-range</a:t>
+            </a:r>
+          </a:p>
+        </p:txBody>
+      </p:sp>
+      <p:sp>
+        <p:nvSpPr>
+          <p:cNvPr id="20" name="Rectangle 19"/>
           <p:cNvSpPr/>
           <p:nvPr/>
         </p:nvSpPr>
         <p:spPr>
           <a:xfrm>
-            <a:off x="365760" y="6291072"/>
-            <a:ext cx="5029200" cy="384048"/>
+            <a:off x="365760" y="6400800"/>
+            <a:ext cx="11475720" cy="347472"/>
           </a:xfrm>
           <a:prstGeom prst="rect">
             <a:avLst/>
@@ -7945,14 +6592,14 @@
       </p:sp>
       <p:sp>
         <p:nvSpPr>
-          <p:cNvPr id="28" name="TextBox 27"/>
-          <p:cNvSpPr txBox="1"/>
-          <p:nvPr/>
-        </p:nvSpPr>
-        <p:spPr>
-          <a:xfrm>
-            <a:off x="502920" y="6336792"/>
-            <a:ext cx="4754880" cy="292608"/>
+          <p:cNvPr id="21" name="TextBox 20"/>
+          <p:cNvSpPr txBox="1"/>
+          <p:nvPr/>
+        </p:nvSpPr>
+        <p:spPr>
+          <a:xfrm>
+            <a:off x="502920" y="6437376"/>
+            <a:ext cx="11155680" cy="274320"/>
           </a:xfrm>
           <a:prstGeom prst="rect">
             <a:avLst/>
@@ -7972,983 +6619,7 @@
                   <a:srgbClr val="9A5A00"/>
                 </a:solidFill>
               </a:rPr>
-              <a:t>Out-of-range β &lt; 0 or β &gt; 1:  248,776 values  ⚠  (raw Illumina noise — not a bug)</a:t>
-            </a:r>
-          </a:p>
-        </p:txBody>
-      </p:sp>
-      <p:sp>
-        <p:nvSpPr>
-          <p:cNvPr id="29" name="Rectangle 28"/>
-          <p:cNvSpPr/>
-          <p:nvPr/>
-        </p:nvSpPr>
-        <p:spPr>
-          <a:xfrm>
-            <a:off x="5669280" y="1261872"/>
-            <a:ext cx="5029200" cy="5120640"/>
-          </a:xfrm>
-          <a:prstGeom prst="rect">
-            <a:avLst/>
-          </a:prstGeom>
-          <a:solidFill>
-            <a:srgbClr val="E8F4ED"/>
-          </a:solidFill>
-          <a:ln w="12700">
-            <a:solidFill>
-              <a:srgbClr val="008F6A"/>
-            </a:solidFill>
-          </a:ln>
-        </p:spPr>
-        <p:style>
-          <a:lnRef idx="1">
-            <a:schemeClr val="accent1"/>
-          </a:lnRef>
-          <a:fillRef idx="3">
-            <a:schemeClr val="accent1"/>
-          </a:fillRef>
-          <a:effectRef idx="2">
-            <a:schemeClr val="accent1"/>
-          </a:effectRef>
-          <a:fontRef idx="minor">
-            <a:schemeClr val="lt1"/>
-          </a:fontRef>
-        </p:style>
-        <p:txBody>
-          <a:bodyPr rtlCol="0" anchor="ctr"/>
-          <a:lstStyle/>
-          <a:p>
-            <a:pPr algn="ctr"/>
-          </a:p>
-        </p:txBody>
-      </p:sp>
-      <p:sp>
-        <p:nvSpPr>
-          <p:cNvPr id="30" name="TextBox 29"/>
-          <p:cNvSpPr txBox="1"/>
-          <p:nvPr/>
-        </p:nvSpPr>
-        <p:spPr>
-          <a:xfrm>
-            <a:off x="5806440" y="1353312"/>
-            <a:ext cx="5486400" cy="274320"/>
-          </a:xfrm>
-          <a:prstGeom prst="rect">
-            <a:avLst/>
-          </a:prstGeom>
-          <a:noFill/>
-        </p:spPr>
-        <p:txBody>
-          <a:bodyPr wrap="square">
-            <a:spAutoFit/>
-          </a:bodyPr>
-          <a:lstStyle/>
-          <a:p>
-            <a:pPr algn="l"/>
-            <a:r>
-              <a:rPr sz="1100" b="1" i="0">
-                <a:solidFill>
-                  <a:srgbClr val="008F6A"/>
-                </a:solidFill>
-              </a:rPr>
-              <a:t>FINE-TUNE  β-VALUE DISTRIBUTION</a:t>
-            </a:r>
-          </a:p>
-        </p:txBody>
-      </p:sp>
-      <p:sp>
-        <p:nvSpPr>
-          <p:cNvPr id="31" name="TextBox 30"/>
-          <p:cNvSpPr txBox="1"/>
-          <p:nvPr/>
-        </p:nvSpPr>
-        <p:spPr>
-          <a:xfrm>
-            <a:off x="5806440" y="1627632"/>
-            <a:ext cx="4663440" cy="274320"/>
-          </a:xfrm>
-          <a:prstGeom prst="rect">
-            <a:avLst/>
-          </a:prstGeom>
-          <a:noFill/>
-        </p:spPr>
-        <p:txBody>
-          <a:bodyPr wrap="square">
-            <a:spAutoFit/>
-          </a:bodyPr>
-          <a:lstStyle/>
-          <a:p>
-            <a:pPr algn="l"/>
-            <a:r>
-              <a:rPr sz="1200" b="0" i="1">
-                <a:solidFill>
-                  <a:srgbClr val="788FA8"/>
-                </a:solidFill>
-              </a:rPr>
-              <a:t>224,570,424 valid values  (39.9% of total slots)</a:t>
-            </a:r>
-          </a:p>
-        </p:txBody>
-      </p:sp>
-      <p:sp>
-        <p:nvSpPr>
-          <p:cNvPr id="32" name="TextBox 31"/>
-          <p:cNvSpPr txBox="1"/>
-          <p:nvPr/>
-        </p:nvSpPr>
-        <p:spPr>
-          <a:xfrm>
-            <a:off x="5806440" y="1938528"/>
-            <a:ext cx="1828800" cy="365760"/>
-          </a:xfrm>
-          <a:prstGeom prst="rect">
-            <a:avLst/>
-          </a:prstGeom>
-          <a:noFill/>
-        </p:spPr>
-        <p:txBody>
-          <a:bodyPr wrap="square">
-            <a:spAutoFit/>
-          </a:bodyPr>
-          <a:lstStyle/>
-          <a:p>
-            <a:pPr algn="l"/>
-            <a:r>
-              <a:rPr sz="1300" b="0" i="0">
-                <a:solidFill>
-                  <a:srgbClr val="788FA8"/>
-                </a:solidFill>
-              </a:rPr>
-              <a:t>0%   (min)</a:t>
-            </a:r>
-          </a:p>
-        </p:txBody>
-      </p:sp>
-      <p:sp>
-        <p:nvSpPr>
-          <p:cNvPr id="33" name="TextBox 32"/>
-          <p:cNvSpPr txBox="1"/>
-          <p:nvPr/>
-        </p:nvSpPr>
-        <p:spPr>
-          <a:xfrm>
-            <a:off x="7680960" y="1938528"/>
-            <a:ext cx="1371600" cy="365760"/>
-          </a:xfrm>
-          <a:prstGeom prst="rect">
-            <a:avLst/>
-          </a:prstGeom>
-          <a:noFill/>
-        </p:spPr>
-        <p:txBody>
-          <a:bodyPr wrap="square">
-            <a:spAutoFit/>
-          </a:bodyPr>
-          <a:lstStyle/>
-          <a:p>
-            <a:pPr algn="l"/>
-            <a:r>
-              <a:rPr sz="1400" b="1" i="0">
-                <a:solidFill>
-                  <a:srgbClr val="3A4A5C"/>
-                </a:solidFill>
-              </a:rPr>
-              <a:t> 0.0000</a:t>
-            </a:r>
-          </a:p>
-        </p:txBody>
-      </p:sp>
-      <p:sp>
-        <p:nvSpPr>
-          <p:cNvPr id="34" name="TextBox 33"/>
-          <p:cNvSpPr txBox="1"/>
-          <p:nvPr/>
-        </p:nvSpPr>
-        <p:spPr>
-          <a:xfrm>
-            <a:off x="5806440" y="2414016"/>
-            <a:ext cx="1828800" cy="365760"/>
-          </a:xfrm>
-          <a:prstGeom prst="rect">
-            <a:avLst/>
-          </a:prstGeom>
-          <a:noFill/>
-        </p:spPr>
-        <p:txBody>
-          <a:bodyPr wrap="square">
-            <a:spAutoFit/>
-          </a:bodyPr>
-          <a:lstStyle/>
-          <a:p>
-            <a:pPr algn="l"/>
-            <a:r>
-              <a:rPr sz="1300" b="0" i="0">
-                <a:solidFill>
-                  <a:srgbClr val="788FA8"/>
-                </a:solidFill>
-              </a:rPr>
-              <a:t>1%</a:t>
-            </a:r>
-          </a:p>
-        </p:txBody>
-      </p:sp>
-      <p:sp>
-        <p:nvSpPr>
-          <p:cNvPr id="35" name="TextBox 34"/>
-          <p:cNvSpPr txBox="1"/>
-          <p:nvPr/>
-        </p:nvSpPr>
-        <p:spPr>
-          <a:xfrm>
-            <a:off x="7680960" y="2414016"/>
-            <a:ext cx="1371600" cy="365760"/>
-          </a:xfrm>
-          <a:prstGeom prst="rect">
-            <a:avLst/>
-          </a:prstGeom>
-          <a:noFill/>
-        </p:spPr>
-        <p:txBody>
-          <a:bodyPr wrap="square">
-            <a:spAutoFit/>
-          </a:bodyPr>
-          <a:lstStyle/>
-          <a:p>
-            <a:pPr algn="l"/>
-            <a:r>
-              <a:rPr sz="1400" b="1" i="0">
-                <a:solidFill>
-                  <a:srgbClr val="3A4A5C"/>
-                </a:solidFill>
-              </a:rPr>
-              <a:t> 0.0086</a:t>
-            </a:r>
-          </a:p>
-        </p:txBody>
-      </p:sp>
-      <p:sp>
-        <p:nvSpPr>
-          <p:cNvPr id="36" name="TextBox 35"/>
-          <p:cNvSpPr txBox="1"/>
-          <p:nvPr/>
-        </p:nvSpPr>
-        <p:spPr>
-          <a:xfrm>
-            <a:off x="5806440" y="2889504"/>
-            <a:ext cx="1828800" cy="365760"/>
-          </a:xfrm>
-          <a:prstGeom prst="rect">
-            <a:avLst/>
-          </a:prstGeom>
-          <a:noFill/>
-        </p:spPr>
-        <p:txBody>
-          <a:bodyPr wrap="square">
-            <a:spAutoFit/>
-          </a:bodyPr>
-          <a:lstStyle/>
-          <a:p>
-            <a:pPr algn="l"/>
-            <a:r>
-              <a:rPr sz="1300" b="0" i="0">
-                <a:solidFill>
-                  <a:srgbClr val="788FA8"/>
-                </a:solidFill>
-              </a:rPr>
-              <a:t>5%</a:t>
-            </a:r>
-          </a:p>
-        </p:txBody>
-      </p:sp>
-      <p:sp>
-        <p:nvSpPr>
-          <p:cNvPr id="37" name="TextBox 36"/>
-          <p:cNvSpPr txBox="1"/>
-          <p:nvPr/>
-        </p:nvSpPr>
-        <p:spPr>
-          <a:xfrm>
-            <a:off x="7680960" y="2889504"/>
-            <a:ext cx="1371600" cy="365760"/>
-          </a:xfrm>
-          <a:prstGeom prst="rect">
-            <a:avLst/>
-          </a:prstGeom>
-          <a:noFill/>
-        </p:spPr>
-        <p:txBody>
-          <a:bodyPr wrap="square">
-            <a:spAutoFit/>
-          </a:bodyPr>
-          <a:lstStyle/>
-          <a:p>
-            <a:pPr algn="l"/>
-            <a:r>
-              <a:rPr sz="1400" b="1" i="0">
-                <a:solidFill>
-                  <a:srgbClr val="3A4A5C"/>
-                </a:solidFill>
-              </a:rPr>
-              <a:t> 0.0188</a:t>
-            </a:r>
-          </a:p>
-        </p:txBody>
-      </p:sp>
-      <p:sp>
-        <p:nvSpPr>
-          <p:cNvPr id="38" name="TextBox 37"/>
-          <p:cNvSpPr txBox="1"/>
-          <p:nvPr/>
-        </p:nvSpPr>
-        <p:spPr>
-          <a:xfrm>
-            <a:off x="5806440" y="3364992"/>
-            <a:ext cx="1828800" cy="365760"/>
-          </a:xfrm>
-          <a:prstGeom prst="rect">
-            <a:avLst/>
-          </a:prstGeom>
-          <a:noFill/>
-        </p:spPr>
-        <p:txBody>
-          <a:bodyPr wrap="square">
-            <a:spAutoFit/>
-          </a:bodyPr>
-          <a:lstStyle/>
-          <a:p>
-            <a:pPr algn="l"/>
-            <a:r>
-              <a:rPr sz="1300" b="0" i="0">
-                <a:solidFill>
-                  <a:srgbClr val="788FA8"/>
-                </a:solidFill>
-              </a:rPr>
-              <a:t>25%</a:t>
-            </a:r>
-          </a:p>
-        </p:txBody>
-      </p:sp>
-      <p:sp>
-        <p:nvSpPr>
-          <p:cNvPr id="39" name="TextBox 38"/>
-          <p:cNvSpPr txBox="1"/>
-          <p:nvPr/>
-        </p:nvSpPr>
-        <p:spPr>
-          <a:xfrm>
-            <a:off x="7680960" y="3364992"/>
-            <a:ext cx="1371600" cy="365760"/>
-          </a:xfrm>
-          <a:prstGeom prst="rect">
-            <a:avLst/>
-          </a:prstGeom>
-          <a:noFill/>
-        </p:spPr>
-        <p:txBody>
-          <a:bodyPr wrap="square">
-            <a:spAutoFit/>
-          </a:bodyPr>
-          <a:lstStyle/>
-          <a:p>
-            <a:pPr algn="l"/>
-            <a:r>
-              <a:rPr sz="1400" b="1" i="0">
-                <a:solidFill>
-                  <a:srgbClr val="3A4A5C"/>
-                </a:solidFill>
-              </a:rPr>
-              <a:t> 0.0400</a:t>
-            </a:r>
-          </a:p>
-        </p:txBody>
-      </p:sp>
-      <p:sp>
-        <p:nvSpPr>
-          <p:cNvPr id="40" name="TextBox 39"/>
-          <p:cNvSpPr txBox="1"/>
-          <p:nvPr/>
-        </p:nvSpPr>
-        <p:spPr>
-          <a:xfrm>
-            <a:off x="5806440" y="3840480"/>
-            <a:ext cx="1828800" cy="365760"/>
-          </a:xfrm>
-          <a:prstGeom prst="rect">
-            <a:avLst/>
-          </a:prstGeom>
-          <a:noFill/>
-        </p:spPr>
-        <p:txBody>
-          <a:bodyPr wrap="square">
-            <a:spAutoFit/>
-          </a:bodyPr>
-          <a:lstStyle/>
-          <a:p>
-            <a:pPr algn="l"/>
-            <a:r>
-              <a:rPr sz="1300" b="0" i="0">
-                <a:solidFill>
-                  <a:srgbClr val="788FA8"/>
-                </a:solidFill>
-              </a:rPr>
-              <a:t>50%  (median)</a:t>
-            </a:r>
-          </a:p>
-        </p:txBody>
-      </p:sp>
-      <p:sp>
-        <p:nvSpPr>
-          <p:cNvPr id="41" name="TextBox 40"/>
-          <p:cNvSpPr txBox="1"/>
-          <p:nvPr/>
-        </p:nvSpPr>
-        <p:spPr>
-          <a:xfrm>
-            <a:off x="7680960" y="3840480"/>
-            <a:ext cx="1371600" cy="365760"/>
-          </a:xfrm>
-          <a:prstGeom prst="rect">
-            <a:avLst/>
-          </a:prstGeom>
-          <a:noFill/>
-        </p:spPr>
-        <p:txBody>
-          <a:bodyPr wrap="square">
-            <a:spAutoFit/>
-          </a:bodyPr>
-          <a:lstStyle/>
-          <a:p>
-            <a:pPr algn="l"/>
-            <a:r>
-              <a:rPr sz="1400" b="1" i="0">
-                <a:solidFill>
-                  <a:srgbClr val="007AC2"/>
-                </a:solidFill>
-              </a:rPr>
-              <a:t> 0.0825</a:t>
-            </a:r>
-          </a:p>
-        </p:txBody>
-      </p:sp>
-      <p:sp>
-        <p:nvSpPr>
-          <p:cNvPr id="42" name="TextBox 41"/>
-          <p:cNvSpPr txBox="1"/>
-          <p:nvPr/>
-        </p:nvSpPr>
-        <p:spPr>
-          <a:xfrm>
-            <a:off x="5806440" y="4315968"/>
-            <a:ext cx="1828800" cy="365760"/>
-          </a:xfrm>
-          <a:prstGeom prst="rect">
-            <a:avLst/>
-          </a:prstGeom>
-          <a:noFill/>
-        </p:spPr>
-        <p:txBody>
-          <a:bodyPr wrap="square">
-            <a:spAutoFit/>
-          </a:bodyPr>
-          <a:lstStyle/>
-          <a:p>
-            <a:pPr algn="l"/>
-            <a:r>
-              <a:rPr sz="1300" b="0" i="0">
-                <a:solidFill>
-                  <a:srgbClr val="788FA8"/>
-                </a:solidFill>
-              </a:rPr>
-              <a:t>75%</a:t>
-            </a:r>
-          </a:p>
-        </p:txBody>
-      </p:sp>
-      <p:sp>
-        <p:nvSpPr>
-          <p:cNvPr id="43" name="TextBox 42"/>
-          <p:cNvSpPr txBox="1"/>
-          <p:nvPr/>
-        </p:nvSpPr>
-        <p:spPr>
-          <a:xfrm>
-            <a:off x="7680960" y="4315968"/>
-            <a:ext cx="1371600" cy="365760"/>
-          </a:xfrm>
-          <a:prstGeom prst="rect">
-            <a:avLst/>
-          </a:prstGeom>
-          <a:noFill/>
-        </p:spPr>
-        <p:txBody>
-          <a:bodyPr wrap="square">
-            <a:spAutoFit/>
-          </a:bodyPr>
-          <a:lstStyle/>
-          <a:p>
-            <a:pPr algn="l"/>
-            <a:r>
-              <a:rPr sz="1400" b="1" i="0">
-                <a:solidFill>
-                  <a:srgbClr val="3A4A5C"/>
-                </a:solidFill>
-              </a:rPr>
-              <a:t> 0.4881</a:t>
-            </a:r>
-          </a:p>
-        </p:txBody>
-      </p:sp>
-      <p:sp>
-        <p:nvSpPr>
-          <p:cNvPr id="44" name="TextBox 43"/>
-          <p:cNvSpPr txBox="1"/>
-          <p:nvPr/>
-        </p:nvSpPr>
-        <p:spPr>
-          <a:xfrm>
-            <a:off x="5806440" y="4791456"/>
-            <a:ext cx="1828800" cy="365760"/>
-          </a:xfrm>
-          <a:prstGeom prst="rect">
-            <a:avLst/>
-          </a:prstGeom>
-          <a:noFill/>
-        </p:spPr>
-        <p:txBody>
-          <a:bodyPr wrap="square">
-            <a:spAutoFit/>
-          </a:bodyPr>
-          <a:lstStyle/>
-          <a:p>
-            <a:pPr algn="l"/>
-            <a:r>
-              <a:rPr sz="1300" b="0" i="0">
-                <a:solidFill>
-                  <a:srgbClr val="788FA8"/>
-                </a:solidFill>
-              </a:rPr>
-              <a:t>95%</a:t>
-            </a:r>
-          </a:p>
-        </p:txBody>
-      </p:sp>
-      <p:sp>
-        <p:nvSpPr>
-          <p:cNvPr id="45" name="TextBox 44"/>
-          <p:cNvSpPr txBox="1"/>
-          <p:nvPr/>
-        </p:nvSpPr>
-        <p:spPr>
-          <a:xfrm>
-            <a:off x="7680960" y="4791456"/>
-            <a:ext cx="1371600" cy="365760"/>
-          </a:xfrm>
-          <a:prstGeom prst="rect">
-            <a:avLst/>
-          </a:prstGeom>
-          <a:noFill/>
-        </p:spPr>
-        <p:txBody>
-          <a:bodyPr wrap="square">
-            <a:spAutoFit/>
-          </a:bodyPr>
-          <a:lstStyle/>
-          <a:p>
-            <a:pPr algn="l"/>
-            <a:r>
-              <a:rPr sz="1400" b="1" i="0">
-                <a:solidFill>
-                  <a:srgbClr val="3A4A5C"/>
-                </a:solidFill>
-              </a:rPr>
-              <a:t> 0.9050</a:t>
-            </a:r>
-          </a:p>
-        </p:txBody>
-      </p:sp>
-      <p:sp>
-        <p:nvSpPr>
-          <p:cNvPr id="46" name="TextBox 45"/>
-          <p:cNvSpPr txBox="1"/>
-          <p:nvPr/>
-        </p:nvSpPr>
-        <p:spPr>
-          <a:xfrm>
-            <a:off x="5806440" y="5266944"/>
-            <a:ext cx="1828800" cy="365760"/>
-          </a:xfrm>
-          <a:prstGeom prst="rect">
-            <a:avLst/>
-          </a:prstGeom>
-          <a:noFill/>
-        </p:spPr>
-        <p:txBody>
-          <a:bodyPr wrap="square">
-            <a:spAutoFit/>
-          </a:bodyPr>
-          <a:lstStyle/>
-          <a:p>
-            <a:pPr algn="l"/>
-            <a:r>
-              <a:rPr sz="1300" b="0" i="0">
-                <a:solidFill>
-                  <a:srgbClr val="788FA8"/>
-                </a:solidFill>
-              </a:rPr>
-              <a:t>99%</a:t>
-            </a:r>
-          </a:p>
-        </p:txBody>
-      </p:sp>
-      <p:sp>
-        <p:nvSpPr>
-          <p:cNvPr id="47" name="TextBox 46"/>
-          <p:cNvSpPr txBox="1"/>
-          <p:nvPr/>
-        </p:nvSpPr>
-        <p:spPr>
-          <a:xfrm>
-            <a:off x="7680960" y="5266944"/>
-            <a:ext cx="1371600" cy="365760"/>
-          </a:xfrm>
-          <a:prstGeom prst="rect">
-            <a:avLst/>
-          </a:prstGeom>
-          <a:noFill/>
-        </p:spPr>
-        <p:txBody>
-          <a:bodyPr wrap="square">
-            <a:spAutoFit/>
-          </a:bodyPr>
-          <a:lstStyle/>
-          <a:p>
-            <a:pPr algn="l"/>
-            <a:r>
-              <a:rPr sz="1400" b="1" i="0">
-                <a:solidFill>
-                  <a:srgbClr val="3A4A5C"/>
-                </a:solidFill>
-              </a:rPr>
-              <a:t> 0.9498</a:t>
-            </a:r>
-          </a:p>
-        </p:txBody>
-      </p:sp>
-      <p:sp>
-        <p:nvSpPr>
-          <p:cNvPr id="48" name="TextBox 47"/>
-          <p:cNvSpPr txBox="1"/>
-          <p:nvPr/>
-        </p:nvSpPr>
-        <p:spPr>
-          <a:xfrm>
-            <a:off x="5806440" y="5742432"/>
-            <a:ext cx="1828800" cy="365760"/>
-          </a:xfrm>
-          <a:prstGeom prst="rect">
-            <a:avLst/>
-          </a:prstGeom>
-          <a:noFill/>
-        </p:spPr>
-        <p:txBody>
-          <a:bodyPr wrap="square">
-            <a:spAutoFit/>
-          </a:bodyPr>
-          <a:lstStyle/>
-          <a:p>
-            <a:pPr algn="l"/>
-            <a:r>
-              <a:rPr sz="1300" b="0" i="0">
-                <a:solidFill>
-                  <a:srgbClr val="788FA8"/>
-                </a:solidFill>
-              </a:rPr>
-              <a:t>100% (max)</a:t>
-            </a:r>
-          </a:p>
-        </p:txBody>
-      </p:sp>
-      <p:sp>
-        <p:nvSpPr>
-          <p:cNvPr id="49" name="TextBox 48"/>
-          <p:cNvSpPr txBox="1"/>
-          <p:nvPr/>
-        </p:nvSpPr>
-        <p:spPr>
-          <a:xfrm>
-            <a:off x="7680960" y="5742432"/>
-            <a:ext cx="1371600" cy="365760"/>
-          </a:xfrm>
-          <a:prstGeom prst="rect">
-            <a:avLst/>
-          </a:prstGeom>
-          <a:noFill/>
-        </p:spPr>
-        <p:txBody>
-          <a:bodyPr wrap="square">
-            <a:spAutoFit/>
-          </a:bodyPr>
-          <a:lstStyle/>
-          <a:p>
-            <a:pPr algn="l"/>
-            <a:r>
-              <a:rPr sz="1400" b="1" i="0">
-                <a:solidFill>
-                  <a:srgbClr val="008F6A"/>
-                </a:solidFill>
-              </a:rPr>
-              <a:t> 1.0000</a:t>
-            </a:r>
-          </a:p>
-        </p:txBody>
-      </p:sp>
-      <p:sp>
-        <p:nvSpPr>
-          <p:cNvPr id="50" name="Rectangle 49"/>
-          <p:cNvSpPr/>
-          <p:nvPr/>
-        </p:nvSpPr>
-        <p:spPr>
-          <a:xfrm>
-            <a:off x="5669280" y="6291072"/>
-            <a:ext cx="5029200" cy="384048"/>
-          </a:xfrm>
-          <a:prstGeom prst="rect">
-            <a:avLst/>
-          </a:prstGeom>
-          <a:solidFill>
-            <a:srgbClr val="D5F0E4"/>
-          </a:solidFill>
-          <a:ln w="12700">
-            <a:solidFill>
-              <a:srgbClr val="008F6A"/>
-            </a:solidFill>
-          </a:ln>
-        </p:spPr>
-        <p:style>
-          <a:lnRef idx="1">
-            <a:schemeClr val="accent1"/>
-          </a:lnRef>
-          <a:fillRef idx="3">
-            <a:schemeClr val="accent1"/>
-          </a:fillRef>
-          <a:effectRef idx="2">
-            <a:schemeClr val="accent1"/>
-          </a:effectRef>
-          <a:fontRef idx="minor">
-            <a:schemeClr val="lt1"/>
-          </a:fontRef>
-        </p:style>
-        <p:txBody>
-          <a:bodyPr rtlCol="0" anchor="ctr"/>
-          <a:lstStyle/>
-          <a:p>
-            <a:pPr algn="ctr"/>
-          </a:p>
-        </p:txBody>
-      </p:sp>
-      <p:sp>
-        <p:nvSpPr>
-          <p:cNvPr id="51" name="TextBox 50"/>
-          <p:cNvSpPr txBox="1"/>
-          <p:nvPr/>
-        </p:nvSpPr>
-        <p:spPr>
-          <a:xfrm>
-            <a:off x="5806440" y="6336792"/>
-            <a:ext cx="4754880" cy="292608"/>
-          </a:xfrm>
-          <a:prstGeom prst="rect">
-            <a:avLst/>
-          </a:prstGeom>
-          <a:noFill/>
-        </p:spPr>
-        <p:txBody>
-          <a:bodyPr wrap="square">
-            <a:spAutoFit/>
-          </a:bodyPr>
-          <a:lstStyle/>
-          <a:p>
-            <a:pPr algn="l"/>
-            <a:r>
-              <a:rPr sz="1200" b="0" i="0">
-                <a:solidFill>
-                  <a:srgbClr val="006045"/>
-                </a:solidFill>
-              </a:rPr>
-              <a:t>Out-of-range β:  0  ✓  (fine-tune values are perfectly in [0, 1])</a:t>
-            </a:r>
-          </a:p>
-        </p:txBody>
-      </p:sp>
-      <p:sp>
-        <p:nvSpPr>
-          <p:cNvPr id="52" name="Rectangle 51"/>
-          <p:cNvSpPr/>
-          <p:nvPr/>
-        </p:nvSpPr>
-        <p:spPr>
-          <a:xfrm>
-            <a:off x="365760" y="1261872"/>
-            <a:ext cx="0" cy="0"/>
-          </a:xfrm>
-          <a:prstGeom prst="rect">
-            <a:avLst/>
-          </a:prstGeom>
-          <a:solidFill>
-            <a:srgbClr val="FFFFFF"/>
-          </a:solidFill>
-          <a:ln w="12700">
-            <a:solidFill>
-              <a:srgbClr val="CCD9E8"/>
-            </a:solidFill>
-          </a:ln>
-        </p:spPr>
-        <p:style>
-          <a:lnRef idx="1">
-            <a:schemeClr val="accent1"/>
-          </a:lnRef>
-          <a:fillRef idx="3">
-            <a:schemeClr val="accent1"/>
-          </a:fillRef>
-          <a:effectRef idx="2">
-            <a:schemeClr val="accent1"/>
-          </a:effectRef>
-          <a:fontRef idx="minor">
-            <a:schemeClr val="lt1"/>
-          </a:fontRef>
-        </p:style>
-        <p:txBody>
-          <a:bodyPr rtlCol="0" anchor="ctr"/>
-          <a:lstStyle/>
-          <a:p>
-            <a:pPr algn="ctr"/>
-          </a:p>
-        </p:txBody>
-      </p:sp>
-      <p:sp>
-        <p:nvSpPr>
-          <p:cNvPr id="53" name="Rectangle 52"/>
-          <p:cNvSpPr/>
-          <p:nvPr/>
-        </p:nvSpPr>
-        <p:spPr>
-          <a:xfrm>
-            <a:off x="10744200" y="1261872"/>
-            <a:ext cx="1097280" cy="5120640"/>
-          </a:xfrm>
-          <a:prstGeom prst="rect">
-            <a:avLst/>
-          </a:prstGeom>
-          <a:solidFill>
-            <a:srgbClr val="F2F6FB"/>
-          </a:solidFill>
-          <a:ln w="12700">
-            <a:solidFill>
-              <a:srgbClr val="CCD9E8"/>
-            </a:solidFill>
-          </a:ln>
-        </p:spPr>
-        <p:style>
-          <a:lnRef idx="1">
-            <a:schemeClr val="accent1"/>
-          </a:lnRef>
-          <a:fillRef idx="3">
-            <a:schemeClr val="accent1"/>
-          </a:fillRef>
-          <a:effectRef idx="2">
-            <a:schemeClr val="accent1"/>
-          </a:effectRef>
-          <a:fontRef idx="minor">
-            <a:schemeClr val="lt1"/>
-          </a:fontRef>
-        </p:style>
-        <p:txBody>
-          <a:bodyPr rtlCol="0" anchor="ctr"/>
-          <a:lstStyle/>
-          <a:p>
-            <a:pPr algn="ctr"/>
-          </a:p>
-        </p:txBody>
-      </p:sp>
-      <p:sp>
-        <p:nvSpPr>
-          <p:cNvPr id="54" name="TextBox 53"/>
-          <p:cNvSpPr txBox="1"/>
-          <p:nvPr/>
-        </p:nvSpPr>
-        <p:spPr>
-          <a:xfrm>
-            <a:off x="10789920" y="1353312"/>
-            <a:ext cx="5486400" cy="274320"/>
-          </a:xfrm>
-          <a:prstGeom prst="rect">
-            <a:avLst/>
-          </a:prstGeom>
-          <a:noFill/>
-        </p:spPr>
-        <p:txBody>
-          <a:bodyPr wrap="square">
-            <a:spAutoFit/>
-          </a:bodyPr>
-          <a:lstStyle/>
-          <a:p>
-            <a:pPr algn="l"/>
-            <a:r>
-              <a:rPr sz="1100" b="1" i="0">
-                <a:solidFill>
-                  <a:srgbClr val="788FA8"/>
-                </a:solidFill>
-              </a:rPr>
-              <a:t>KEY</a:t>
-            </a:r>
-          </a:p>
-        </p:txBody>
-      </p:sp>
-      <p:sp>
-        <p:nvSpPr>
-          <p:cNvPr id="55" name="TextBox 54"/>
-          <p:cNvSpPr txBox="1"/>
-          <p:nvPr/>
-        </p:nvSpPr>
-        <p:spPr>
-          <a:xfrm>
-            <a:off x="10789920" y="1627632"/>
-            <a:ext cx="1005840" cy="4663440"/>
-          </a:xfrm>
-          <a:prstGeom prst="rect">
-            <a:avLst/>
-          </a:prstGeom>
-          <a:noFill/>
-        </p:spPr>
-        <p:txBody>
-          <a:bodyPr wrap="square">
-            <a:spAutoFit/>
-          </a:bodyPr>
-          <a:lstStyle/>
-          <a:p>
-            <a:pPr algn="l"/>
-            <a:r>
-              <a:rPr sz="1100" b="0" i="0">
-                <a:solidFill>
-                  <a:srgbClr val="3A4A5C"/>
-                </a:solidFill>
-              </a:rPr>
-              <a:t>Pretrain
-median
-0.286
-Fine-tune
-median
-0.083
-Different
-distributions!
-Pretrain:
-more hemi-
-methylated
-sites
-Fine-tune:
-more un-
-methylated</a:t>
+              <a:t>Distribution shift:  Pretrain is bimodal (unmethylated 0–0.2  +  methylated 0.6–1.0)  ·  Fine-tune is more heavily unmethylated (median 0.083)  ·  Pretrain out-of-range due to raw Illumina signal (harmless — model learns from valid range)</a:t>
             </a:r>
           </a:p>
         </p:txBody>

</xml_diff>

<commit_message>
fix: remove duplicate ID warning from slide 11 — not real leakage
id column is a per-split row index, never used by the model.
Replaced with split size breakdown instead.

Co-Authored-By: Claude Sonnet 4.6 <noreply@anthropic.com>
</commit_message>
<xml_diff>
--- a/methyl/NaN_Handling_MethylLlama.pptx
+++ b/methyl/NaN_Handling_MethylLlama.pptx
@@ -5687,7 +5687,7 @@
             <a:avLst/>
           </a:prstGeom>
           <a:solidFill>
-            <a:srgbClr val="FDEAC8"/>
+            <a:srgbClr val="D6EAF8"/>
           </a:solidFill>
           <a:ln w="12700">
             <a:solidFill>
@@ -5743,10 +5743,10 @@
             <a:r>
               <a:rPr sz="2200" b="1" i="0">
                 <a:solidFill>
-                  <a:srgbClr val="D47E00"/>
-                </a:solidFill>
-              </a:rPr>
-              <a:t>5,992  ⚠</a:t>
+                  <a:srgbClr val="007AC2"/>
+                </a:solidFill>
+              </a:rPr>
+              <a:t>5,461 / 1,366 / 4,626</a:t>
             </a:r>
           </a:p>
         </p:txBody>
@@ -5780,8 +5780,8 @@
                   <a:srgbClr val="3A4A5C"/>
                 </a:solidFill>
               </a:rPr>
-              <a:t>Fine-tune duplicate
-sample IDs</a:t>
+              <a:t>Fine-tune splits
+train / val / test</a:t>
             </a:r>
           </a:p>
         </p:txBody>

</xml_diff>